<commit_message>
LedgerLens AI: admin real /api/receipts queue, backend risk rules, 3 reproducible tests, deliverables & PPT
</commit_message>
<xml_diff>
--- a/LedgerLens_AI_pitch.pptx
+++ b/LedgerLens_AI_pitch.pptx
@@ -2,29 +2,30 @@
 <file path=ppt/presentation.xml><?xml version="1.0" encoding="utf-8"?>
 <p:presentation xmlns:p="http://schemas.openxmlformats.org/presentationml/2006/main">
   <p:sldMasterIdLst>
-    <p:sldMasterId xmlns:r="http://schemas.openxmlformats.org/officeDocument/2006/relationships" id="2147483648" r:id="R093244ae8a634819"/>
+    <p:sldMasterId xmlns:r="http://schemas.openxmlformats.org/officeDocument/2006/relationships" id="2147483648" r:id="Rc202e451d6ac422c"/>
   </p:sldMasterIdLst>
   <p:notesMasterIdLst>
-    <p:notesMasterId xmlns:r="http://schemas.openxmlformats.org/officeDocument/2006/relationships" r:id="R4b2be5f8715641ea"/>
+    <p:notesMasterId xmlns:r="http://schemas.openxmlformats.org/officeDocument/2006/relationships" r:id="R09adeaa9449b4094"/>
   </p:notesMasterIdLst>
   <p:sldIdLst>
-    <p:sldId xmlns:r="http://schemas.openxmlformats.org/officeDocument/2006/relationships" id="256" r:id="Rc20239703ade4d25"/>
-    <p:sldId xmlns:r="http://schemas.openxmlformats.org/officeDocument/2006/relationships" id="257" r:id="R0b1811c0c91e4f04"/>
-    <p:sldId xmlns:r="http://schemas.openxmlformats.org/officeDocument/2006/relationships" id="258" r:id="R47e5ee54e4324d8d"/>
-    <p:sldId xmlns:r="http://schemas.openxmlformats.org/officeDocument/2006/relationships" id="259" r:id="R24108c5a5bc74f7b"/>
-    <p:sldId xmlns:r="http://schemas.openxmlformats.org/officeDocument/2006/relationships" id="260" r:id="Re52b45013326490a"/>
-    <p:sldId xmlns:r="http://schemas.openxmlformats.org/officeDocument/2006/relationships" id="261" r:id="R03e8921f86a744cc"/>
-    <p:sldId xmlns:r="http://schemas.openxmlformats.org/officeDocument/2006/relationships" id="262" r:id="Rf1a812f073594c3d"/>
-    <p:sldId xmlns:r="http://schemas.openxmlformats.org/officeDocument/2006/relationships" id="263" r:id="R570837050e8b4a7b"/>
-    <p:sldId xmlns:r="http://schemas.openxmlformats.org/officeDocument/2006/relationships" id="264" r:id="R1c768940e4a84bb5"/>
-    <p:sldId xmlns:r="http://schemas.openxmlformats.org/officeDocument/2006/relationships" id="265" r:id="Rf05d9d09ea184ff5"/>
-    <p:sldId xmlns:r="http://schemas.openxmlformats.org/officeDocument/2006/relationships" id="266" r:id="R09adfad18be745e3"/>
-    <p:sldId xmlns:r="http://schemas.openxmlformats.org/officeDocument/2006/relationships" id="267" r:id="R32116f81d6144ec7"/>
-    <p:sldId xmlns:r="http://schemas.openxmlformats.org/officeDocument/2006/relationships" id="268" r:id="Rccee5c3df25847ba"/>
-    <p:sldId xmlns:r="http://schemas.openxmlformats.org/officeDocument/2006/relationships" id="269" r:id="R73204c374d364ce4"/>
-    <p:sldId xmlns:r="http://schemas.openxmlformats.org/officeDocument/2006/relationships" id="270" r:id="Rc218fe3e872a4ae6"/>
-    <p:sldId xmlns:r="http://schemas.openxmlformats.org/officeDocument/2006/relationships" id="271" r:id="Rb960a66b3e66439c"/>
-    <p:sldId xmlns:r="http://schemas.openxmlformats.org/officeDocument/2006/relationships" id="272" r:id="Rb2de95402de9418f"/>
+    <p:sldId xmlns:r="http://schemas.openxmlformats.org/officeDocument/2006/relationships" id="256" r:id="R1c2e9b3066e04b2e"/>
+    <p:sldId xmlns:r="http://schemas.openxmlformats.org/officeDocument/2006/relationships" id="257" r:id="R12f2b923257c4280"/>
+    <p:sldId xmlns:r="http://schemas.openxmlformats.org/officeDocument/2006/relationships" id="258" r:id="R65a6144173084c96"/>
+    <p:sldId xmlns:r="http://schemas.openxmlformats.org/officeDocument/2006/relationships" id="259" r:id="R22727e2323534b96"/>
+    <p:sldId xmlns:r="http://schemas.openxmlformats.org/officeDocument/2006/relationships" id="260" r:id="R5a208e3d17da4bb3"/>
+    <p:sldId xmlns:r="http://schemas.openxmlformats.org/officeDocument/2006/relationships" id="261" r:id="R65cf1b8e6d964089"/>
+    <p:sldId xmlns:r="http://schemas.openxmlformats.org/officeDocument/2006/relationships" id="262" r:id="Rc82cb8c8e062419a"/>
+    <p:sldId xmlns:r="http://schemas.openxmlformats.org/officeDocument/2006/relationships" id="263" r:id="R6d6e95f2bee74f2d"/>
+    <p:sldId xmlns:r="http://schemas.openxmlformats.org/officeDocument/2006/relationships" id="264" r:id="R4c5abe60477d4753"/>
+    <p:sldId xmlns:r="http://schemas.openxmlformats.org/officeDocument/2006/relationships" id="265" r:id="Rec0b9923ff3f4dcb"/>
+    <p:sldId xmlns:r="http://schemas.openxmlformats.org/officeDocument/2006/relationships" id="266" r:id="R98b18aca4def4b9d"/>
+    <p:sldId xmlns:r="http://schemas.openxmlformats.org/officeDocument/2006/relationships" id="267" r:id="R308ddd44be4b4ea3"/>
+    <p:sldId xmlns:r="http://schemas.openxmlformats.org/officeDocument/2006/relationships" id="268" r:id="R0fb9d6a5acf542b6"/>
+    <p:sldId xmlns:r="http://schemas.openxmlformats.org/officeDocument/2006/relationships" id="269" r:id="R2d657ae9f78341f8"/>
+    <p:sldId xmlns:r="http://schemas.openxmlformats.org/officeDocument/2006/relationships" id="270" r:id="R7620fabeb6dd4a8f"/>
+    <p:sldId xmlns:r="http://schemas.openxmlformats.org/officeDocument/2006/relationships" id="271" r:id="Rdf395384823f4674"/>
+    <p:sldId xmlns:r="http://schemas.openxmlformats.org/officeDocument/2006/relationships" id="272" r:id="R5c722c60381748e1"/>
+    <p:sldId xmlns:r="http://schemas.openxmlformats.org/officeDocument/2006/relationships" id="273" r:id="R753830c302f949b6"/>
   </p:sldIdLst>
   <p:sldSz cx="12192000" cy="6858000"/>
   <p:notesSz cx="6858000" cy="9144000"/>
@@ -738,7 +739,7 @@
           <a:lstStyle xmlns:a="http://schemas.openxmlformats.org/drawingml/2006/main"/>
           <a:p xmlns:a="http://schemas.openxmlformats.org/drawingml/2006/main">
             <a:r>
-              <a:t>明确模拟接口与真实 API 的边界。</a:t>
+              <a:t>明确模拟接口与真实 API 的边界。口播必须说出“模拟接入/尚未接通”。</a:t>
             </a:r>
           </a:p>
         </p:txBody>
@@ -1019,6 +1020,76 @@
           <a:p xmlns:a="http://schemas.openxmlformats.org/drawingml/2006/main">
             <a:r>
               <a:t>展示完整交付物，强调可以复跑和验证。</a:t>
+            </a:r>
+          </a:p>
+        </p:txBody>
+      </p:sp>
+      <p:sp>
+        <p:nvSpPr>
+          <p:cNvPr id="4" name="Slide Number Placeholder 3"/>
+          <p:cNvSpPr>
+            <a:spLocks xmlns:a="http://schemas.openxmlformats.org/drawingml/2006/main" noGrp="1"/>
+          </p:cNvSpPr>
+          <p:nvPr>
+            <p:ph type="sldNum" idx="5"/>
+          </p:nvPr>
+        </p:nvSpPr>
+        <p:spPr/>
+        <p:txBody>
+          <a:bodyPr xmlns:a="http://schemas.openxmlformats.org/drawingml/2006/main"/>
+          <a:lstStyle xmlns:a="http://schemas.openxmlformats.org/drawingml/2006/main"/>
+          <a:p xmlns:a="http://schemas.openxmlformats.org/drawingml/2006/main"/>
+        </p:txBody>
+      </p:sp>
+    </p:spTree>
+  </p:cSld>
+  <p:clrMapOvr>
+    <a:masterClrMapping xmlns:a="http://schemas.openxmlformats.org/drawingml/2006/main"/>
+  </p:clrMapOvr>
+</p:notes>
+</file>
+
+<file path=ppt/notesSlides/notesSlide18.xml><?xml version="1.0" encoding="utf-8"?>
+<p:notes xmlns:p="http://schemas.openxmlformats.org/presentationml/2006/main">
+  <p:cSld>
+    <p:spTree>
+      <p:nvGrpSpPr>
+        <p:cNvPr id="1" name=""/>
+        <p:cNvGrpSpPr/>
+        <p:nvPr/>
+      </p:nvGrpSpPr>
+      <p:grpSpPr>
+        <a:xfrm xmlns:a="http://schemas.openxmlformats.org/drawingml/2006/main"/>
+      </p:grpSpPr>
+      <p:sp>
+        <p:nvSpPr>
+          <p:cNvPr id="2" name="Slide Image Placeholder 1"/>
+          <p:cNvSpPr>
+            <a:spLocks xmlns:a="http://schemas.openxmlformats.org/drawingml/2006/main" noGrp="1"/>
+          </p:cNvSpPr>
+          <p:nvPr>
+            <p:ph type="sldImg" idx="0"/>
+          </p:nvPr>
+        </p:nvSpPr>
+        <p:spPr/>
+      </p:sp>
+      <p:sp>
+        <p:nvSpPr>
+          <p:cNvPr id="3" name="Notes Placeholder 2"/>
+          <p:cNvSpPr>
+            <a:spLocks xmlns:a="http://schemas.openxmlformats.org/drawingml/2006/main" noGrp="1"/>
+          </p:cNvSpPr>
+          <p:nvPr>
+            <p:ph type="body" idx="1"/>
+          </p:nvPr>
+        </p:nvSpPr>
+        <p:spPr/>
+        <p:txBody>
+          <a:bodyPr xmlns:a="http://schemas.openxmlformats.org/drawingml/2006/main"/>
+          <a:lstStyle xmlns:a="http://schemas.openxmlformats.org/drawingml/2006/main"/>
+          <a:p xmlns:a="http://schemas.openxmlformats.org/drawingml/2006/main">
+            <a:r>
+              <a:t>评审时可直接运行 npm test 证明三类用例可复现。</a:t>
             </a:r>
           </a:p>
         </p:txBody>
@@ -1646,7 +1717,7 @@
   </p:cSld>
   <p:clrMap bg1="lt1" tx1="dk1" bg2="lt2" tx2="dk2" accent1="accent1" accent2="accent2" accent3="accent3" accent4="accent4" accent5="accent5" accent6="accent6" hlink="hlink" folHlink="folHlink"/>
   <p:sldLayoutIdLst>
-    <p:sldLayoutId xmlns:r="http://schemas.openxmlformats.org/officeDocument/2006/relationships" id="2147483649" r:id="R838badb095b04ada"/>
+    <p:sldLayoutId xmlns:r="http://schemas.openxmlformats.org/officeDocument/2006/relationships" id="2147483649" r:id="R53aacc6bd02941ed"/>
   </p:sldLayoutIdLst>
   <p:txStyles>
     <p:titleStyle>
@@ -2197,7 +2268,7 @@
           <p:cNvPr id="13" name="">
             <a:extLst xmlns:a="http://schemas.openxmlformats.org/drawingml/2006/main">
               <a:ext uri="{FF2B5EF4-FFF2-40B4-BE49-F238E27FC236}">
-                <a16:creationId xmlns:a16="http://schemas.microsoft.com/office/drawing/2014/main" id="{E68DB3B6-5A53-4D6B-B2B5-D38835476F6F}"/>
+                <a16:creationId xmlns:a16="http://schemas.microsoft.com/office/drawing/2014/main" id="{214D6CC2-1401-48EF-AC79-9180F4A15345}"/>
               </a:ext>
             </a:extLst>
           </p:cNvPr>
@@ -2247,7 +2318,7 @@
           <p:cNvPr id="2" name="">
             <a:extLst xmlns:a="http://schemas.openxmlformats.org/drawingml/2006/main">
               <a:ext uri="{FF2B5EF4-FFF2-40B4-BE49-F238E27FC236}">
-                <a16:creationId xmlns:a16="http://schemas.microsoft.com/office/drawing/2014/main" id="{52301FEF-D864-4B84-A7AA-06F2C945066D}"/>
+                <a16:creationId xmlns:a16="http://schemas.microsoft.com/office/drawing/2014/main" id="{A698E623-FB74-4576-8F98-F1DAD9F3EFE2}"/>
               </a:ext>
             </a:extLst>
           </p:cNvPr>
@@ -2297,7 +2368,7 @@
           <p:cNvPr id="3" name="">
             <a:extLst xmlns:a="http://schemas.openxmlformats.org/drawingml/2006/main">
               <a:ext uri="{FF2B5EF4-FFF2-40B4-BE49-F238E27FC236}">
-                <a16:creationId xmlns:a16="http://schemas.microsoft.com/office/drawing/2014/main" id="{E8B5A72D-4392-46F9-A869-1325D13A6FDA}"/>
+                <a16:creationId xmlns:a16="http://schemas.microsoft.com/office/drawing/2014/main" id="{0E439059-C556-4FF5-B8E2-6C33FA133FAC}"/>
               </a:ext>
             </a:extLst>
           </p:cNvPr>
@@ -2347,7 +2418,7 @@
           <p:cNvPr id="4" name="">
             <a:extLst xmlns:a="http://schemas.openxmlformats.org/drawingml/2006/main">
               <a:ext uri="{FF2B5EF4-FFF2-40B4-BE49-F238E27FC236}">
-                <a16:creationId xmlns:a16="http://schemas.microsoft.com/office/drawing/2014/main" id="{0AEE0DA1-4D12-4FA9-B997-B84E19D61940}"/>
+                <a16:creationId xmlns:a16="http://schemas.microsoft.com/office/drawing/2014/main" id="{19786F7D-8270-4FBE-91D4-5F870CC4808A}"/>
               </a:ext>
             </a:extLst>
           </p:cNvPr>
@@ -2380,7 +2451,7 @@
           <p:cNvPr id="5" name="">
             <a:extLst xmlns:a="http://schemas.openxmlformats.org/drawingml/2006/main">
               <a:ext uri="{FF2B5EF4-FFF2-40B4-BE49-F238E27FC236}">
-                <a16:creationId xmlns:a16="http://schemas.microsoft.com/office/drawing/2014/main" id="{59D47D78-F360-4D42-8D99-99E07C25034D}"/>
+                <a16:creationId xmlns:a16="http://schemas.microsoft.com/office/drawing/2014/main" id="{857CC619-1759-40E2-BA61-443AA8623D1E}"/>
               </a:ext>
             </a:extLst>
           </p:cNvPr>
@@ -2430,7 +2501,7 @@
           <p:cNvPr id="6" name="">
             <a:extLst xmlns:a="http://schemas.openxmlformats.org/drawingml/2006/main">
               <a:ext uri="{FF2B5EF4-FFF2-40B4-BE49-F238E27FC236}">
-                <a16:creationId xmlns:a16="http://schemas.microsoft.com/office/drawing/2014/main" id="{68CADD52-FC38-4464-A39A-24EB8C0C5AD4}"/>
+                <a16:creationId xmlns:a16="http://schemas.microsoft.com/office/drawing/2014/main" id="{E3F52E10-E497-40E0-8E8A-1A0C5E1A198F}"/>
               </a:ext>
             </a:extLst>
           </p:cNvPr>
@@ -2480,7 +2551,7 @@
           <p:cNvPr id="7" name="">
             <a:extLst xmlns:a="http://schemas.openxmlformats.org/drawingml/2006/main">
               <a:ext uri="{FF2B5EF4-FFF2-40B4-BE49-F238E27FC236}">
-                <a16:creationId xmlns:a16="http://schemas.microsoft.com/office/drawing/2014/main" id="{44D10033-CEC0-4706-9793-59FBD4D712A3}"/>
+                <a16:creationId xmlns:a16="http://schemas.microsoft.com/office/drawing/2014/main" id="{AF8D0414-8C16-4A64-8CB5-C6BC07B1A790}"/>
               </a:ext>
             </a:extLst>
           </p:cNvPr>
@@ -2530,7 +2601,7 @@
           <p:cNvPr id="8" name="">
             <a:extLst xmlns:a="http://schemas.openxmlformats.org/drawingml/2006/main">
               <a:ext uri="{FF2B5EF4-FFF2-40B4-BE49-F238E27FC236}">
-                <a16:creationId xmlns:a16="http://schemas.microsoft.com/office/drawing/2014/main" id="{68D61BDF-66B6-4B98-ACF5-F89389FDFF7B}"/>
+                <a16:creationId xmlns:a16="http://schemas.microsoft.com/office/drawing/2014/main" id="{8432F353-8E3A-45E1-9CA3-A99EF45280E3}"/>
               </a:ext>
             </a:extLst>
           </p:cNvPr>
@@ -2580,7 +2651,7 @@
           <p:cNvPr id="9" name="">
             <a:extLst xmlns:a="http://schemas.openxmlformats.org/drawingml/2006/main">
               <a:ext uri="{FF2B5EF4-FFF2-40B4-BE49-F238E27FC236}">
-                <a16:creationId xmlns:a16="http://schemas.microsoft.com/office/drawing/2014/main" id="{3590CF65-1E07-4A3F-89C0-65278C7E673A}"/>
+                <a16:creationId xmlns:a16="http://schemas.microsoft.com/office/drawing/2014/main" id="{F74B0DFD-0F5B-4A60-9978-D791EB315922}"/>
               </a:ext>
             </a:extLst>
           </p:cNvPr>
@@ -2630,7 +2701,7 @@
           <p:cNvPr id="10" name="">
             <a:extLst xmlns:a="http://schemas.openxmlformats.org/drawingml/2006/main">
               <a:ext uri="{FF2B5EF4-FFF2-40B4-BE49-F238E27FC236}">
-                <a16:creationId xmlns:a16="http://schemas.microsoft.com/office/drawing/2014/main" id="{3F4C60CE-8CA7-41BC-9E28-277B11566B5A}"/>
+                <a16:creationId xmlns:a16="http://schemas.microsoft.com/office/drawing/2014/main" id="{C18F0153-8C1F-466E-B3E8-C99705BA3B79}"/>
               </a:ext>
             </a:extLst>
           </p:cNvPr>
@@ -2680,7 +2751,7 @@
           <p:cNvPr id="11" name="">
             <a:extLst xmlns:a="http://schemas.openxmlformats.org/drawingml/2006/main">
               <a:ext uri="{FF2B5EF4-FFF2-40B4-BE49-F238E27FC236}">
-                <a16:creationId xmlns:a16="http://schemas.microsoft.com/office/drawing/2014/main" id="{F860C5E2-D6DD-432C-BC67-3592674576FF}"/>
+                <a16:creationId xmlns:a16="http://schemas.microsoft.com/office/drawing/2014/main" id="{EFC8AD77-FD30-4C72-A0B8-C5F3A0C7E00D}"/>
               </a:ext>
             </a:extLst>
           </p:cNvPr>
@@ -2730,7 +2801,7 @@
           <p:cNvPr id="12" name="">
             <a:extLst xmlns:a="http://schemas.openxmlformats.org/drawingml/2006/main">
               <a:ext uri="{FF2B5EF4-FFF2-40B4-BE49-F238E27FC236}">
-                <a16:creationId xmlns:a16="http://schemas.microsoft.com/office/drawing/2014/main" id="{6A5D6088-ADFD-4F83-A975-62FFDAF04B12}"/>
+                <a16:creationId xmlns:a16="http://schemas.microsoft.com/office/drawing/2014/main" id="{040C1F59-9EC1-4730-B2B7-1B9FCCF35A8F}"/>
               </a:ext>
             </a:extLst>
           </p:cNvPr>
@@ -2778,7 +2849,7 @@
     </p:spTree>
     <p:extLst>
       <p:ext uri="{BB962C8B-B14F-4D97-AF65-F5344CB8AC3E}">
-        <p14:creationId xmlns:p14="http://schemas.microsoft.com/office/powerpoint/2010/main" val="1198194223"/>
+        <p14:creationId xmlns:p14="http://schemas.microsoft.com/office/powerpoint/2010/main" val="1468434261"/>
       </p:ext>
     </p:extLst>
   </p:cSld>
@@ -2809,7 +2880,7 @@
           <p:cNvPr id="10" name="">
             <a:extLst xmlns:a="http://schemas.openxmlformats.org/drawingml/2006/main">
               <a:ext uri="{FF2B5EF4-FFF2-40B4-BE49-F238E27FC236}">
-                <a16:creationId xmlns:a16="http://schemas.microsoft.com/office/drawing/2014/main" id="{63EA5579-11FB-40F3-91D2-63F3D2E8B240}"/>
+                <a16:creationId xmlns:a16="http://schemas.microsoft.com/office/drawing/2014/main" id="{94E055E2-EB2F-4484-B7D6-F7D443F8D38C}"/>
               </a:ext>
             </a:extLst>
           </p:cNvPr>
@@ -2859,7 +2930,7 @@
           <p:cNvPr id="2" name="">
             <a:extLst xmlns:a="http://schemas.openxmlformats.org/drawingml/2006/main">
               <a:ext uri="{FF2B5EF4-FFF2-40B4-BE49-F238E27FC236}">
-                <a16:creationId xmlns:a16="http://schemas.microsoft.com/office/drawing/2014/main" id="{3F594DB2-55C2-47D4-B409-7DA3761CF0D1}"/>
+                <a16:creationId xmlns:a16="http://schemas.microsoft.com/office/drawing/2014/main" id="{6F1A0BF3-E4DE-4DB2-98F2-1F43EA03C48D}"/>
               </a:ext>
             </a:extLst>
           </p:cNvPr>
@@ -2909,7 +2980,7 @@
           <p:cNvPr id="3" name="">
             <a:extLst xmlns:a="http://schemas.openxmlformats.org/drawingml/2006/main">
               <a:ext uri="{FF2B5EF4-FFF2-40B4-BE49-F238E27FC236}">
-                <a16:creationId xmlns:a16="http://schemas.microsoft.com/office/drawing/2014/main" id="{0CE43309-5847-4D41-9CF5-70DDCEBE9B1C}"/>
+                <a16:creationId xmlns:a16="http://schemas.microsoft.com/office/drawing/2014/main" id="{DE088FD6-422F-4D24-94E2-98C874D87970}"/>
               </a:ext>
             </a:extLst>
           </p:cNvPr>
@@ -2959,7 +3030,7 @@
           <p:cNvPr id="4" name="">
             <a:extLst xmlns:a="http://schemas.openxmlformats.org/drawingml/2006/main">
               <a:ext uri="{FF2B5EF4-FFF2-40B4-BE49-F238E27FC236}">
-                <a16:creationId xmlns:a16="http://schemas.microsoft.com/office/drawing/2014/main" id="{FB01828D-18FE-4B90-8705-D6B4A72BCA48}"/>
+                <a16:creationId xmlns:a16="http://schemas.microsoft.com/office/drawing/2014/main" id="{810C8CB5-CF34-43E1-9C4A-22B3E2B3DDC0}"/>
               </a:ext>
             </a:extLst>
           </p:cNvPr>
@@ -3065,7 +3136,7 @@
           <p:cNvPr id="5" name="">
             <a:extLst xmlns:a="http://schemas.openxmlformats.org/drawingml/2006/main">
               <a:ext uri="{FF2B5EF4-FFF2-40B4-BE49-F238E27FC236}">
-                <a16:creationId xmlns:a16="http://schemas.microsoft.com/office/drawing/2014/main" id="{54FFF3A6-503A-4636-B245-264326CCF58C}"/>
+                <a16:creationId xmlns:a16="http://schemas.microsoft.com/office/drawing/2014/main" id="{4F6EEE14-3C61-420C-A107-87D6AC18943B}"/>
               </a:ext>
             </a:extLst>
           </p:cNvPr>
@@ -3115,7 +3186,7 @@
           <p:cNvPr id="6" name="">
             <a:extLst xmlns:a="http://schemas.openxmlformats.org/drawingml/2006/main">
               <a:ext uri="{FF2B5EF4-FFF2-40B4-BE49-F238E27FC236}">
-                <a16:creationId xmlns:a16="http://schemas.microsoft.com/office/drawing/2014/main" id="{683AFBFC-D880-4438-96A7-8213CFB738B5}"/>
+                <a16:creationId xmlns:a16="http://schemas.microsoft.com/office/drawing/2014/main" id="{F4FDAD76-49AF-4720-943E-5612796A788D}"/>
               </a:ext>
             </a:extLst>
           </p:cNvPr>
@@ -3221,7 +3292,7 @@
           <p:cNvPr id="7" name="">
             <a:extLst xmlns:a="http://schemas.openxmlformats.org/drawingml/2006/main">
               <a:ext uri="{FF2B5EF4-FFF2-40B4-BE49-F238E27FC236}">
-                <a16:creationId xmlns:a16="http://schemas.microsoft.com/office/drawing/2014/main" id="{D895E329-0E60-45EC-BCCC-E42ED7CBD5A8}"/>
+                <a16:creationId xmlns:a16="http://schemas.microsoft.com/office/drawing/2014/main" id="{2DFE9071-01E5-4A8C-A618-DA25F1ECE874}"/>
               </a:ext>
             </a:extLst>
           </p:cNvPr>
@@ -3271,7 +3342,7 @@
           <p:cNvPr id="8" name="">
             <a:extLst xmlns:a="http://schemas.openxmlformats.org/drawingml/2006/main">
               <a:ext uri="{FF2B5EF4-FFF2-40B4-BE49-F238E27FC236}">
-                <a16:creationId xmlns:a16="http://schemas.microsoft.com/office/drawing/2014/main" id="{9721ABCF-63E1-4932-8807-04082764D8F0}"/>
+                <a16:creationId xmlns:a16="http://schemas.microsoft.com/office/drawing/2014/main" id="{E5C77887-D8C9-43B1-8BFE-AA206A8FAF02}"/>
               </a:ext>
             </a:extLst>
           </p:cNvPr>
@@ -3321,7 +3392,7 @@
           <p:cNvPr id="9" name="">
             <a:extLst xmlns:a="http://schemas.openxmlformats.org/drawingml/2006/main">
               <a:ext uri="{FF2B5EF4-FFF2-40B4-BE49-F238E27FC236}">
-                <a16:creationId xmlns:a16="http://schemas.microsoft.com/office/drawing/2014/main" id="{4DEE0D98-98F3-4161-A51F-EB8FCD26975B}"/>
+                <a16:creationId xmlns:a16="http://schemas.microsoft.com/office/drawing/2014/main" id="{57E4B7A9-E2CA-405A-AB01-99E80D876F33}"/>
               </a:ext>
             </a:extLst>
           </p:cNvPr>
@@ -3369,7 +3440,7 @@
     </p:spTree>
     <p:extLst>
       <p:ext uri="{BB962C8B-B14F-4D97-AF65-F5344CB8AC3E}">
-        <p14:creationId xmlns:p14="http://schemas.microsoft.com/office/powerpoint/2010/main" val="1891042629"/>
+        <p14:creationId xmlns:p14="http://schemas.microsoft.com/office/powerpoint/2010/main" val="811012560"/>
       </p:ext>
     </p:extLst>
   </p:cSld>
@@ -3400,7 +3471,7 @@
           <p:cNvPr id="25" name="">
             <a:extLst xmlns:a="http://schemas.openxmlformats.org/drawingml/2006/main">
               <a:ext uri="{FF2B5EF4-FFF2-40B4-BE49-F238E27FC236}">
-                <a16:creationId xmlns:a16="http://schemas.microsoft.com/office/drawing/2014/main" id="{360D2B3E-FC02-459B-AEF5-4E1478AC57BC}"/>
+                <a16:creationId xmlns:a16="http://schemas.microsoft.com/office/drawing/2014/main" id="{53924C5C-811A-45F6-8654-DF922091DE41}"/>
               </a:ext>
             </a:extLst>
           </p:cNvPr>
@@ -3450,7 +3521,7 @@
           <p:cNvPr id="2" name="">
             <a:extLst xmlns:a="http://schemas.openxmlformats.org/drawingml/2006/main">
               <a:ext uri="{FF2B5EF4-FFF2-40B4-BE49-F238E27FC236}">
-                <a16:creationId xmlns:a16="http://schemas.microsoft.com/office/drawing/2014/main" id="{7913F687-50A5-4E87-A4B2-ADD3E7705D89}"/>
+                <a16:creationId xmlns:a16="http://schemas.microsoft.com/office/drawing/2014/main" id="{53CD029E-BE1D-490B-99E1-8E754625903F}"/>
               </a:ext>
             </a:extLst>
           </p:cNvPr>
@@ -3500,7 +3571,7 @@
           <p:cNvPr id="3" name="">
             <a:extLst xmlns:a="http://schemas.openxmlformats.org/drawingml/2006/main">
               <a:ext uri="{FF2B5EF4-FFF2-40B4-BE49-F238E27FC236}">
-                <a16:creationId xmlns:a16="http://schemas.microsoft.com/office/drawing/2014/main" id="{0FF1900F-A523-4080-9852-411DA9923E12}"/>
+                <a16:creationId xmlns:a16="http://schemas.microsoft.com/office/drawing/2014/main" id="{2BD424BC-49BF-4FE4-8CE8-23832FFFE168}"/>
               </a:ext>
             </a:extLst>
           </p:cNvPr>
@@ -3535,7 +3606,7 @@
           <p:cNvPr id="4" name="">
             <a:extLst xmlns:a="http://schemas.openxmlformats.org/drawingml/2006/main">
               <a:ext uri="{FF2B5EF4-FFF2-40B4-BE49-F238E27FC236}">
-                <a16:creationId xmlns:a16="http://schemas.microsoft.com/office/drawing/2014/main" id="{120EE1B3-5865-49CF-B2F2-2C20F4C69744}"/>
+                <a16:creationId xmlns:a16="http://schemas.microsoft.com/office/drawing/2014/main" id="{C50511F3-E3FB-4A5A-A138-628132ED724D}"/>
               </a:ext>
             </a:extLst>
           </p:cNvPr>
@@ -3585,7 +3656,7 @@
           <p:cNvPr id="5" name="">
             <a:extLst xmlns:a="http://schemas.openxmlformats.org/drawingml/2006/main">
               <a:ext uri="{FF2B5EF4-FFF2-40B4-BE49-F238E27FC236}">
-                <a16:creationId xmlns:a16="http://schemas.microsoft.com/office/drawing/2014/main" id="{711EF359-32AD-45F3-9711-69AD5F5CEEC2}"/>
+                <a16:creationId xmlns:a16="http://schemas.microsoft.com/office/drawing/2014/main" id="{AFCD000D-FAEA-451A-B56D-DDCF44FD2732}"/>
               </a:ext>
             </a:extLst>
           </p:cNvPr>
@@ -3635,7 +3706,7 @@
           <p:cNvPr id="6" name="">
             <a:extLst xmlns:a="http://schemas.openxmlformats.org/drawingml/2006/main">
               <a:ext uri="{FF2B5EF4-FFF2-40B4-BE49-F238E27FC236}">
-                <a16:creationId xmlns:a16="http://schemas.microsoft.com/office/drawing/2014/main" id="{EE93C9B1-F040-48DB-8997-6B49C1F891D3}"/>
+                <a16:creationId xmlns:a16="http://schemas.microsoft.com/office/drawing/2014/main" id="{9DD63EB8-4D08-4635-A03B-A7E4DAB56A72}"/>
               </a:ext>
             </a:extLst>
           </p:cNvPr>
@@ -3685,7 +3756,7 @@
           <p:cNvPr id="7" name="">
             <a:extLst xmlns:a="http://schemas.openxmlformats.org/drawingml/2006/main">
               <a:ext uri="{FF2B5EF4-FFF2-40B4-BE49-F238E27FC236}">
-                <a16:creationId xmlns:a16="http://schemas.microsoft.com/office/drawing/2014/main" id="{AD98D9FD-EE21-420E-8149-784A1E442B3C}"/>
+                <a16:creationId xmlns:a16="http://schemas.microsoft.com/office/drawing/2014/main" id="{00F904BF-7715-46FA-AAAA-589EA7358BA3}"/>
               </a:ext>
             </a:extLst>
           </p:cNvPr>
@@ -3720,7 +3791,7 @@
           <p:cNvPr id="8" name="">
             <a:extLst xmlns:a="http://schemas.openxmlformats.org/drawingml/2006/main">
               <a:ext uri="{FF2B5EF4-FFF2-40B4-BE49-F238E27FC236}">
-                <a16:creationId xmlns:a16="http://schemas.microsoft.com/office/drawing/2014/main" id="{D2D3AFCD-BB73-473E-9AF5-F5843FF2B46A}"/>
+                <a16:creationId xmlns:a16="http://schemas.microsoft.com/office/drawing/2014/main" id="{CFD2216C-6E87-4792-8AB1-C9CD5FE1DCEC}"/>
               </a:ext>
             </a:extLst>
           </p:cNvPr>
@@ -3770,7 +3841,7 @@
           <p:cNvPr id="9" name="">
             <a:extLst xmlns:a="http://schemas.openxmlformats.org/drawingml/2006/main">
               <a:ext uri="{FF2B5EF4-FFF2-40B4-BE49-F238E27FC236}">
-                <a16:creationId xmlns:a16="http://schemas.microsoft.com/office/drawing/2014/main" id="{2362750D-9A0D-4A0A-8062-4946EA517425}"/>
+                <a16:creationId xmlns:a16="http://schemas.microsoft.com/office/drawing/2014/main" id="{D343CFA3-5BD2-4B70-9FAD-0505F8C29502}"/>
               </a:ext>
             </a:extLst>
           </p:cNvPr>
@@ -3820,7 +3891,7 @@
           <p:cNvPr id="10" name="">
             <a:extLst xmlns:a="http://schemas.openxmlformats.org/drawingml/2006/main">
               <a:ext uri="{FF2B5EF4-FFF2-40B4-BE49-F238E27FC236}">
-                <a16:creationId xmlns:a16="http://schemas.microsoft.com/office/drawing/2014/main" id="{29B46A45-F725-40D8-B9F8-276DE77B3707}"/>
+                <a16:creationId xmlns:a16="http://schemas.microsoft.com/office/drawing/2014/main" id="{284CDBF9-0D39-47C8-9925-2B16A0A9A57F}"/>
               </a:ext>
             </a:extLst>
           </p:cNvPr>
@@ -3870,7 +3941,7 @@
           <p:cNvPr id="11" name="">
             <a:extLst xmlns:a="http://schemas.openxmlformats.org/drawingml/2006/main">
               <a:ext uri="{FF2B5EF4-FFF2-40B4-BE49-F238E27FC236}">
-                <a16:creationId xmlns:a16="http://schemas.microsoft.com/office/drawing/2014/main" id="{2AA6117C-ADCE-4FF3-BA7F-994280962B97}"/>
+                <a16:creationId xmlns:a16="http://schemas.microsoft.com/office/drawing/2014/main" id="{EFD0697C-02A8-4322-BCDF-6F2E99EFA37F}"/>
               </a:ext>
             </a:extLst>
           </p:cNvPr>
@@ -3905,7 +3976,7 @@
           <p:cNvPr id="12" name="">
             <a:extLst xmlns:a="http://schemas.openxmlformats.org/drawingml/2006/main">
               <a:ext uri="{FF2B5EF4-FFF2-40B4-BE49-F238E27FC236}">
-                <a16:creationId xmlns:a16="http://schemas.microsoft.com/office/drawing/2014/main" id="{0D09DFE1-CF6C-46C2-87D5-53A427B69255}"/>
+                <a16:creationId xmlns:a16="http://schemas.microsoft.com/office/drawing/2014/main" id="{624D6E68-4519-4997-B1A8-8303FD1104AB}"/>
               </a:ext>
             </a:extLst>
           </p:cNvPr>
@@ -3955,7 +4026,7 @@
           <p:cNvPr id="13" name="">
             <a:extLst xmlns:a="http://schemas.openxmlformats.org/drawingml/2006/main">
               <a:ext uri="{FF2B5EF4-FFF2-40B4-BE49-F238E27FC236}">
-                <a16:creationId xmlns:a16="http://schemas.microsoft.com/office/drawing/2014/main" id="{E550D6E8-069E-40CE-839D-B0B9288AACA3}"/>
+                <a16:creationId xmlns:a16="http://schemas.microsoft.com/office/drawing/2014/main" id="{E587FFCF-ECD3-452A-B0AE-0ED299E2D6FA}"/>
               </a:ext>
             </a:extLst>
           </p:cNvPr>
@@ -4005,7 +4076,7 @@
           <p:cNvPr id="14" name="">
             <a:extLst xmlns:a="http://schemas.openxmlformats.org/drawingml/2006/main">
               <a:ext uri="{FF2B5EF4-FFF2-40B4-BE49-F238E27FC236}">
-                <a16:creationId xmlns:a16="http://schemas.microsoft.com/office/drawing/2014/main" id="{F9C92A69-9FE6-453D-BF1D-7EFE9B962DB5}"/>
+                <a16:creationId xmlns:a16="http://schemas.microsoft.com/office/drawing/2014/main" id="{647D67B7-08E5-47FB-9C9A-5A8CB044E4A8}"/>
               </a:ext>
             </a:extLst>
           </p:cNvPr>
@@ -4055,7 +4126,7 @@
           <p:cNvPr id="15" name="">
             <a:extLst xmlns:a="http://schemas.openxmlformats.org/drawingml/2006/main">
               <a:ext uri="{FF2B5EF4-FFF2-40B4-BE49-F238E27FC236}">
-                <a16:creationId xmlns:a16="http://schemas.microsoft.com/office/drawing/2014/main" id="{332744EF-5108-427C-AC33-0595F0703BE6}"/>
+                <a16:creationId xmlns:a16="http://schemas.microsoft.com/office/drawing/2014/main" id="{505E2F5D-9C9D-43C0-8294-57A101A9A9F1}"/>
               </a:ext>
             </a:extLst>
           </p:cNvPr>
@@ -4090,7 +4161,7 @@
           <p:cNvPr id="16" name="">
             <a:extLst xmlns:a="http://schemas.openxmlformats.org/drawingml/2006/main">
               <a:ext uri="{FF2B5EF4-FFF2-40B4-BE49-F238E27FC236}">
-                <a16:creationId xmlns:a16="http://schemas.microsoft.com/office/drawing/2014/main" id="{C6BCE42D-F8CD-4395-B0D2-9EF912C169F7}"/>
+                <a16:creationId xmlns:a16="http://schemas.microsoft.com/office/drawing/2014/main" id="{0232E416-F7D0-4BEB-AC36-E351D149634F}"/>
               </a:ext>
             </a:extLst>
           </p:cNvPr>
@@ -4140,7 +4211,7 @@
           <p:cNvPr id="17" name="">
             <a:extLst xmlns:a="http://schemas.openxmlformats.org/drawingml/2006/main">
               <a:ext uri="{FF2B5EF4-FFF2-40B4-BE49-F238E27FC236}">
-                <a16:creationId xmlns:a16="http://schemas.microsoft.com/office/drawing/2014/main" id="{F5ADEF02-9A46-49D4-83E4-B32B067A198D}"/>
+                <a16:creationId xmlns:a16="http://schemas.microsoft.com/office/drawing/2014/main" id="{2188C40E-CF57-4985-805D-D896C5A2A7AC}"/>
               </a:ext>
             </a:extLst>
           </p:cNvPr>
@@ -4190,7 +4261,7 @@
           <p:cNvPr id="18" name="">
             <a:extLst xmlns:a="http://schemas.openxmlformats.org/drawingml/2006/main">
               <a:ext uri="{FF2B5EF4-FFF2-40B4-BE49-F238E27FC236}">
-                <a16:creationId xmlns:a16="http://schemas.microsoft.com/office/drawing/2014/main" id="{17128944-6249-4212-97EB-125E24447ED0}"/>
+                <a16:creationId xmlns:a16="http://schemas.microsoft.com/office/drawing/2014/main" id="{A8963FDE-A1BA-4B92-BDD4-5FA5F80D8F63}"/>
               </a:ext>
             </a:extLst>
           </p:cNvPr>
@@ -4240,7 +4311,7 @@
           <p:cNvPr id="19" name="">
             <a:extLst xmlns:a="http://schemas.openxmlformats.org/drawingml/2006/main">
               <a:ext uri="{FF2B5EF4-FFF2-40B4-BE49-F238E27FC236}">
-                <a16:creationId xmlns:a16="http://schemas.microsoft.com/office/drawing/2014/main" id="{F7F34703-14D8-46DF-9B89-D8E5555ADC85}"/>
+                <a16:creationId xmlns:a16="http://schemas.microsoft.com/office/drawing/2014/main" id="{1B1D1DFD-82C1-4E9A-A469-FAC7D3206804}"/>
               </a:ext>
             </a:extLst>
           </p:cNvPr>
@@ -4275,7 +4346,7 @@
           <p:cNvPr id="20" name="">
             <a:extLst xmlns:a="http://schemas.openxmlformats.org/drawingml/2006/main">
               <a:ext uri="{FF2B5EF4-FFF2-40B4-BE49-F238E27FC236}">
-                <a16:creationId xmlns:a16="http://schemas.microsoft.com/office/drawing/2014/main" id="{A6495F76-5D20-4B11-B86F-5941068DB3A9}"/>
+                <a16:creationId xmlns:a16="http://schemas.microsoft.com/office/drawing/2014/main" id="{733F0BB5-1BB8-4E2A-B083-4709269120B7}"/>
               </a:ext>
             </a:extLst>
           </p:cNvPr>
@@ -4325,7 +4396,7 @@
           <p:cNvPr id="21" name="">
             <a:extLst xmlns:a="http://schemas.openxmlformats.org/drawingml/2006/main">
               <a:ext uri="{FF2B5EF4-FFF2-40B4-BE49-F238E27FC236}">
-                <a16:creationId xmlns:a16="http://schemas.microsoft.com/office/drawing/2014/main" id="{16D32170-F0AF-4EC0-B1AB-DBE6031153F4}"/>
+                <a16:creationId xmlns:a16="http://schemas.microsoft.com/office/drawing/2014/main" id="{0E8C7845-0DAD-4F44-86BD-DBDBD9B04E23}"/>
               </a:ext>
             </a:extLst>
           </p:cNvPr>
@@ -4375,7 +4446,7 @@
           <p:cNvPr id="22" name="">
             <a:extLst xmlns:a="http://schemas.openxmlformats.org/drawingml/2006/main">
               <a:ext uri="{FF2B5EF4-FFF2-40B4-BE49-F238E27FC236}">
-                <a16:creationId xmlns:a16="http://schemas.microsoft.com/office/drawing/2014/main" id="{079D11CF-EB16-4BE9-9FA5-12D865D2BE62}"/>
+                <a16:creationId xmlns:a16="http://schemas.microsoft.com/office/drawing/2014/main" id="{A9F72A6D-253E-44CC-8AE8-9395678DD603}"/>
               </a:ext>
             </a:extLst>
           </p:cNvPr>
@@ -4425,7 +4496,7 @@
           <p:cNvPr id="23" name="">
             <a:extLst xmlns:a="http://schemas.openxmlformats.org/drawingml/2006/main">
               <a:ext uri="{FF2B5EF4-FFF2-40B4-BE49-F238E27FC236}">
-                <a16:creationId xmlns:a16="http://schemas.microsoft.com/office/drawing/2014/main" id="{2BE1DBB3-1A26-49C2-B19C-7955AAC71F90}"/>
+                <a16:creationId xmlns:a16="http://schemas.microsoft.com/office/drawing/2014/main" id="{F812124F-64B6-4471-AF70-90485272183F}"/>
               </a:ext>
             </a:extLst>
           </p:cNvPr>
@@ -4475,7 +4546,7 @@
           <p:cNvPr id="24" name="">
             <a:extLst xmlns:a="http://schemas.openxmlformats.org/drawingml/2006/main">
               <a:ext uri="{FF2B5EF4-FFF2-40B4-BE49-F238E27FC236}">
-                <a16:creationId xmlns:a16="http://schemas.microsoft.com/office/drawing/2014/main" id="{558A4F61-487D-4321-83AC-92C7015EC8AC}"/>
+                <a16:creationId xmlns:a16="http://schemas.microsoft.com/office/drawing/2014/main" id="{97B9F695-94F1-4A5A-9E5C-8506C258E98F}"/>
               </a:ext>
             </a:extLst>
           </p:cNvPr>
@@ -4523,7 +4594,7 @@
     </p:spTree>
     <p:extLst>
       <p:ext uri="{BB962C8B-B14F-4D97-AF65-F5344CB8AC3E}">
-        <p14:creationId xmlns:p14="http://schemas.microsoft.com/office/powerpoint/2010/main" val="1510944831"/>
+        <p14:creationId xmlns:p14="http://schemas.microsoft.com/office/powerpoint/2010/main" val="308966647"/>
       </p:ext>
     </p:extLst>
   </p:cSld>
@@ -4554,7 +4625,7 @@
           <p:cNvPr id="21" name="">
             <a:extLst xmlns:a="http://schemas.openxmlformats.org/drawingml/2006/main">
               <a:ext uri="{FF2B5EF4-FFF2-40B4-BE49-F238E27FC236}">
-                <a16:creationId xmlns:a16="http://schemas.microsoft.com/office/drawing/2014/main" id="{03737701-241D-48ED-AAB9-88D05C14DDE8}"/>
+                <a16:creationId xmlns:a16="http://schemas.microsoft.com/office/drawing/2014/main" id="{5C4EAD25-2443-49CC-9E33-AD04271E2553}"/>
               </a:ext>
             </a:extLst>
           </p:cNvPr>
@@ -4604,7 +4675,7 @@
           <p:cNvPr id="2" name="">
             <a:extLst xmlns:a="http://schemas.openxmlformats.org/drawingml/2006/main">
               <a:ext uri="{FF2B5EF4-FFF2-40B4-BE49-F238E27FC236}">
-                <a16:creationId xmlns:a16="http://schemas.microsoft.com/office/drawing/2014/main" id="{C67DE1F1-D306-48A8-8050-75C47A2A9DB5}"/>
+                <a16:creationId xmlns:a16="http://schemas.microsoft.com/office/drawing/2014/main" id="{89C77BDA-1112-422E-896A-3ACBF4430665}"/>
               </a:ext>
             </a:extLst>
           </p:cNvPr>
@@ -4654,7 +4725,7 @@
           <p:cNvPr id="3" name="">
             <a:extLst xmlns:a="http://schemas.openxmlformats.org/drawingml/2006/main">
               <a:ext uri="{FF2B5EF4-FFF2-40B4-BE49-F238E27FC236}">
-                <a16:creationId xmlns:a16="http://schemas.microsoft.com/office/drawing/2014/main" id="{72AA6B10-9447-4624-8CA8-F6E5AEB714BB}"/>
+                <a16:creationId xmlns:a16="http://schemas.microsoft.com/office/drawing/2014/main" id="{4B970EA3-A5D6-4A3B-8DB4-CFFBDE547F40}"/>
               </a:ext>
             </a:extLst>
           </p:cNvPr>
@@ -4687,7 +4758,7 @@
           <p:cNvPr id="4" name="">
             <a:extLst xmlns:a="http://schemas.openxmlformats.org/drawingml/2006/main">
               <a:ext uri="{FF2B5EF4-FFF2-40B4-BE49-F238E27FC236}">
-                <a16:creationId xmlns:a16="http://schemas.microsoft.com/office/drawing/2014/main" id="{E79973DE-BD5C-4DF1-8C59-29BB3DCD9799}"/>
+                <a16:creationId xmlns:a16="http://schemas.microsoft.com/office/drawing/2014/main" id="{4EE56138-658D-4A47-92F3-2BAF63619579}"/>
               </a:ext>
             </a:extLst>
           </p:cNvPr>
@@ -4737,7 +4808,7 @@
           <p:cNvPr id="5" name="">
             <a:extLst xmlns:a="http://schemas.openxmlformats.org/drawingml/2006/main">
               <a:ext uri="{FF2B5EF4-FFF2-40B4-BE49-F238E27FC236}">
-                <a16:creationId xmlns:a16="http://schemas.microsoft.com/office/drawing/2014/main" id="{29C2613D-F761-484A-9085-E74A368C0030}"/>
+                <a16:creationId xmlns:a16="http://schemas.microsoft.com/office/drawing/2014/main" id="{98376507-070A-44D3-B039-F9EC35EE01A8}"/>
               </a:ext>
             </a:extLst>
           </p:cNvPr>
@@ -4787,7 +4858,7 @@
           <p:cNvPr id="6" name="">
             <a:extLst xmlns:a="http://schemas.openxmlformats.org/drawingml/2006/main">
               <a:ext uri="{FF2B5EF4-FFF2-40B4-BE49-F238E27FC236}">
-                <a16:creationId xmlns:a16="http://schemas.microsoft.com/office/drawing/2014/main" id="{FC3A12DB-8ADA-4F82-AE23-D97D37AE7BC1}"/>
+                <a16:creationId xmlns:a16="http://schemas.microsoft.com/office/drawing/2014/main" id="{46417B2E-A36C-4325-BE74-BFC41DEB8AF5}"/>
               </a:ext>
             </a:extLst>
           </p:cNvPr>
@@ -4837,7 +4908,7 @@
           <p:cNvPr id="7" name="">
             <a:extLst xmlns:a="http://schemas.openxmlformats.org/drawingml/2006/main">
               <a:ext uri="{FF2B5EF4-FFF2-40B4-BE49-F238E27FC236}">
-                <a16:creationId xmlns:a16="http://schemas.microsoft.com/office/drawing/2014/main" id="{0453DA21-41C7-4344-8F19-15A764CDA67C}"/>
+                <a16:creationId xmlns:a16="http://schemas.microsoft.com/office/drawing/2014/main" id="{45CFC13E-2CD0-4EF6-8C90-5867DFE3663F}"/>
               </a:ext>
             </a:extLst>
           </p:cNvPr>
@@ -4870,7 +4941,7 @@
           <p:cNvPr id="8" name="">
             <a:extLst xmlns:a="http://schemas.openxmlformats.org/drawingml/2006/main">
               <a:ext uri="{FF2B5EF4-FFF2-40B4-BE49-F238E27FC236}">
-                <a16:creationId xmlns:a16="http://schemas.microsoft.com/office/drawing/2014/main" id="{E0ADA7F3-87CC-473F-83C5-7EFC2F86EB75}"/>
+                <a16:creationId xmlns:a16="http://schemas.microsoft.com/office/drawing/2014/main" id="{916D9549-6D29-4563-BBF7-B4E9E68A52D3}"/>
               </a:ext>
             </a:extLst>
           </p:cNvPr>
@@ -4920,7 +4991,7 @@
           <p:cNvPr id="9" name="">
             <a:extLst xmlns:a="http://schemas.openxmlformats.org/drawingml/2006/main">
               <a:ext uri="{FF2B5EF4-FFF2-40B4-BE49-F238E27FC236}">
-                <a16:creationId xmlns:a16="http://schemas.microsoft.com/office/drawing/2014/main" id="{87935CA9-935B-45DE-8A67-8EEDFD8ABCF8}"/>
+                <a16:creationId xmlns:a16="http://schemas.microsoft.com/office/drawing/2014/main" id="{3BA91F86-DD88-4397-82A7-EDCE0225AD52}"/>
               </a:ext>
             </a:extLst>
           </p:cNvPr>
@@ -4970,7 +5041,7 @@
           <p:cNvPr id="10" name="">
             <a:extLst xmlns:a="http://schemas.openxmlformats.org/drawingml/2006/main">
               <a:ext uri="{FF2B5EF4-FFF2-40B4-BE49-F238E27FC236}">
-                <a16:creationId xmlns:a16="http://schemas.microsoft.com/office/drawing/2014/main" id="{7DFFAC86-9BB7-442F-B318-A039A8E2DF69}"/>
+                <a16:creationId xmlns:a16="http://schemas.microsoft.com/office/drawing/2014/main" id="{6E3F1128-ED02-44DC-A5DD-C9FBA3195268}"/>
               </a:ext>
             </a:extLst>
           </p:cNvPr>
@@ -5020,7 +5091,7 @@
           <p:cNvPr id="11" name="">
             <a:extLst xmlns:a="http://schemas.openxmlformats.org/drawingml/2006/main">
               <a:ext uri="{FF2B5EF4-FFF2-40B4-BE49-F238E27FC236}">
-                <a16:creationId xmlns:a16="http://schemas.microsoft.com/office/drawing/2014/main" id="{05765A92-9311-4AD4-8E08-9F0E7BD266B3}"/>
+                <a16:creationId xmlns:a16="http://schemas.microsoft.com/office/drawing/2014/main" id="{E198717D-824E-4FAB-A845-937CAA714DA2}"/>
               </a:ext>
             </a:extLst>
           </p:cNvPr>
@@ -5053,7 +5124,7 @@
           <p:cNvPr id="12" name="">
             <a:extLst xmlns:a="http://schemas.openxmlformats.org/drawingml/2006/main">
               <a:ext uri="{FF2B5EF4-FFF2-40B4-BE49-F238E27FC236}">
-                <a16:creationId xmlns:a16="http://schemas.microsoft.com/office/drawing/2014/main" id="{C8441B01-DA42-42B5-A7B7-D429776DA221}"/>
+                <a16:creationId xmlns:a16="http://schemas.microsoft.com/office/drawing/2014/main" id="{48FC813D-84F6-4A45-BDFA-D49EB32C5E4D}"/>
               </a:ext>
             </a:extLst>
           </p:cNvPr>
@@ -5103,7 +5174,7 @@
           <p:cNvPr id="13" name="">
             <a:extLst xmlns:a="http://schemas.openxmlformats.org/drawingml/2006/main">
               <a:ext uri="{FF2B5EF4-FFF2-40B4-BE49-F238E27FC236}">
-                <a16:creationId xmlns:a16="http://schemas.microsoft.com/office/drawing/2014/main" id="{C53BA4CA-58E4-400C-9C4C-C43F6DBC5E0A}"/>
+                <a16:creationId xmlns:a16="http://schemas.microsoft.com/office/drawing/2014/main" id="{C4F66A53-B6CD-43F9-A51A-9B78E0F8DB68}"/>
               </a:ext>
             </a:extLst>
           </p:cNvPr>
@@ -5153,7 +5224,7 @@
           <p:cNvPr id="14" name="">
             <a:extLst xmlns:a="http://schemas.openxmlformats.org/drawingml/2006/main">
               <a:ext uri="{FF2B5EF4-FFF2-40B4-BE49-F238E27FC236}">
-                <a16:creationId xmlns:a16="http://schemas.microsoft.com/office/drawing/2014/main" id="{F3D85407-6C43-49C7-9669-5ED76ACDEB38}"/>
+                <a16:creationId xmlns:a16="http://schemas.microsoft.com/office/drawing/2014/main" id="{3A536060-1228-41C9-9AF5-7D4DC190F56E}"/>
               </a:ext>
             </a:extLst>
           </p:cNvPr>
@@ -5203,7 +5274,7 @@
           <p:cNvPr id="15" name="">
             <a:extLst xmlns:a="http://schemas.openxmlformats.org/drawingml/2006/main">
               <a:ext uri="{FF2B5EF4-FFF2-40B4-BE49-F238E27FC236}">
-                <a16:creationId xmlns:a16="http://schemas.microsoft.com/office/drawing/2014/main" id="{BAD7F184-8B71-4550-9A2C-5CEC73B53BB2}"/>
+                <a16:creationId xmlns:a16="http://schemas.microsoft.com/office/drawing/2014/main" id="{FC3305DE-B196-4FD8-A928-194B48F65770}"/>
               </a:ext>
             </a:extLst>
           </p:cNvPr>
@@ -5236,7 +5307,7 @@
           <p:cNvPr id="16" name="">
             <a:extLst xmlns:a="http://schemas.openxmlformats.org/drawingml/2006/main">
               <a:ext uri="{FF2B5EF4-FFF2-40B4-BE49-F238E27FC236}">
-                <a16:creationId xmlns:a16="http://schemas.microsoft.com/office/drawing/2014/main" id="{32E09FAE-CC73-4654-BE1C-6EEE07E1A6F6}"/>
+                <a16:creationId xmlns:a16="http://schemas.microsoft.com/office/drawing/2014/main" id="{3FE40B8C-CD28-4774-B065-BBEC56F259FC}"/>
               </a:ext>
             </a:extLst>
           </p:cNvPr>
@@ -5286,7 +5357,7 @@
           <p:cNvPr id="17" name="">
             <a:extLst xmlns:a="http://schemas.openxmlformats.org/drawingml/2006/main">
               <a:ext uri="{FF2B5EF4-FFF2-40B4-BE49-F238E27FC236}">
-                <a16:creationId xmlns:a16="http://schemas.microsoft.com/office/drawing/2014/main" id="{D9CEA2EF-FABD-4EAE-B10B-4406ACD59FE8}"/>
+                <a16:creationId xmlns:a16="http://schemas.microsoft.com/office/drawing/2014/main" id="{70D66377-1B13-4D5C-B976-C414C864E761}"/>
               </a:ext>
             </a:extLst>
           </p:cNvPr>
@@ -5336,7 +5407,7 @@
           <p:cNvPr id="18" name="">
             <a:extLst xmlns:a="http://schemas.openxmlformats.org/drawingml/2006/main">
               <a:ext uri="{FF2B5EF4-FFF2-40B4-BE49-F238E27FC236}">
-                <a16:creationId xmlns:a16="http://schemas.microsoft.com/office/drawing/2014/main" id="{AF0E2F31-F4BB-44BE-963E-D2859EEB76A9}"/>
+                <a16:creationId xmlns:a16="http://schemas.microsoft.com/office/drawing/2014/main" id="{25BD2591-A6E8-4C3C-B692-D8E07D2A9FB4}"/>
               </a:ext>
             </a:extLst>
           </p:cNvPr>
@@ -5386,7 +5457,7 @@
           <p:cNvPr id="19" name="">
             <a:extLst xmlns:a="http://schemas.openxmlformats.org/drawingml/2006/main">
               <a:ext uri="{FF2B5EF4-FFF2-40B4-BE49-F238E27FC236}">
-                <a16:creationId xmlns:a16="http://schemas.microsoft.com/office/drawing/2014/main" id="{17859DCF-F782-4D7A-908D-B57A41F6F9F6}"/>
+                <a16:creationId xmlns:a16="http://schemas.microsoft.com/office/drawing/2014/main" id="{7A69A7CC-8A6F-4DA2-8496-8B30F3BD14F5}"/>
               </a:ext>
             </a:extLst>
           </p:cNvPr>
@@ -5436,7 +5507,7 @@
           <p:cNvPr id="20" name="">
             <a:extLst xmlns:a="http://schemas.openxmlformats.org/drawingml/2006/main">
               <a:ext uri="{FF2B5EF4-FFF2-40B4-BE49-F238E27FC236}">
-                <a16:creationId xmlns:a16="http://schemas.microsoft.com/office/drawing/2014/main" id="{CB6ACA31-C066-48AB-9458-1251E3586A14}"/>
+                <a16:creationId xmlns:a16="http://schemas.microsoft.com/office/drawing/2014/main" id="{2CCBDC2E-052F-4D54-8D1D-5025DECA718B}"/>
               </a:ext>
             </a:extLst>
           </p:cNvPr>
@@ -5484,7 +5555,7 @@
     </p:spTree>
     <p:extLst>
       <p:ext uri="{BB962C8B-B14F-4D97-AF65-F5344CB8AC3E}">
-        <p14:creationId xmlns:p14="http://schemas.microsoft.com/office/powerpoint/2010/main" val="116574296"/>
+        <p14:creationId xmlns:p14="http://schemas.microsoft.com/office/powerpoint/2010/main" val="1524455665"/>
       </p:ext>
     </p:extLst>
   </p:cSld>
@@ -5515,7 +5586,7 @@
           <p:cNvPr id="28" name="">
             <a:extLst xmlns:a="http://schemas.openxmlformats.org/drawingml/2006/main">
               <a:ext uri="{FF2B5EF4-FFF2-40B4-BE49-F238E27FC236}">
-                <a16:creationId xmlns:a16="http://schemas.microsoft.com/office/drawing/2014/main" id="{2E8CC515-8ED5-40ED-8817-142C0BA9DB76}"/>
+                <a16:creationId xmlns:a16="http://schemas.microsoft.com/office/drawing/2014/main" id="{50662CDF-91EE-4373-AC00-8EC6A02B598E}"/>
               </a:ext>
             </a:extLst>
           </p:cNvPr>
@@ -5565,7 +5636,7 @@
           <p:cNvPr id="2" name="">
             <a:extLst xmlns:a="http://schemas.openxmlformats.org/drawingml/2006/main">
               <a:ext uri="{FF2B5EF4-FFF2-40B4-BE49-F238E27FC236}">
-                <a16:creationId xmlns:a16="http://schemas.microsoft.com/office/drawing/2014/main" id="{1D333F3D-01B3-441B-B33D-60502401A1AD}"/>
+                <a16:creationId xmlns:a16="http://schemas.microsoft.com/office/drawing/2014/main" id="{A36758AF-7A09-42EC-8422-5607AB161C4D}"/>
               </a:ext>
             </a:extLst>
           </p:cNvPr>
@@ -5615,7 +5686,7 @@
           <p:cNvPr id="3" name="">
             <a:extLst xmlns:a="http://schemas.openxmlformats.org/drawingml/2006/main">
               <a:ext uri="{FF2B5EF4-FFF2-40B4-BE49-F238E27FC236}">
-                <a16:creationId xmlns:a16="http://schemas.microsoft.com/office/drawing/2014/main" id="{44825AA2-0482-4C57-907E-9ED95D1549AC}"/>
+                <a16:creationId xmlns:a16="http://schemas.microsoft.com/office/drawing/2014/main" id="{93AD239A-E426-4665-9D71-65E47849462A}"/>
               </a:ext>
             </a:extLst>
           </p:cNvPr>
@@ -5650,7 +5721,7 @@
           <p:cNvPr id="4" name="">
             <a:extLst xmlns:a="http://schemas.openxmlformats.org/drawingml/2006/main">
               <a:ext uri="{FF2B5EF4-FFF2-40B4-BE49-F238E27FC236}">
-                <a16:creationId xmlns:a16="http://schemas.microsoft.com/office/drawing/2014/main" id="{9BA42A37-3DD9-44EB-BD0A-E0A4BEB3F9D8}"/>
+                <a16:creationId xmlns:a16="http://schemas.microsoft.com/office/drawing/2014/main" id="{8CDA4D39-5056-4413-A84C-015A42B576CB}"/>
               </a:ext>
             </a:extLst>
           </p:cNvPr>
@@ -5700,7 +5771,7 @@
           <p:cNvPr id="5" name="">
             <a:extLst xmlns:a="http://schemas.openxmlformats.org/drawingml/2006/main">
               <a:ext uri="{FF2B5EF4-FFF2-40B4-BE49-F238E27FC236}">
-                <a16:creationId xmlns:a16="http://schemas.microsoft.com/office/drawing/2014/main" id="{BB500609-FAE5-401F-8B48-349A693DDDE1}"/>
+                <a16:creationId xmlns:a16="http://schemas.microsoft.com/office/drawing/2014/main" id="{FB150585-C35F-42BD-9195-2B8A027B32AB}"/>
               </a:ext>
             </a:extLst>
           </p:cNvPr>
@@ -5750,7 +5821,7 @@
           <p:cNvPr id="6" name="">
             <a:extLst xmlns:a="http://schemas.openxmlformats.org/drawingml/2006/main">
               <a:ext uri="{FF2B5EF4-FFF2-40B4-BE49-F238E27FC236}">
-                <a16:creationId xmlns:a16="http://schemas.microsoft.com/office/drawing/2014/main" id="{73AC4E3F-4C1B-4110-BBB7-A72A569B109D}"/>
+                <a16:creationId xmlns:a16="http://schemas.microsoft.com/office/drawing/2014/main" id="{01A5AC0D-30F0-499C-87ED-9E648CB0A1D2}"/>
               </a:ext>
             </a:extLst>
           </p:cNvPr>
@@ -5800,7 +5871,7 @@
           <p:cNvPr id="7" name="">
             <a:extLst xmlns:a="http://schemas.openxmlformats.org/drawingml/2006/main">
               <a:ext uri="{FF2B5EF4-FFF2-40B4-BE49-F238E27FC236}">
-                <a16:creationId xmlns:a16="http://schemas.microsoft.com/office/drawing/2014/main" id="{E13C6481-1250-4DD4-999D-0B887D66FDA1}"/>
+                <a16:creationId xmlns:a16="http://schemas.microsoft.com/office/drawing/2014/main" id="{718F754C-4E22-4526-9C3F-B8807BFBCECC}"/>
               </a:ext>
             </a:extLst>
           </p:cNvPr>
@@ -5835,7 +5906,7 @@
           <p:cNvPr id="8" name="">
             <a:extLst xmlns:a="http://schemas.openxmlformats.org/drawingml/2006/main">
               <a:ext uri="{FF2B5EF4-FFF2-40B4-BE49-F238E27FC236}">
-                <a16:creationId xmlns:a16="http://schemas.microsoft.com/office/drawing/2014/main" id="{E1977B76-0D21-46DD-96D4-C21B981D33F6}"/>
+                <a16:creationId xmlns:a16="http://schemas.microsoft.com/office/drawing/2014/main" id="{813E74EA-3DA3-4468-98EA-B5370655BF5A}"/>
               </a:ext>
             </a:extLst>
           </p:cNvPr>
@@ -5885,7 +5956,7 @@
           <p:cNvPr id="9" name="">
             <a:extLst xmlns:a="http://schemas.openxmlformats.org/drawingml/2006/main">
               <a:ext uri="{FF2B5EF4-FFF2-40B4-BE49-F238E27FC236}">
-                <a16:creationId xmlns:a16="http://schemas.microsoft.com/office/drawing/2014/main" id="{EF1AC122-AA57-4996-95F5-FB8C37DA25E7}"/>
+                <a16:creationId xmlns:a16="http://schemas.microsoft.com/office/drawing/2014/main" id="{256359B0-DA6B-4ADD-B91C-D318C80DDFC6}"/>
               </a:ext>
             </a:extLst>
           </p:cNvPr>
@@ -5935,7 +6006,7 @@
           <p:cNvPr id="10" name="">
             <a:extLst xmlns:a="http://schemas.openxmlformats.org/drawingml/2006/main">
               <a:ext uri="{FF2B5EF4-FFF2-40B4-BE49-F238E27FC236}">
-                <a16:creationId xmlns:a16="http://schemas.microsoft.com/office/drawing/2014/main" id="{56D50A9A-A8BA-4A9D-BB0D-EF39708D5C99}"/>
+                <a16:creationId xmlns:a16="http://schemas.microsoft.com/office/drawing/2014/main" id="{C8F2294E-0D04-4FC4-AE83-06DDC5409226}"/>
               </a:ext>
             </a:extLst>
           </p:cNvPr>
@@ -5985,7 +6056,7 @@
           <p:cNvPr id="11" name="">
             <a:extLst xmlns:a="http://schemas.openxmlformats.org/drawingml/2006/main">
               <a:ext uri="{FF2B5EF4-FFF2-40B4-BE49-F238E27FC236}">
-                <a16:creationId xmlns:a16="http://schemas.microsoft.com/office/drawing/2014/main" id="{709DC79F-9A77-4740-AB39-954501DC0AF9}"/>
+                <a16:creationId xmlns:a16="http://schemas.microsoft.com/office/drawing/2014/main" id="{6D49AFAD-A470-4A3A-AA67-FDE9F8772DCF}"/>
               </a:ext>
             </a:extLst>
           </p:cNvPr>
@@ -6020,7 +6091,7 @@
           <p:cNvPr id="12" name="">
             <a:extLst xmlns:a="http://schemas.openxmlformats.org/drawingml/2006/main">
               <a:ext uri="{FF2B5EF4-FFF2-40B4-BE49-F238E27FC236}">
-                <a16:creationId xmlns:a16="http://schemas.microsoft.com/office/drawing/2014/main" id="{B2ADF510-6D5C-4FB6-B2A2-0ACE3FBBAE9D}"/>
+                <a16:creationId xmlns:a16="http://schemas.microsoft.com/office/drawing/2014/main" id="{2AF96408-9260-4C87-AB29-2B2C8FF3CE41}"/>
               </a:ext>
             </a:extLst>
           </p:cNvPr>
@@ -6070,7 +6141,7 @@
           <p:cNvPr id="13" name="">
             <a:extLst xmlns:a="http://schemas.openxmlformats.org/drawingml/2006/main">
               <a:ext uri="{FF2B5EF4-FFF2-40B4-BE49-F238E27FC236}">
-                <a16:creationId xmlns:a16="http://schemas.microsoft.com/office/drawing/2014/main" id="{75C85B03-B909-4799-A0D4-345F6ACED446}"/>
+                <a16:creationId xmlns:a16="http://schemas.microsoft.com/office/drawing/2014/main" id="{250835C2-3487-4A18-9C05-E606F4335A67}"/>
               </a:ext>
             </a:extLst>
           </p:cNvPr>
@@ -6120,7 +6191,7 @@
           <p:cNvPr id="14" name="">
             <a:extLst xmlns:a="http://schemas.openxmlformats.org/drawingml/2006/main">
               <a:ext uri="{FF2B5EF4-FFF2-40B4-BE49-F238E27FC236}">
-                <a16:creationId xmlns:a16="http://schemas.microsoft.com/office/drawing/2014/main" id="{E1DF5BE2-F3B7-4A71-A76F-451600B7CD90}"/>
+                <a16:creationId xmlns:a16="http://schemas.microsoft.com/office/drawing/2014/main" id="{B2F5A399-A2C0-4CCB-B23F-AA50BB41A658}"/>
               </a:ext>
             </a:extLst>
           </p:cNvPr>
@@ -6170,7 +6241,7 @@
           <p:cNvPr id="15" name="">
             <a:extLst xmlns:a="http://schemas.openxmlformats.org/drawingml/2006/main">
               <a:ext uri="{FF2B5EF4-FFF2-40B4-BE49-F238E27FC236}">
-                <a16:creationId xmlns:a16="http://schemas.microsoft.com/office/drawing/2014/main" id="{1805FF50-C67F-4069-BBCF-50373F1F8F29}"/>
+                <a16:creationId xmlns:a16="http://schemas.microsoft.com/office/drawing/2014/main" id="{5A592F7C-133C-440D-9EAB-AFB76B8CAE4F}"/>
               </a:ext>
             </a:extLst>
           </p:cNvPr>
@@ -6205,7 +6276,7 @@
           <p:cNvPr id="16" name="">
             <a:extLst xmlns:a="http://schemas.openxmlformats.org/drawingml/2006/main">
               <a:ext uri="{FF2B5EF4-FFF2-40B4-BE49-F238E27FC236}">
-                <a16:creationId xmlns:a16="http://schemas.microsoft.com/office/drawing/2014/main" id="{09F2B629-83E5-4859-89CC-FC03D76C6B1B}"/>
+                <a16:creationId xmlns:a16="http://schemas.microsoft.com/office/drawing/2014/main" id="{F83E2140-754A-471D-9109-C9C3510FCBEC}"/>
               </a:ext>
             </a:extLst>
           </p:cNvPr>
@@ -6255,7 +6326,7 @@
           <p:cNvPr id="17" name="">
             <a:extLst xmlns:a="http://schemas.openxmlformats.org/drawingml/2006/main">
               <a:ext uri="{FF2B5EF4-FFF2-40B4-BE49-F238E27FC236}">
-                <a16:creationId xmlns:a16="http://schemas.microsoft.com/office/drawing/2014/main" id="{A53BE7BA-C344-4372-BE9E-A73E4B96070D}"/>
+                <a16:creationId xmlns:a16="http://schemas.microsoft.com/office/drawing/2014/main" id="{E90526F8-4D6E-4516-9313-29127E10D635}"/>
               </a:ext>
             </a:extLst>
           </p:cNvPr>
@@ -6305,7 +6376,7 @@
           <p:cNvPr id="18" name="">
             <a:extLst xmlns:a="http://schemas.openxmlformats.org/drawingml/2006/main">
               <a:ext uri="{FF2B5EF4-FFF2-40B4-BE49-F238E27FC236}">
-                <a16:creationId xmlns:a16="http://schemas.microsoft.com/office/drawing/2014/main" id="{DC22458D-D078-4DC7-B54B-1DB11FB1EBC5}"/>
+                <a16:creationId xmlns:a16="http://schemas.microsoft.com/office/drawing/2014/main" id="{A8432F98-CD60-46AE-B95A-DDED505F06CC}"/>
               </a:ext>
             </a:extLst>
           </p:cNvPr>
@@ -6355,7 +6426,7 @@
           <p:cNvPr id="19" name="">
             <a:extLst xmlns:a="http://schemas.openxmlformats.org/drawingml/2006/main">
               <a:ext uri="{FF2B5EF4-FFF2-40B4-BE49-F238E27FC236}">
-                <a16:creationId xmlns:a16="http://schemas.microsoft.com/office/drawing/2014/main" id="{9A962DBD-AD9C-4D45-B4BF-4607C514BCE7}"/>
+                <a16:creationId xmlns:a16="http://schemas.microsoft.com/office/drawing/2014/main" id="{0108636D-7B35-4277-85BB-EDC12217B7BE}"/>
               </a:ext>
             </a:extLst>
           </p:cNvPr>
@@ -6390,7 +6461,7 @@
           <p:cNvPr id="20" name="">
             <a:extLst xmlns:a="http://schemas.openxmlformats.org/drawingml/2006/main">
               <a:ext uri="{FF2B5EF4-FFF2-40B4-BE49-F238E27FC236}">
-                <a16:creationId xmlns:a16="http://schemas.microsoft.com/office/drawing/2014/main" id="{D710F1D7-BFBE-443D-8098-8C78B8456CF7}"/>
+                <a16:creationId xmlns:a16="http://schemas.microsoft.com/office/drawing/2014/main" id="{61C83D6B-97BF-4C9D-B464-26580C151BCD}"/>
               </a:ext>
             </a:extLst>
           </p:cNvPr>
@@ -6440,7 +6511,7 @@
           <p:cNvPr id="21" name="">
             <a:extLst xmlns:a="http://schemas.openxmlformats.org/drawingml/2006/main">
               <a:ext uri="{FF2B5EF4-FFF2-40B4-BE49-F238E27FC236}">
-                <a16:creationId xmlns:a16="http://schemas.microsoft.com/office/drawing/2014/main" id="{DD9A7CAC-FCF8-4F56-82C0-76BF7DD071F3}"/>
+                <a16:creationId xmlns:a16="http://schemas.microsoft.com/office/drawing/2014/main" id="{373CBFEB-A251-4364-B8BC-386946049042}"/>
               </a:ext>
             </a:extLst>
           </p:cNvPr>
@@ -6490,7 +6561,7 @@
           <p:cNvPr id="22" name="">
             <a:extLst xmlns:a="http://schemas.openxmlformats.org/drawingml/2006/main">
               <a:ext uri="{FF2B5EF4-FFF2-40B4-BE49-F238E27FC236}">
-                <a16:creationId xmlns:a16="http://schemas.microsoft.com/office/drawing/2014/main" id="{0C119040-02C6-4C24-BD16-1A5E39362A48}"/>
+                <a16:creationId xmlns:a16="http://schemas.microsoft.com/office/drawing/2014/main" id="{68E7F391-AAD0-4AC5-9BD5-C5E846580889}"/>
               </a:ext>
             </a:extLst>
           </p:cNvPr>
@@ -6540,7 +6611,7 @@
           <p:cNvPr id="23" name="">
             <a:extLst xmlns:a="http://schemas.openxmlformats.org/drawingml/2006/main">
               <a:ext uri="{FF2B5EF4-FFF2-40B4-BE49-F238E27FC236}">
-                <a16:creationId xmlns:a16="http://schemas.microsoft.com/office/drawing/2014/main" id="{858180C9-C542-4BB9-B0A0-27A2AF199B5E}"/>
+                <a16:creationId xmlns:a16="http://schemas.microsoft.com/office/drawing/2014/main" id="{E1AC7685-32C0-48FF-85CA-31FCA078FCDB}"/>
               </a:ext>
             </a:extLst>
           </p:cNvPr>
@@ -6580,7 +6651,7 @@
                   <a:srgbClr val="173052"/>
                 </a:solidFill>
               </a:rPr>
-              <a:t>使用模拟消息，展示“收到收据 → 进入审核队列 → 管理员处理”的完整体验。</a:t>
+              <a:t>使用模拟消息，展示“收到收据 → 进入审核队列 → 管理员处理”的完整体验。当前为模拟接入，不发起任何真实 Meta API 调用。</a:t>
             </a:r>
           </a:p>
         </p:txBody>
@@ -6590,7 +6661,7 @@
           <p:cNvPr id="24" name="">
             <a:extLst xmlns:a="http://schemas.openxmlformats.org/drawingml/2006/main">
               <a:ext uri="{FF2B5EF4-FFF2-40B4-BE49-F238E27FC236}">
-                <a16:creationId xmlns:a16="http://schemas.microsoft.com/office/drawing/2014/main" id="{DC12A26C-0138-4788-8765-877D2362C6D5}"/>
+                <a16:creationId xmlns:a16="http://schemas.microsoft.com/office/drawing/2014/main" id="{920F7AE5-8DDC-4855-BDEB-247D2C2B9BA5}"/>
               </a:ext>
             </a:extLst>
           </p:cNvPr>
@@ -6640,7 +6711,7 @@
           <p:cNvPr id="25" name="">
             <a:extLst xmlns:a="http://schemas.openxmlformats.org/drawingml/2006/main">
               <a:ext uri="{FF2B5EF4-FFF2-40B4-BE49-F238E27FC236}">
-                <a16:creationId xmlns:a16="http://schemas.microsoft.com/office/drawing/2014/main" id="{8E50D781-DCD5-4D8A-BE3E-2CBE38E03A5D}"/>
+                <a16:creationId xmlns:a16="http://schemas.microsoft.com/office/drawing/2014/main" id="{881AA19C-ADD5-4958-B87F-3FDB3423BA85}"/>
               </a:ext>
             </a:extLst>
           </p:cNvPr>
@@ -6690,7 +6761,7 @@
           <p:cNvPr id="26" name="">
             <a:extLst xmlns:a="http://schemas.openxmlformats.org/drawingml/2006/main">
               <a:ext uri="{FF2B5EF4-FFF2-40B4-BE49-F238E27FC236}">
-                <a16:creationId xmlns:a16="http://schemas.microsoft.com/office/drawing/2014/main" id="{D5A910D5-9B4D-4CF7-A2B5-CD395F919DB5}"/>
+                <a16:creationId xmlns:a16="http://schemas.microsoft.com/office/drawing/2014/main" id="{6968AF33-5B8E-435B-B8C5-14BDD0FD4FA6}"/>
               </a:ext>
             </a:extLst>
           </p:cNvPr>
@@ -6740,7 +6811,7 @@
           <p:cNvPr id="27" name="">
             <a:extLst xmlns:a="http://schemas.openxmlformats.org/drawingml/2006/main">
               <a:ext uri="{FF2B5EF4-FFF2-40B4-BE49-F238E27FC236}">
-                <a16:creationId xmlns:a16="http://schemas.microsoft.com/office/drawing/2014/main" id="{70803C93-D41B-41D9-B93E-9ABF9AD0D2B4}"/>
+                <a16:creationId xmlns:a16="http://schemas.microsoft.com/office/drawing/2014/main" id="{E8D7FD6C-E32C-4897-BD3E-90F1C04A436C}"/>
               </a:ext>
             </a:extLst>
           </p:cNvPr>
@@ -6788,7 +6859,7 @@
     </p:spTree>
     <p:extLst>
       <p:ext uri="{BB962C8B-B14F-4D97-AF65-F5344CB8AC3E}">
-        <p14:creationId xmlns:p14="http://schemas.microsoft.com/office/powerpoint/2010/main" val="1560322563"/>
+        <p14:creationId xmlns:p14="http://schemas.microsoft.com/office/powerpoint/2010/main" val="910721277"/>
       </p:ext>
     </p:extLst>
   </p:cSld>
@@ -6819,7 +6890,7 @@
           <p:cNvPr id="18" name="">
             <a:extLst xmlns:a="http://schemas.openxmlformats.org/drawingml/2006/main">
               <a:ext uri="{FF2B5EF4-FFF2-40B4-BE49-F238E27FC236}">
-                <a16:creationId xmlns:a16="http://schemas.microsoft.com/office/drawing/2014/main" id="{2AD79ED6-4BFB-4D98-8447-3F3CB26E23D3}"/>
+                <a16:creationId xmlns:a16="http://schemas.microsoft.com/office/drawing/2014/main" id="{4F61310E-AD5B-4C19-B6E1-D79C360819D9}"/>
               </a:ext>
             </a:extLst>
           </p:cNvPr>
@@ -6869,7 +6940,7 @@
           <p:cNvPr id="2" name="">
             <a:extLst xmlns:a="http://schemas.openxmlformats.org/drawingml/2006/main">
               <a:ext uri="{FF2B5EF4-FFF2-40B4-BE49-F238E27FC236}">
-                <a16:creationId xmlns:a16="http://schemas.microsoft.com/office/drawing/2014/main" id="{1C758BF2-F6C5-454A-8710-D31825719585}"/>
+                <a16:creationId xmlns:a16="http://schemas.microsoft.com/office/drawing/2014/main" id="{E09C562A-DBDE-4C10-A804-F14947A8C5E8}"/>
               </a:ext>
             </a:extLst>
           </p:cNvPr>
@@ -6919,7 +6990,7 @@
           <p:cNvPr id="3" name="">
             <a:extLst xmlns:a="http://schemas.openxmlformats.org/drawingml/2006/main">
               <a:ext uri="{FF2B5EF4-FFF2-40B4-BE49-F238E27FC236}">
-                <a16:creationId xmlns:a16="http://schemas.microsoft.com/office/drawing/2014/main" id="{B1AF64A4-6B98-476B-A243-AFDE85E44991}"/>
+                <a16:creationId xmlns:a16="http://schemas.microsoft.com/office/drawing/2014/main" id="{3F6DEB7E-5B8C-43F8-8F67-25822D942135}"/>
               </a:ext>
             </a:extLst>
           </p:cNvPr>
@@ -6954,7 +7025,7 @@
           <p:cNvPr id="4" name="">
             <a:extLst xmlns:a="http://schemas.openxmlformats.org/drawingml/2006/main">
               <a:ext uri="{FF2B5EF4-FFF2-40B4-BE49-F238E27FC236}">
-                <a16:creationId xmlns:a16="http://schemas.microsoft.com/office/drawing/2014/main" id="{3FEDB217-6E98-412A-BF10-954BAE54950F}"/>
+                <a16:creationId xmlns:a16="http://schemas.microsoft.com/office/drawing/2014/main" id="{FF0ABA05-81EE-40B9-9466-5EB231544291}"/>
               </a:ext>
             </a:extLst>
           </p:cNvPr>
@@ -7004,7 +7075,7 @@
           <p:cNvPr id="5" name="">
             <a:extLst xmlns:a="http://schemas.openxmlformats.org/drawingml/2006/main">
               <a:ext uri="{FF2B5EF4-FFF2-40B4-BE49-F238E27FC236}">
-                <a16:creationId xmlns:a16="http://schemas.microsoft.com/office/drawing/2014/main" id="{47685E47-329A-4794-9EE1-6F151E6AAB32}"/>
+                <a16:creationId xmlns:a16="http://schemas.microsoft.com/office/drawing/2014/main" id="{9CC327FD-E7AC-46ED-BBDB-44B9C2AE01C3}"/>
               </a:ext>
             </a:extLst>
           </p:cNvPr>
@@ -7054,7 +7125,7 @@
           <p:cNvPr id="6" name="">
             <a:extLst xmlns:a="http://schemas.openxmlformats.org/drawingml/2006/main">
               <a:ext uri="{FF2B5EF4-FFF2-40B4-BE49-F238E27FC236}">
-                <a16:creationId xmlns:a16="http://schemas.microsoft.com/office/drawing/2014/main" id="{827233CF-AACE-42CC-81B0-0467E9E697FE}"/>
+                <a16:creationId xmlns:a16="http://schemas.microsoft.com/office/drawing/2014/main" id="{DE20D2D8-FA9E-4C40-B586-37467DE819C4}"/>
               </a:ext>
             </a:extLst>
           </p:cNvPr>
@@ -7089,7 +7160,7 @@
           <p:cNvPr id="7" name="">
             <a:extLst xmlns:a="http://schemas.openxmlformats.org/drawingml/2006/main">
               <a:ext uri="{FF2B5EF4-FFF2-40B4-BE49-F238E27FC236}">
-                <a16:creationId xmlns:a16="http://schemas.microsoft.com/office/drawing/2014/main" id="{76BC669F-AFD1-4205-8FB0-9232D1C516A1}"/>
+                <a16:creationId xmlns:a16="http://schemas.microsoft.com/office/drawing/2014/main" id="{DD285E9E-7E1B-423B-BF3D-0AD5882D0008}"/>
               </a:ext>
             </a:extLst>
           </p:cNvPr>
@@ -7139,7 +7210,7 @@
           <p:cNvPr id="8" name="">
             <a:extLst xmlns:a="http://schemas.openxmlformats.org/drawingml/2006/main">
               <a:ext uri="{FF2B5EF4-FFF2-40B4-BE49-F238E27FC236}">
-                <a16:creationId xmlns:a16="http://schemas.microsoft.com/office/drawing/2014/main" id="{BF68EEC8-9B87-4223-92BC-275D5B77B3B6}"/>
+                <a16:creationId xmlns:a16="http://schemas.microsoft.com/office/drawing/2014/main" id="{970CC202-D097-4A34-BAD1-8147C0C023E0}"/>
               </a:ext>
             </a:extLst>
           </p:cNvPr>
@@ -7189,7 +7260,7 @@
           <p:cNvPr id="9" name="">
             <a:extLst xmlns:a="http://schemas.openxmlformats.org/drawingml/2006/main">
               <a:ext uri="{FF2B5EF4-FFF2-40B4-BE49-F238E27FC236}">
-                <a16:creationId xmlns:a16="http://schemas.microsoft.com/office/drawing/2014/main" id="{9E2BD26C-44DC-4364-8F39-2696A0FBBD7E}"/>
+                <a16:creationId xmlns:a16="http://schemas.microsoft.com/office/drawing/2014/main" id="{C758C3F1-47F7-4006-8D89-554EAE441968}"/>
               </a:ext>
             </a:extLst>
           </p:cNvPr>
@@ -7224,7 +7295,7 @@
           <p:cNvPr id="10" name="">
             <a:extLst xmlns:a="http://schemas.openxmlformats.org/drawingml/2006/main">
               <a:ext uri="{FF2B5EF4-FFF2-40B4-BE49-F238E27FC236}">
-                <a16:creationId xmlns:a16="http://schemas.microsoft.com/office/drawing/2014/main" id="{0013EA66-FB81-4C81-A757-AF7B0EF243EE}"/>
+                <a16:creationId xmlns:a16="http://schemas.microsoft.com/office/drawing/2014/main" id="{E581247F-1A19-4028-BDC9-9CF404AE269C}"/>
               </a:ext>
             </a:extLst>
           </p:cNvPr>
@@ -7274,7 +7345,7 @@
           <p:cNvPr id="11" name="">
             <a:extLst xmlns:a="http://schemas.openxmlformats.org/drawingml/2006/main">
               <a:ext uri="{FF2B5EF4-FFF2-40B4-BE49-F238E27FC236}">
-                <a16:creationId xmlns:a16="http://schemas.microsoft.com/office/drawing/2014/main" id="{BCA48294-F1AA-4EC3-BAA2-9F2485162828}"/>
+                <a16:creationId xmlns:a16="http://schemas.microsoft.com/office/drawing/2014/main" id="{1FF4CF33-BB59-4C64-A5F9-908E95249849}"/>
               </a:ext>
             </a:extLst>
           </p:cNvPr>
@@ -7324,7 +7395,7 @@
           <p:cNvPr id="12" name="">
             <a:extLst xmlns:a="http://schemas.openxmlformats.org/drawingml/2006/main">
               <a:ext uri="{FF2B5EF4-FFF2-40B4-BE49-F238E27FC236}">
-                <a16:creationId xmlns:a16="http://schemas.microsoft.com/office/drawing/2014/main" id="{72794626-DF46-4497-A039-0A566444955B}"/>
+                <a16:creationId xmlns:a16="http://schemas.microsoft.com/office/drawing/2014/main" id="{677B0CA9-0680-4100-9414-545C2DFEE9F6}"/>
               </a:ext>
             </a:extLst>
           </p:cNvPr>
@@ -7359,7 +7430,7 @@
           <p:cNvPr id="13" name="">
             <a:extLst xmlns:a="http://schemas.openxmlformats.org/drawingml/2006/main">
               <a:ext uri="{FF2B5EF4-FFF2-40B4-BE49-F238E27FC236}">
-                <a16:creationId xmlns:a16="http://schemas.microsoft.com/office/drawing/2014/main" id="{9CFF6E11-A610-4C11-BABE-C03C742AC3E3}"/>
+                <a16:creationId xmlns:a16="http://schemas.microsoft.com/office/drawing/2014/main" id="{91B6F43F-2B64-4526-980F-FC9FCE8483C1}"/>
               </a:ext>
             </a:extLst>
           </p:cNvPr>
@@ -7409,7 +7480,7 @@
           <p:cNvPr id="14" name="">
             <a:extLst xmlns:a="http://schemas.openxmlformats.org/drawingml/2006/main">
               <a:ext uri="{FF2B5EF4-FFF2-40B4-BE49-F238E27FC236}">
-                <a16:creationId xmlns:a16="http://schemas.microsoft.com/office/drawing/2014/main" id="{EE9CAB56-8F93-4969-A98B-4B03ACD5BC27}"/>
+                <a16:creationId xmlns:a16="http://schemas.microsoft.com/office/drawing/2014/main" id="{CB31994E-9452-4B5A-AB57-7747FA396572}"/>
               </a:ext>
             </a:extLst>
           </p:cNvPr>
@@ -7459,7 +7530,7 @@
           <p:cNvPr id="15" name="">
             <a:extLst xmlns:a="http://schemas.openxmlformats.org/drawingml/2006/main">
               <a:ext uri="{FF2B5EF4-FFF2-40B4-BE49-F238E27FC236}">
-                <a16:creationId xmlns:a16="http://schemas.microsoft.com/office/drawing/2014/main" id="{78AE30D4-3EFE-4603-AEFF-070060D0CC7F}"/>
+                <a16:creationId xmlns:a16="http://schemas.microsoft.com/office/drawing/2014/main" id="{15C3B7D1-044E-417E-972F-0F3364C53200}"/>
               </a:ext>
             </a:extLst>
           </p:cNvPr>
@@ -7509,7 +7580,7 @@
           <p:cNvPr id="16" name="">
             <a:extLst xmlns:a="http://schemas.openxmlformats.org/drawingml/2006/main">
               <a:ext uri="{FF2B5EF4-FFF2-40B4-BE49-F238E27FC236}">
-                <a16:creationId xmlns:a16="http://schemas.microsoft.com/office/drawing/2014/main" id="{7C5C2452-1EFB-4950-9E69-55ADD5972030}"/>
+                <a16:creationId xmlns:a16="http://schemas.microsoft.com/office/drawing/2014/main" id="{9D5DE373-67DA-4952-9425-CC88CEEEDF55}"/>
               </a:ext>
             </a:extLst>
           </p:cNvPr>
@@ -7559,7 +7630,7 @@
           <p:cNvPr id="17" name="">
             <a:extLst xmlns:a="http://schemas.openxmlformats.org/drawingml/2006/main">
               <a:ext uri="{FF2B5EF4-FFF2-40B4-BE49-F238E27FC236}">
-                <a16:creationId xmlns:a16="http://schemas.microsoft.com/office/drawing/2014/main" id="{BBECC69B-D613-4006-B84D-18ADAB00702F}"/>
+                <a16:creationId xmlns:a16="http://schemas.microsoft.com/office/drawing/2014/main" id="{E432A2AA-514D-461C-AF3E-B8D19B8506FB}"/>
               </a:ext>
             </a:extLst>
           </p:cNvPr>
@@ -7607,7 +7678,7 @@
     </p:spTree>
     <p:extLst>
       <p:ext uri="{BB962C8B-B14F-4D97-AF65-F5344CB8AC3E}">
-        <p14:creationId xmlns:p14="http://schemas.microsoft.com/office/powerpoint/2010/main" val="955810501"/>
+        <p14:creationId xmlns:p14="http://schemas.microsoft.com/office/powerpoint/2010/main" val="276326649"/>
       </p:ext>
     </p:extLst>
   </p:cSld>
@@ -7638,7 +7709,7 @@
           <p:cNvPr id="10" name="">
             <a:extLst xmlns:a="http://schemas.openxmlformats.org/drawingml/2006/main">
               <a:ext uri="{FF2B5EF4-FFF2-40B4-BE49-F238E27FC236}">
-                <a16:creationId xmlns:a16="http://schemas.microsoft.com/office/drawing/2014/main" id="{10C2BC6D-44E4-4518-881E-DF709EE9C5C0}"/>
+                <a16:creationId xmlns:a16="http://schemas.microsoft.com/office/drawing/2014/main" id="{0443E3CB-6172-46DF-8CC9-BD096F7B5C0A}"/>
               </a:ext>
             </a:extLst>
           </p:cNvPr>
@@ -7688,7 +7759,7 @@
           <p:cNvPr id="2" name="">
             <a:extLst xmlns:a="http://schemas.openxmlformats.org/drawingml/2006/main">
               <a:ext uri="{FF2B5EF4-FFF2-40B4-BE49-F238E27FC236}">
-                <a16:creationId xmlns:a16="http://schemas.microsoft.com/office/drawing/2014/main" id="{68E7E485-8D88-42CB-9601-4A5C09F6E4EE}"/>
+                <a16:creationId xmlns:a16="http://schemas.microsoft.com/office/drawing/2014/main" id="{DA1C679F-83AA-4B7E-938F-42D59116B15B}"/>
               </a:ext>
             </a:extLst>
           </p:cNvPr>
@@ -7738,7 +7809,7 @@
           <p:cNvPr id="3" name="">
             <a:extLst xmlns:a="http://schemas.openxmlformats.org/drawingml/2006/main">
               <a:ext uri="{FF2B5EF4-FFF2-40B4-BE49-F238E27FC236}">
-                <a16:creationId xmlns:a16="http://schemas.microsoft.com/office/drawing/2014/main" id="{B99B8DE5-D775-4D07-A8C9-9794C630FD76}"/>
+                <a16:creationId xmlns:a16="http://schemas.microsoft.com/office/drawing/2014/main" id="{5439B482-3B21-4A16-ACF1-C09CC185FE3A}"/>
               </a:ext>
             </a:extLst>
           </p:cNvPr>
@@ -7788,7 +7859,7 @@
           <p:cNvPr id="4" name="">
             <a:extLst xmlns:a="http://schemas.openxmlformats.org/drawingml/2006/main">
               <a:ext uri="{FF2B5EF4-FFF2-40B4-BE49-F238E27FC236}">
-                <a16:creationId xmlns:a16="http://schemas.microsoft.com/office/drawing/2014/main" id="{69618B6A-EDE8-4261-9F61-5595C913D912}"/>
+                <a16:creationId xmlns:a16="http://schemas.microsoft.com/office/drawing/2014/main" id="{DC426544-0D2A-4FAE-A727-C591B49EEE09}"/>
               </a:ext>
             </a:extLst>
           </p:cNvPr>
@@ -7889,7 +7960,7 @@
           <p:cNvPr id="5" name="">
             <a:extLst xmlns:a="http://schemas.openxmlformats.org/drawingml/2006/main">
               <a:ext uri="{FF2B5EF4-FFF2-40B4-BE49-F238E27FC236}">
-                <a16:creationId xmlns:a16="http://schemas.microsoft.com/office/drawing/2014/main" id="{F2532C91-C0A7-488E-ACD8-028474048811}"/>
+                <a16:creationId xmlns:a16="http://schemas.microsoft.com/office/drawing/2014/main" id="{FC7D16C9-E723-454D-87D1-1F2A9125D1A5}"/>
               </a:ext>
             </a:extLst>
           </p:cNvPr>
@@ -7939,7 +8010,7 @@
           <p:cNvPr id="6" name="">
             <a:extLst xmlns:a="http://schemas.openxmlformats.org/drawingml/2006/main">
               <a:ext uri="{FF2B5EF4-FFF2-40B4-BE49-F238E27FC236}">
-                <a16:creationId xmlns:a16="http://schemas.microsoft.com/office/drawing/2014/main" id="{FFE53A38-74E6-4E57-ABB2-AFC0D3C90CB8}"/>
+                <a16:creationId xmlns:a16="http://schemas.microsoft.com/office/drawing/2014/main" id="{1B7F7785-CC1D-42CE-B0FE-BC661963B021}"/>
               </a:ext>
             </a:extLst>
           </p:cNvPr>
@@ -8040,7 +8111,7 @@
           <p:cNvPr id="7" name="">
             <a:extLst xmlns:a="http://schemas.openxmlformats.org/drawingml/2006/main">
               <a:ext uri="{FF2B5EF4-FFF2-40B4-BE49-F238E27FC236}">
-                <a16:creationId xmlns:a16="http://schemas.microsoft.com/office/drawing/2014/main" id="{E45E89AB-C1D0-423F-AB78-718E6B3424F7}"/>
+                <a16:creationId xmlns:a16="http://schemas.microsoft.com/office/drawing/2014/main" id="{F23B8206-E748-4A2F-A699-17DC3B70572C}"/>
               </a:ext>
             </a:extLst>
           </p:cNvPr>
@@ -8090,7 +8161,7 @@
           <p:cNvPr id="8" name="">
             <a:extLst xmlns:a="http://schemas.openxmlformats.org/drawingml/2006/main">
               <a:ext uri="{FF2B5EF4-FFF2-40B4-BE49-F238E27FC236}">
-                <a16:creationId xmlns:a16="http://schemas.microsoft.com/office/drawing/2014/main" id="{A7C6308F-5F36-443C-9AE3-527EC11D3BAF}"/>
+                <a16:creationId xmlns:a16="http://schemas.microsoft.com/office/drawing/2014/main" id="{E5273C18-F5E6-4855-8654-1C35D2D85F58}"/>
               </a:ext>
             </a:extLst>
           </p:cNvPr>
@@ -8140,7 +8211,7 @@
           <p:cNvPr id="9" name="">
             <a:extLst xmlns:a="http://schemas.openxmlformats.org/drawingml/2006/main">
               <a:ext uri="{FF2B5EF4-FFF2-40B4-BE49-F238E27FC236}">
-                <a16:creationId xmlns:a16="http://schemas.microsoft.com/office/drawing/2014/main" id="{75AC2838-C8E0-473A-8718-70288C177470}"/>
+                <a16:creationId xmlns:a16="http://schemas.microsoft.com/office/drawing/2014/main" id="{098F1615-0A0F-4178-ABA3-1A15840FD33E}"/>
               </a:ext>
             </a:extLst>
           </p:cNvPr>
@@ -8188,7 +8259,7 @@
     </p:spTree>
     <p:extLst>
       <p:ext uri="{BB962C8B-B14F-4D97-AF65-F5344CB8AC3E}">
-        <p14:creationId xmlns:p14="http://schemas.microsoft.com/office/powerpoint/2010/main" val="488185585"/>
+        <p14:creationId xmlns:p14="http://schemas.microsoft.com/office/powerpoint/2010/main" val="790183441"/>
       </p:ext>
     </p:extLst>
   </p:cSld>
@@ -8219,7 +8290,7 @@
           <p:cNvPr id="20" name="">
             <a:extLst xmlns:a="http://schemas.openxmlformats.org/drawingml/2006/main">
               <a:ext uri="{FF2B5EF4-FFF2-40B4-BE49-F238E27FC236}">
-                <a16:creationId xmlns:a16="http://schemas.microsoft.com/office/drawing/2014/main" id="{F07FF5E1-1026-41B5-B76B-D7A5EF9596E6}"/>
+                <a16:creationId xmlns:a16="http://schemas.microsoft.com/office/drawing/2014/main" id="{7C4C8A5C-945D-4EE6-9DBA-10E7A5044C0B}"/>
               </a:ext>
             </a:extLst>
           </p:cNvPr>
@@ -8269,7 +8340,7 @@
           <p:cNvPr id="2" name="">
             <a:extLst xmlns:a="http://schemas.openxmlformats.org/drawingml/2006/main">
               <a:ext uri="{FF2B5EF4-FFF2-40B4-BE49-F238E27FC236}">
-                <a16:creationId xmlns:a16="http://schemas.microsoft.com/office/drawing/2014/main" id="{2374374F-C3C0-415F-BC76-1466E957CE3A}"/>
+                <a16:creationId xmlns:a16="http://schemas.microsoft.com/office/drawing/2014/main" id="{A00AE424-3CA2-4AEE-84F7-047D2E073B89}"/>
               </a:ext>
             </a:extLst>
           </p:cNvPr>
@@ -8319,7 +8390,7 @@
           <p:cNvPr id="3" name="">
             <a:extLst xmlns:a="http://schemas.openxmlformats.org/drawingml/2006/main">
               <a:ext uri="{FF2B5EF4-FFF2-40B4-BE49-F238E27FC236}">
-                <a16:creationId xmlns:a16="http://schemas.microsoft.com/office/drawing/2014/main" id="{DABECA72-D8F1-4BE2-9946-AC43E7DE53D5}"/>
+                <a16:creationId xmlns:a16="http://schemas.microsoft.com/office/drawing/2014/main" id="{832C0757-4659-4533-AA33-D0FAFE83370F}"/>
               </a:ext>
             </a:extLst>
           </p:cNvPr>
@@ -8369,7 +8440,7 @@
           <p:cNvPr id="4" name="">
             <a:extLst xmlns:a="http://schemas.openxmlformats.org/drawingml/2006/main">
               <a:ext uri="{FF2B5EF4-FFF2-40B4-BE49-F238E27FC236}">
-                <a16:creationId xmlns:a16="http://schemas.microsoft.com/office/drawing/2014/main" id="{779B39A0-0BE2-448D-9C5E-ACF615C2D69B}"/>
+                <a16:creationId xmlns:a16="http://schemas.microsoft.com/office/drawing/2014/main" id="{1308BCDB-BE40-4A5E-A209-B2DCD426D8D4}"/>
               </a:ext>
             </a:extLst>
           </p:cNvPr>
@@ -8419,7 +8490,7 @@
           <p:cNvPr id="5" name="">
             <a:extLst xmlns:a="http://schemas.openxmlformats.org/drawingml/2006/main">
               <a:ext uri="{FF2B5EF4-FFF2-40B4-BE49-F238E27FC236}">
-                <a16:creationId xmlns:a16="http://schemas.microsoft.com/office/drawing/2014/main" id="{13D9541C-3A84-4F9E-82E4-23E14FD35FD8}"/>
+                <a16:creationId xmlns:a16="http://schemas.microsoft.com/office/drawing/2014/main" id="{50924744-515A-4919-923D-18B527881BFB}"/>
               </a:ext>
             </a:extLst>
           </p:cNvPr>
@@ -8450,7 +8521,7 @@
           <p:cNvPr id="6" name="">
             <a:extLst xmlns:a="http://schemas.openxmlformats.org/drawingml/2006/main">
               <a:ext uri="{FF2B5EF4-FFF2-40B4-BE49-F238E27FC236}">
-                <a16:creationId xmlns:a16="http://schemas.microsoft.com/office/drawing/2014/main" id="{D8F2B644-FBDB-408B-81C8-FC28E13C6533}"/>
+                <a16:creationId xmlns:a16="http://schemas.microsoft.com/office/drawing/2014/main" id="{7A5B1F7F-4E8B-401D-87C0-5256D223ECA8}"/>
               </a:ext>
             </a:extLst>
           </p:cNvPr>
@@ -8500,7 +8571,7 @@
           <p:cNvPr id="7" name="">
             <a:extLst xmlns:a="http://schemas.openxmlformats.org/drawingml/2006/main">
               <a:ext uri="{FF2B5EF4-FFF2-40B4-BE49-F238E27FC236}">
-                <a16:creationId xmlns:a16="http://schemas.microsoft.com/office/drawing/2014/main" id="{D8EAE47F-D621-4261-A8F6-8E998F88DC4C}"/>
+                <a16:creationId xmlns:a16="http://schemas.microsoft.com/office/drawing/2014/main" id="{834B46C7-94CD-443D-AA91-AE1EB992F3F0}"/>
               </a:ext>
             </a:extLst>
           </p:cNvPr>
@@ -8550,7 +8621,7 @@
           <p:cNvPr id="8" name="">
             <a:extLst xmlns:a="http://schemas.openxmlformats.org/drawingml/2006/main">
               <a:ext uri="{FF2B5EF4-FFF2-40B4-BE49-F238E27FC236}">
-                <a16:creationId xmlns:a16="http://schemas.microsoft.com/office/drawing/2014/main" id="{1632EC36-93A5-4FA7-AFF2-8C7A500AFFF6}"/>
+                <a16:creationId xmlns:a16="http://schemas.microsoft.com/office/drawing/2014/main" id="{16F1C19D-DB79-4762-9468-208E729B2D1E}"/>
               </a:ext>
             </a:extLst>
           </p:cNvPr>
@@ -8581,7 +8652,7 @@
           <p:cNvPr id="9" name="">
             <a:extLst xmlns:a="http://schemas.openxmlformats.org/drawingml/2006/main">
               <a:ext uri="{FF2B5EF4-FFF2-40B4-BE49-F238E27FC236}">
-                <a16:creationId xmlns:a16="http://schemas.microsoft.com/office/drawing/2014/main" id="{1292C52D-0051-4C19-B0A3-D8ABBCC541FE}"/>
+                <a16:creationId xmlns:a16="http://schemas.microsoft.com/office/drawing/2014/main" id="{4865C0D2-E757-493C-B8A8-ADD2D5E2F979}"/>
               </a:ext>
             </a:extLst>
           </p:cNvPr>
@@ -8631,7 +8702,7 @@
           <p:cNvPr id="10" name="">
             <a:extLst xmlns:a="http://schemas.openxmlformats.org/drawingml/2006/main">
               <a:ext uri="{FF2B5EF4-FFF2-40B4-BE49-F238E27FC236}">
-                <a16:creationId xmlns:a16="http://schemas.microsoft.com/office/drawing/2014/main" id="{83EBEBF1-50A6-4202-980A-7F74EA8B552C}"/>
+                <a16:creationId xmlns:a16="http://schemas.microsoft.com/office/drawing/2014/main" id="{320D69C8-6F98-4751-80AA-F225BF6DBBD8}"/>
               </a:ext>
             </a:extLst>
           </p:cNvPr>
@@ -8681,7 +8752,7 @@
           <p:cNvPr id="11" name="">
             <a:extLst xmlns:a="http://schemas.openxmlformats.org/drawingml/2006/main">
               <a:ext uri="{FF2B5EF4-FFF2-40B4-BE49-F238E27FC236}">
-                <a16:creationId xmlns:a16="http://schemas.microsoft.com/office/drawing/2014/main" id="{5AA09A7F-E4DD-4028-A504-F1FD2680EBCA}"/>
+                <a16:creationId xmlns:a16="http://schemas.microsoft.com/office/drawing/2014/main" id="{72041361-36FA-41EA-97E5-2256331EB825}"/>
               </a:ext>
             </a:extLst>
           </p:cNvPr>
@@ -8712,7 +8783,7 @@
           <p:cNvPr id="12" name="">
             <a:extLst xmlns:a="http://schemas.openxmlformats.org/drawingml/2006/main">
               <a:ext uri="{FF2B5EF4-FFF2-40B4-BE49-F238E27FC236}">
-                <a16:creationId xmlns:a16="http://schemas.microsoft.com/office/drawing/2014/main" id="{913410E1-82D8-48B2-A8A2-98B992D41ED6}"/>
+                <a16:creationId xmlns:a16="http://schemas.microsoft.com/office/drawing/2014/main" id="{0E08FE55-96F0-4B37-8B90-7ADDD5C9CE15}"/>
               </a:ext>
             </a:extLst>
           </p:cNvPr>
@@ -8762,7 +8833,7 @@
           <p:cNvPr id="13" name="">
             <a:extLst xmlns:a="http://schemas.openxmlformats.org/drawingml/2006/main">
               <a:ext uri="{FF2B5EF4-FFF2-40B4-BE49-F238E27FC236}">
-                <a16:creationId xmlns:a16="http://schemas.microsoft.com/office/drawing/2014/main" id="{E94958EA-B90F-405D-8A9B-3F535DEE0612}"/>
+                <a16:creationId xmlns:a16="http://schemas.microsoft.com/office/drawing/2014/main" id="{D3070359-8C4E-4EB7-A949-D33ECC07CAB6}"/>
               </a:ext>
             </a:extLst>
           </p:cNvPr>
@@ -8812,7 +8883,7 @@
           <p:cNvPr id="14" name="">
             <a:extLst xmlns:a="http://schemas.openxmlformats.org/drawingml/2006/main">
               <a:ext uri="{FF2B5EF4-FFF2-40B4-BE49-F238E27FC236}">
-                <a16:creationId xmlns:a16="http://schemas.microsoft.com/office/drawing/2014/main" id="{6202D51E-B9BA-4617-9ED7-4A05A5393ECD}"/>
+                <a16:creationId xmlns:a16="http://schemas.microsoft.com/office/drawing/2014/main" id="{B5D7B49A-9F8E-4056-8E67-DC913E663557}"/>
               </a:ext>
             </a:extLst>
           </p:cNvPr>
@@ -8843,7 +8914,7 @@
           <p:cNvPr id="15" name="">
             <a:extLst xmlns:a="http://schemas.openxmlformats.org/drawingml/2006/main">
               <a:ext uri="{FF2B5EF4-FFF2-40B4-BE49-F238E27FC236}">
-                <a16:creationId xmlns:a16="http://schemas.microsoft.com/office/drawing/2014/main" id="{8CE6D2BB-C3D5-461C-9C2A-2AB3C8754D0D}"/>
+                <a16:creationId xmlns:a16="http://schemas.microsoft.com/office/drawing/2014/main" id="{D690749A-B705-4897-8858-AFA956A47FEF}"/>
               </a:ext>
             </a:extLst>
           </p:cNvPr>
@@ -8893,7 +8964,7 @@
           <p:cNvPr id="16" name="">
             <a:extLst xmlns:a="http://schemas.openxmlformats.org/drawingml/2006/main">
               <a:ext uri="{FF2B5EF4-FFF2-40B4-BE49-F238E27FC236}">
-                <a16:creationId xmlns:a16="http://schemas.microsoft.com/office/drawing/2014/main" id="{023B24B5-CCE5-4D44-90D4-672D80AFBDAD}"/>
+                <a16:creationId xmlns:a16="http://schemas.microsoft.com/office/drawing/2014/main" id="{047AF4BD-51DF-4150-A2E7-EC3E2023787F}"/>
               </a:ext>
             </a:extLst>
           </p:cNvPr>
@@ -8943,7 +9014,7 @@
           <p:cNvPr id="17" name="">
             <a:extLst xmlns:a="http://schemas.openxmlformats.org/drawingml/2006/main">
               <a:ext uri="{FF2B5EF4-FFF2-40B4-BE49-F238E27FC236}">
-                <a16:creationId xmlns:a16="http://schemas.microsoft.com/office/drawing/2014/main" id="{6B9B0EE1-272C-4353-B0AE-78A726A45BBA}"/>
+                <a16:creationId xmlns:a16="http://schemas.microsoft.com/office/drawing/2014/main" id="{824934EB-23A0-4079-988F-FAE9692CE700}"/>
               </a:ext>
             </a:extLst>
           </p:cNvPr>
@@ -8974,7 +9045,7 @@
           <p:cNvPr id="18" name="">
             <a:extLst xmlns:a="http://schemas.openxmlformats.org/drawingml/2006/main">
               <a:ext uri="{FF2B5EF4-FFF2-40B4-BE49-F238E27FC236}">
-                <a16:creationId xmlns:a16="http://schemas.microsoft.com/office/drawing/2014/main" id="{F8F37C78-B238-4741-8653-E21FABE1BF87}"/>
+                <a16:creationId xmlns:a16="http://schemas.microsoft.com/office/drawing/2014/main" id="{1C3297FC-B470-4196-B65C-74AC303C4805}"/>
               </a:ext>
             </a:extLst>
           </p:cNvPr>
@@ -9024,7 +9095,7 @@
           <p:cNvPr id="19" name="">
             <a:extLst xmlns:a="http://schemas.openxmlformats.org/drawingml/2006/main">
               <a:ext uri="{FF2B5EF4-FFF2-40B4-BE49-F238E27FC236}">
-                <a16:creationId xmlns:a16="http://schemas.microsoft.com/office/drawing/2014/main" id="{004B84BD-CF62-4AF6-9C74-5D0019C5A3BC}"/>
+                <a16:creationId xmlns:a16="http://schemas.microsoft.com/office/drawing/2014/main" id="{CBD7D69D-D058-4EB3-81F9-EABA8234866C}"/>
               </a:ext>
             </a:extLst>
           </p:cNvPr>
@@ -9072,7 +9143,7 @@
     </p:spTree>
     <p:extLst>
       <p:ext uri="{BB962C8B-B14F-4D97-AF65-F5344CB8AC3E}">
-        <p14:creationId xmlns:p14="http://schemas.microsoft.com/office/powerpoint/2010/main" val="409368433"/>
+        <p14:creationId xmlns:p14="http://schemas.microsoft.com/office/powerpoint/2010/main" val="464489222"/>
       </p:ext>
     </p:extLst>
   </p:cSld>
@@ -9100,10 +9171,10 @@
       </p:grpSpPr>
       <p:sp>
         <p:nvSpPr>
-          <p:cNvPr id="26" name="">
-            <a:extLst xmlns:a="http://schemas.openxmlformats.org/drawingml/2006/main">
-              <a:ext uri="{FF2B5EF4-FFF2-40B4-BE49-F238E27FC236}">
-                <a16:creationId xmlns:a16="http://schemas.microsoft.com/office/drawing/2014/main" id="{2F3900EF-9BA2-4296-86C0-2F1A356FE16D}"/>
+          <p:cNvPr id="30" name="">
+            <a:extLst xmlns:a="http://schemas.openxmlformats.org/drawingml/2006/main">
+              <a:ext uri="{FF2B5EF4-FFF2-40B4-BE49-F238E27FC236}">
+                <a16:creationId xmlns:a16="http://schemas.microsoft.com/office/drawing/2014/main" id="{80B42C06-B752-4F83-8F22-F7CCD25A1A25}"/>
               </a:ext>
             </a:extLst>
           </p:cNvPr>
@@ -9153,7 +9224,7 @@
           <p:cNvPr id="2" name="">
             <a:extLst xmlns:a="http://schemas.openxmlformats.org/drawingml/2006/main">
               <a:ext uri="{FF2B5EF4-FFF2-40B4-BE49-F238E27FC236}">
-                <a16:creationId xmlns:a16="http://schemas.microsoft.com/office/drawing/2014/main" id="{4EE9663C-9DED-48BB-802A-3E70E37C1E22}"/>
+                <a16:creationId xmlns:a16="http://schemas.microsoft.com/office/drawing/2014/main" id="{EB86DE1F-B5E6-489D-9A80-7DFB5AEF9C13}"/>
               </a:ext>
             </a:extLst>
           </p:cNvPr>
@@ -9203,18 +9274,18 @@
           <p:cNvPr id="3" name="">
             <a:extLst xmlns:a="http://schemas.openxmlformats.org/drawingml/2006/main">
               <a:ext uri="{FF2B5EF4-FFF2-40B4-BE49-F238E27FC236}">
-                <a16:creationId xmlns:a16="http://schemas.microsoft.com/office/drawing/2014/main" id="{43876620-8E0F-4450-AD92-7F7611AE5110}"/>
-              </a:ext>
-            </a:extLst>
-          </p:cNvPr>
-          <p:cNvSpPr>
-            <a:spLocks xmlns:a="http://schemas.openxmlformats.org/drawingml/2006/main" noGrp="1"/>
-          </p:cNvSpPr>
-          <p:nvPr/>
-        </p:nvSpPr>
-        <p:spPr>
-          <a:xfrm xmlns:a="http://schemas.openxmlformats.org/drawingml/2006/main">
-            <a:off x="781050" y="1809750"/>
+                <a16:creationId xmlns:a16="http://schemas.microsoft.com/office/drawing/2014/main" id="{9D5729B8-6B16-4809-ABD6-65E0EEA697AF}"/>
+              </a:ext>
+            </a:extLst>
+          </p:cNvPr>
+          <p:cNvSpPr>
+            <a:spLocks xmlns:a="http://schemas.openxmlformats.org/drawingml/2006/main" noGrp="1"/>
+          </p:cNvSpPr>
+          <p:nvPr/>
+        </p:nvSpPr>
+        <p:spPr>
+          <a:xfrm xmlns:a="http://schemas.openxmlformats.org/drawingml/2006/main">
+            <a:off x="781050" y="1714500"/>
             <a:ext cx="438150" cy="361950"/>
           </a:xfrm>
           <a:prstGeom xmlns:a="http://schemas.openxmlformats.org/drawingml/2006/main" prst="roundRect">
@@ -9236,18 +9307,18 @@
           <p:cNvPr id="4" name="">
             <a:extLst xmlns:a="http://schemas.openxmlformats.org/drawingml/2006/main">
               <a:ext uri="{FF2B5EF4-FFF2-40B4-BE49-F238E27FC236}">
-                <a16:creationId xmlns:a16="http://schemas.microsoft.com/office/drawing/2014/main" id="{21F2E8B7-0D0B-4C2D-B932-3F65473DC397}"/>
-              </a:ext>
-            </a:extLst>
-          </p:cNvPr>
-          <p:cNvSpPr>
-            <a:spLocks xmlns:a="http://schemas.openxmlformats.org/drawingml/2006/main" noGrp="1"/>
-          </p:cNvSpPr>
-          <p:nvPr/>
-        </p:nvSpPr>
-        <p:spPr>
-          <a:xfrm xmlns:a="http://schemas.openxmlformats.org/drawingml/2006/main">
-            <a:off x="923925" y="1876425"/>
+                <a16:creationId xmlns:a16="http://schemas.microsoft.com/office/drawing/2014/main" id="{18DD6D73-B5E0-4AAC-9E99-E8E1C771CA14}"/>
+              </a:ext>
+            </a:extLst>
+          </p:cNvPr>
+          <p:cNvSpPr>
+            <a:spLocks xmlns:a="http://schemas.openxmlformats.org/drawingml/2006/main" noGrp="1"/>
+          </p:cNvSpPr>
+          <p:nvPr/>
+        </p:nvSpPr>
+        <p:spPr>
+          <a:xfrm xmlns:a="http://schemas.openxmlformats.org/drawingml/2006/main">
+            <a:off x="923925" y="1781175"/>
             <a:ext cx="190500" cy="190500"/>
           </a:xfrm>
           <a:prstGeom xmlns:a="http://schemas.openxmlformats.org/drawingml/2006/main" prst="rect">
@@ -9286,18 +9357,18 @@
           <p:cNvPr id="5" name="">
             <a:extLst xmlns:a="http://schemas.openxmlformats.org/drawingml/2006/main">
               <a:ext uri="{FF2B5EF4-FFF2-40B4-BE49-F238E27FC236}">
-                <a16:creationId xmlns:a16="http://schemas.microsoft.com/office/drawing/2014/main" id="{8C67BB3A-BD8C-4198-A3E7-B44853EF0286}"/>
-              </a:ext>
-            </a:extLst>
-          </p:cNvPr>
-          <p:cNvSpPr>
-            <a:spLocks xmlns:a="http://schemas.openxmlformats.org/drawingml/2006/main" noGrp="1"/>
-          </p:cNvSpPr>
-          <p:nvPr/>
-        </p:nvSpPr>
-        <p:spPr>
-          <a:xfrm xmlns:a="http://schemas.openxmlformats.org/drawingml/2006/main">
-            <a:off x="1524000" y="1857375"/>
+                <a16:creationId xmlns:a16="http://schemas.microsoft.com/office/drawing/2014/main" id="{908CFAA4-5972-451D-A0F8-388F8DB041D3}"/>
+              </a:ext>
+            </a:extLst>
+          </p:cNvPr>
+          <p:cNvSpPr>
+            <a:spLocks xmlns:a="http://schemas.openxmlformats.org/drawingml/2006/main" noGrp="1"/>
+          </p:cNvSpPr>
+          <p:nvPr/>
+        </p:nvSpPr>
+        <p:spPr>
+          <a:xfrm xmlns:a="http://schemas.openxmlformats.org/drawingml/2006/main">
+            <a:off x="1524000" y="1762125"/>
             <a:ext cx="2381250" cy="247650"/>
           </a:xfrm>
           <a:prstGeom xmlns:a="http://schemas.openxmlformats.org/drawingml/2006/main" prst="rect">
@@ -9336,18 +9407,18 @@
           <p:cNvPr id="6" name="">
             <a:extLst xmlns:a="http://schemas.openxmlformats.org/drawingml/2006/main">
               <a:ext uri="{FF2B5EF4-FFF2-40B4-BE49-F238E27FC236}">
-                <a16:creationId xmlns:a16="http://schemas.microsoft.com/office/drawing/2014/main" id="{DB385292-6491-422F-ACFE-D03F4A093B60}"/>
-              </a:ext>
-            </a:extLst>
-          </p:cNvPr>
-          <p:cNvSpPr>
-            <a:spLocks xmlns:a="http://schemas.openxmlformats.org/drawingml/2006/main" noGrp="1"/>
-          </p:cNvSpPr>
-          <p:nvPr/>
-        </p:nvSpPr>
-        <p:spPr>
-          <a:xfrm xmlns:a="http://schemas.openxmlformats.org/drawingml/2006/main">
-            <a:off x="4238625" y="1866900"/>
+                <a16:creationId xmlns:a16="http://schemas.microsoft.com/office/drawing/2014/main" id="{FDC15A91-FA4D-4514-830E-FC35D321B3F9}"/>
+              </a:ext>
+            </a:extLst>
+          </p:cNvPr>
+          <p:cNvSpPr>
+            <a:spLocks xmlns:a="http://schemas.openxmlformats.org/drawingml/2006/main" noGrp="1"/>
+          </p:cNvSpPr>
+          <p:nvPr/>
+        </p:nvSpPr>
+        <p:spPr>
+          <a:xfrm xmlns:a="http://schemas.openxmlformats.org/drawingml/2006/main">
+            <a:off x="4238625" y="1771650"/>
             <a:ext cx="6477000" cy="247650"/>
           </a:xfrm>
           <a:prstGeom xmlns:a="http://schemas.openxmlformats.org/drawingml/2006/main" prst="rect">
@@ -9386,18 +9457,18 @@
           <p:cNvPr id="7" name="">
             <a:extLst xmlns:a="http://schemas.openxmlformats.org/drawingml/2006/main">
               <a:ext uri="{FF2B5EF4-FFF2-40B4-BE49-F238E27FC236}">
-                <a16:creationId xmlns:a16="http://schemas.microsoft.com/office/drawing/2014/main" id="{8D45FA1B-C6AC-49BB-BD55-74C9C374438F}"/>
-              </a:ext>
-            </a:extLst>
-          </p:cNvPr>
-          <p:cNvSpPr>
-            <a:spLocks xmlns:a="http://schemas.openxmlformats.org/drawingml/2006/main" noGrp="1"/>
-          </p:cNvSpPr>
-          <p:nvPr/>
-        </p:nvSpPr>
-        <p:spPr>
-          <a:xfrm xmlns:a="http://schemas.openxmlformats.org/drawingml/2006/main">
-            <a:off x="781050" y="2476500"/>
+                <a16:creationId xmlns:a16="http://schemas.microsoft.com/office/drawing/2014/main" id="{107B44FC-654A-4794-8BBB-027F96752375}"/>
+              </a:ext>
+            </a:extLst>
+          </p:cNvPr>
+          <p:cNvSpPr>
+            <a:spLocks xmlns:a="http://schemas.openxmlformats.org/drawingml/2006/main" noGrp="1"/>
+          </p:cNvSpPr>
+          <p:nvPr/>
+        </p:nvSpPr>
+        <p:spPr>
+          <a:xfrm xmlns:a="http://schemas.openxmlformats.org/drawingml/2006/main">
+            <a:off x="781050" y="2286000"/>
             <a:ext cx="438150" cy="361950"/>
           </a:xfrm>
           <a:prstGeom xmlns:a="http://schemas.openxmlformats.org/drawingml/2006/main" prst="roundRect">
@@ -9419,18 +9490,18 @@
           <p:cNvPr id="8" name="">
             <a:extLst xmlns:a="http://schemas.openxmlformats.org/drawingml/2006/main">
               <a:ext uri="{FF2B5EF4-FFF2-40B4-BE49-F238E27FC236}">
-                <a16:creationId xmlns:a16="http://schemas.microsoft.com/office/drawing/2014/main" id="{982508F5-D58A-4178-8FEC-4C64D4705A77}"/>
-              </a:ext>
-            </a:extLst>
-          </p:cNvPr>
-          <p:cNvSpPr>
-            <a:spLocks xmlns:a="http://schemas.openxmlformats.org/drawingml/2006/main" noGrp="1"/>
-          </p:cNvSpPr>
-          <p:nvPr/>
-        </p:nvSpPr>
-        <p:spPr>
-          <a:xfrm xmlns:a="http://schemas.openxmlformats.org/drawingml/2006/main">
-            <a:off x="923925" y="2543175"/>
+                <a16:creationId xmlns:a16="http://schemas.microsoft.com/office/drawing/2014/main" id="{7473D204-88E4-4960-9401-82776AAB67B2}"/>
+              </a:ext>
+            </a:extLst>
+          </p:cNvPr>
+          <p:cNvSpPr>
+            <a:spLocks xmlns:a="http://schemas.openxmlformats.org/drawingml/2006/main" noGrp="1"/>
+          </p:cNvSpPr>
+          <p:nvPr/>
+        </p:nvSpPr>
+        <p:spPr>
+          <a:xfrm xmlns:a="http://schemas.openxmlformats.org/drawingml/2006/main">
+            <a:off x="923925" y="2352675"/>
             <a:ext cx="190500" cy="190500"/>
           </a:xfrm>
           <a:prstGeom xmlns:a="http://schemas.openxmlformats.org/drawingml/2006/main" prst="rect">
@@ -9469,18 +9540,18 @@
           <p:cNvPr id="9" name="">
             <a:extLst xmlns:a="http://schemas.openxmlformats.org/drawingml/2006/main">
               <a:ext uri="{FF2B5EF4-FFF2-40B4-BE49-F238E27FC236}">
-                <a16:creationId xmlns:a16="http://schemas.microsoft.com/office/drawing/2014/main" id="{691CDECE-63FB-4874-8205-0C1695793BA2}"/>
-              </a:ext>
-            </a:extLst>
-          </p:cNvPr>
-          <p:cNvSpPr>
-            <a:spLocks xmlns:a="http://schemas.openxmlformats.org/drawingml/2006/main" noGrp="1"/>
-          </p:cNvSpPr>
-          <p:nvPr/>
-        </p:nvSpPr>
-        <p:spPr>
-          <a:xfrm xmlns:a="http://schemas.openxmlformats.org/drawingml/2006/main">
-            <a:off x="1524000" y="2524125"/>
+                <a16:creationId xmlns:a16="http://schemas.microsoft.com/office/drawing/2014/main" id="{691EED48-A4FF-497F-BCF4-9151E2C81057}"/>
+              </a:ext>
+            </a:extLst>
+          </p:cNvPr>
+          <p:cNvSpPr>
+            <a:spLocks xmlns:a="http://schemas.openxmlformats.org/drawingml/2006/main" noGrp="1"/>
+          </p:cNvSpPr>
+          <p:nvPr/>
+        </p:nvSpPr>
+        <p:spPr>
+          <a:xfrm xmlns:a="http://schemas.openxmlformats.org/drawingml/2006/main">
+            <a:off x="1524000" y="2333625"/>
             <a:ext cx="2381250" cy="247650"/>
           </a:xfrm>
           <a:prstGeom xmlns:a="http://schemas.openxmlformats.org/drawingml/2006/main" prst="rect">
@@ -9519,18 +9590,18 @@
           <p:cNvPr id="10" name="">
             <a:extLst xmlns:a="http://schemas.openxmlformats.org/drawingml/2006/main">
               <a:ext uri="{FF2B5EF4-FFF2-40B4-BE49-F238E27FC236}">
-                <a16:creationId xmlns:a16="http://schemas.microsoft.com/office/drawing/2014/main" id="{24121576-27BE-488F-AF22-691E60255812}"/>
-              </a:ext>
-            </a:extLst>
-          </p:cNvPr>
-          <p:cNvSpPr>
-            <a:spLocks xmlns:a="http://schemas.openxmlformats.org/drawingml/2006/main" noGrp="1"/>
-          </p:cNvSpPr>
-          <p:nvPr/>
-        </p:nvSpPr>
-        <p:spPr>
-          <a:xfrm xmlns:a="http://schemas.openxmlformats.org/drawingml/2006/main">
-            <a:off x="4238625" y="2533650"/>
+                <a16:creationId xmlns:a16="http://schemas.microsoft.com/office/drawing/2014/main" id="{48B997F2-D930-4D0F-9F1A-DDF696F91D1D}"/>
+              </a:ext>
+            </a:extLst>
+          </p:cNvPr>
+          <p:cNvSpPr>
+            <a:spLocks xmlns:a="http://schemas.openxmlformats.org/drawingml/2006/main" noGrp="1"/>
+          </p:cNvSpPr>
+          <p:nvPr/>
+        </p:nvSpPr>
+        <p:spPr>
+          <a:xfrm xmlns:a="http://schemas.openxmlformats.org/drawingml/2006/main">
+            <a:off x="4238625" y="2343150"/>
             <a:ext cx="6477000" cy="247650"/>
           </a:xfrm>
           <a:prstGeom xmlns:a="http://schemas.openxmlformats.org/drawingml/2006/main" prst="rect">
@@ -9569,18 +9640,18 @@
           <p:cNvPr id="11" name="">
             <a:extLst xmlns:a="http://schemas.openxmlformats.org/drawingml/2006/main">
               <a:ext uri="{FF2B5EF4-FFF2-40B4-BE49-F238E27FC236}">
-                <a16:creationId xmlns:a16="http://schemas.microsoft.com/office/drawing/2014/main" id="{8B485481-C7B5-4DBB-A851-2DF38460E0FB}"/>
-              </a:ext>
-            </a:extLst>
-          </p:cNvPr>
-          <p:cNvSpPr>
-            <a:spLocks xmlns:a="http://schemas.openxmlformats.org/drawingml/2006/main" noGrp="1"/>
-          </p:cNvSpPr>
-          <p:nvPr/>
-        </p:nvSpPr>
-        <p:spPr>
-          <a:xfrm xmlns:a="http://schemas.openxmlformats.org/drawingml/2006/main">
-            <a:off x="781050" y="3143250"/>
+                <a16:creationId xmlns:a16="http://schemas.microsoft.com/office/drawing/2014/main" id="{E3F68867-5A6C-4BC5-ACAC-49BD008F36BE}"/>
+              </a:ext>
+            </a:extLst>
+          </p:cNvPr>
+          <p:cNvSpPr>
+            <a:spLocks xmlns:a="http://schemas.openxmlformats.org/drawingml/2006/main" noGrp="1"/>
+          </p:cNvSpPr>
+          <p:nvPr/>
+        </p:nvSpPr>
+        <p:spPr>
+          <a:xfrm xmlns:a="http://schemas.openxmlformats.org/drawingml/2006/main">
+            <a:off x="781050" y="2857500"/>
             <a:ext cx="438150" cy="361950"/>
           </a:xfrm>
           <a:prstGeom xmlns:a="http://schemas.openxmlformats.org/drawingml/2006/main" prst="roundRect">
@@ -9602,18 +9673,18 @@
           <p:cNvPr id="12" name="">
             <a:extLst xmlns:a="http://schemas.openxmlformats.org/drawingml/2006/main">
               <a:ext uri="{FF2B5EF4-FFF2-40B4-BE49-F238E27FC236}">
-                <a16:creationId xmlns:a16="http://schemas.microsoft.com/office/drawing/2014/main" id="{1C29748C-75E7-47EE-B3FD-8A548026557A}"/>
-              </a:ext>
-            </a:extLst>
-          </p:cNvPr>
-          <p:cNvSpPr>
-            <a:spLocks xmlns:a="http://schemas.openxmlformats.org/drawingml/2006/main" noGrp="1"/>
-          </p:cNvSpPr>
-          <p:nvPr/>
-        </p:nvSpPr>
-        <p:spPr>
-          <a:xfrm xmlns:a="http://schemas.openxmlformats.org/drawingml/2006/main">
-            <a:off x="923925" y="3209925"/>
+                <a16:creationId xmlns:a16="http://schemas.microsoft.com/office/drawing/2014/main" id="{E8B01A6C-3BB5-4CD8-8EC0-05E9612EABCF}"/>
+              </a:ext>
+            </a:extLst>
+          </p:cNvPr>
+          <p:cNvSpPr>
+            <a:spLocks xmlns:a="http://schemas.openxmlformats.org/drawingml/2006/main" noGrp="1"/>
+          </p:cNvSpPr>
+          <p:nvPr/>
+        </p:nvSpPr>
+        <p:spPr>
+          <a:xfrm xmlns:a="http://schemas.openxmlformats.org/drawingml/2006/main">
+            <a:off x="923925" y="2924175"/>
             <a:ext cx="190500" cy="190500"/>
           </a:xfrm>
           <a:prstGeom xmlns:a="http://schemas.openxmlformats.org/drawingml/2006/main" prst="rect">
@@ -9652,18 +9723,18 @@
           <p:cNvPr id="13" name="">
             <a:extLst xmlns:a="http://schemas.openxmlformats.org/drawingml/2006/main">
               <a:ext uri="{FF2B5EF4-FFF2-40B4-BE49-F238E27FC236}">
-                <a16:creationId xmlns:a16="http://schemas.microsoft.com/office/drawing/2014/main" id="{BEFE488D-B4FC-4CD7-92D4-19AF6A043981}"/>
-              </a:ext>
-            </a:extLst>
-          </p:cNvPr>
-          <p:cNvSpPr>
-            <a:spLocks xmlns:a="http://schemas.openxmlformats.org/drawingml/2006/main" noGrp="1"/>
-          </p:cNvSpPr>
-          <p:nvPr/>
-        </p:nvSpPr>
-        <p:spPr>
-          <a:xfrm xmlns:a="http://schemas.openxmlformats.org/drawingml/2006/main">
-            <a:off x="1524000" y="3190875"/>
+                <a16:creationId xmlns:a16="http://schemas.microsoft.com/office/drawing/2014/main" id="{E6D4A703-F7E6-4BDA-BBCF-A598772741D2}"/>
+              </a:ext>
+            </a:extLst>
+          </p:cNvPr>
+          <p:cNvSpPr>
+            <a:spLocks xmlns:a="http://schemas.openxmlformats.org/drawingml/2006/main" noGrp="1"/>
+          </p:cNvSpPr>
+          <p:nvPr/>
+        </p:nvSpPr>
+        <p:spPr>
+          <a:xfrm xmlns:a="http://schemas.openxmlformats.org/drawingml/2006/main">
+            <a:off x="1524000" y="2905125"/>
             <a:ext cx="2381250" cy="247650"/>
           </a:xfrm>
           <a:prstGeom xmlns:a="http://schemas.openxmlformats.org/drawingml/2006/main" prst="rect">
@@ -9702,18 +9773,18 @@
           <p:cNvPr id="14" name="">
             <a:extLst xmlns:a="http://schemas.openxmlformats.org/drawingml/2006/main">
               <a:ext uri="{FF2B5EF4-FFF2-40B4-BE49-F238E27FC236}">
-                <a16:creationId xmlns:a16="http://schemas.microsoft.com/office/drawing/2014/main" id="{118F8CA2-5798-409C-99F2-F0912465359A}"/>
-              </a:ext>
-            </a:extLst>
-          </p:cNvPr>
-          <p:cNvSpPr>
-            <a:spLocks xmlns:a="http://schemas.openxmlformats.org/drawingml/2006/main" noGrp="1"/>
-          </p:cNvSpPr>
-          <p:nvPr/>
-        </p:nvSpPr>
-        <p:spPr>
-          <a:xfrm xmlns:a="http://schemas.openxmlformats.org/drawingml/2006/main">
-            <a:off x="4238625" y="3200400"/>
+                <a16:creationId xmlns:a16="http://schemas.microsoft.com/office/drawing/2014/main" id="{FD87595A-CCF2-4398-A68A-D21F1719D9B5}"/>
+              </a:ext>
+            </a:extLst>
+          </p:cNvPr>
+          <p:cNvSpPr>
+            <a:spLocks xmlns:a="http://schemas.openxmlformats.org/drawingml/2006/main" noGrp="1"/>
+          </p:cNvSpPr>
+          <p:nvPr/>
+        </p:nvSpPr>
+        <p:spPr>
+          <a:xfrm xmlns:a="http://schemas.openxmlformats.org/drawingml/2006/main">
+            <a:off x="4238625" y="2914650"/>
             <a:ext cx="6477000" cy="247650"/>
           </a:xfrm>
           <a:prstGeom xmlns:a="http://schemas.openxmlformats.org/drawingml/2006/main" prst="rect">
@@ -9742,7 +9813,7 @@
                   <a:srgbClr val="64748B"/>
                 </a:solidFill>
               </a:rPr>
-              <a:t>npm test 验证登录、共享队列、批准、通知</a:t>
+              <a:t>npm test：正常 / 重复 / 高风险 三类用例</a:t>
             </a:r>
           </a:p>
         </p:txBody>
@@ -9752,18 +9823,18 @@
           <p:cNvPr id="15" name="">
             <a:extLst xmlns:a="http://schemas.openxmlformats.org/drawingml/2006/main">
               <a:ext uri="{FF2B5EF4-FFF2-40B4-BE49-F238E27FC236}">
-                <a16:creationId xmlns:a16="http://schemas.microsoft.com/office/drawing/2014/main" id="{D171887C-A4A2-4A3A-8192-928AE87AB84E}"/>
-              </a:ext>
-            </a:extLst>
-          </p:cNvPr>
-          <p:cNvSpPr>
-            <a:spLocks xmlns:a="http://schemas.openxmlformats.org/drawingml/2006/main" noGrp="1"/>
-          </p:cNvSpPr>
-          <p:nvPr/>
-        </p:nvSpPr>
-        <p:spPr>
-          <a:xfrm xmlns:a="http://schemas.openxmlformats.org/drawingml/2006/main">
-            <a:off x="781050" y="3810000"/>
+                <a16:creationId xmlns:a16="http://schemas.microsoft.com/office/drawing/2014/main" id="{CCF89907-CB4F-4804-A2FA-326EC15861F8}"/>
+              </a:ext>
+            </a:extLst>
+          </p:cNvPr>
+          <p:cNvSpPr>
+            <a:spLocks xmlns:a="http://schemas.openxmlformats.org/drawingml/2006/main" noGrp="1"/>
+          </p:cNvSpPr>
+          <p:nvPr/>
+        </p:nvSpPr>
+        <p:spPr>
+          <a:xfrm xmlns:a="http://schemas.openxmlformats.org/drawingml/2006/main">
+            <a:off x="781050" y="3429000"/>
             <a:ext cx="438150" cy="361950"/>
           </a:xfrm>
           <a:prstGeom xmlns:a="http://schemas.openxmlformats.org/drawingml/2006/main" prst="roundRect">
@@ -9785,18 +9856,18 @@
           <p:cNvPr id="16" name="">
             <a:extLst xmlns:a="http://schemas.openxmlformats.org/drawingml/2006/main">
               <a:ext uri="{FF2B5EF4-FFF2-40B4-BE49-F238E27FC236}">
-                <a16:creationId xmlns:a16="http://schemas.microsoft.com/office/drawing/2014/main" id="{FF52A79D-E46F-496C-9DAC-F8997F811F20}"/>
-              </a:ext>
-            </a:extLst>
-          </p:cNvPr>
-          <p:cNvSpPr>
-            <a:spLocks xmlns:a="http://schemas.openxmlformats.org/drawingml/2006/main" noGrp="1"/>
-          </p:cNvSpPr>
-          <p:nvPr/>
-        </p:nvSpPr>
-        <p:spPr>
-          <a:xfrm xmlns:a="http://schemas.openxmlformats.org/drawingml/2006/main">
-            <a:off x="923925" y="3876675"/>
+                <a16:creationId xmlns:a16="http://schemas.microsoft.com/office/drawing/2014/main" id="{FE3B6070-A473-4436-BB23-D9C6250131D7}"/>
+              </a:ext>
+            </a:extLst>
+          </p:cNvPr>
+          <p:cNvSpPr>
+            <a:spLocks xmlns:a="http://schemas.openxmlformats.org/drawingml/2006/main" noGrp="1"/>
+          </p:cNvSpPr>
+          <p:nvPr/>
+        </p:nvSpPr>
+        <p:spPr>
+          <a:xfrm xmlns:a="http://schemas.openxmlformats.org/drawingml/2006/main">
+            <a:off x="923925" y="3495675"/>
             <a:ext cx="190500" cy="190500"/>
           </a:xfrm>
           <a:prstGeom xmlns:a="http://schemas.openxmlformats.org/drawingml/2006/main" prst="rect">
@@ -9835,18 +9906,18 @@
           <p:cNvPr id="17" name="">
             <a:extLst xmlns:a="http://schemas.openxmlformats.org/drawingml/2006/main">
               <a:ext uri="{FF2B5EF4-FFF2-40B4-BE49-F238E27FC236}">
-                <a16:creationId xmlns:a16="http://schemas.microsoft.com/office/drawing/2014/main" id="{A4E951AD-55D2-4172-8B92-701EB047CE39}"/>
-              </a:ext>
-            </a:extLst>
-          </p:cNvPr>
-          <p:cNvSpPr>
-            <a:spLocks xmlns:a="http://schemas.openxmlformats.org/drawingml/2006/main" noGrp="1"/>
-          </p:cNvSpPr>
-          <p:nvPr/>
-        </p:nvSpPr>
-        <p:spPr>
-          <a:xfrm xmlns:a="http://schemas.openxmlformats.org/drawingml/2006/main">
-            <a:off x="1524000" y="3857625"/>
+                <a16:creationId xmlns:a16="http://schemas.microsoft.com/office/drawing/2014/main" id="{1E640C09-229A-4E3E-BF63-FB14D958A951}"/>
+              </a:ext>
+            </a:extLst>
+          </p:cNvPr>
+          <p:cNvSpPr>
+            <a:spLocks xmlns:a="http://schemas.openxmlformats.org/drawingml/2006/main" noGrp="1"/>
+          </p:cNvSpPr>
+          <p:nvPr/>
+        </p:nvSpPr>
+        <p:spPr>
+          <a:xfrm xmlns:a="http://schemas.openxmlformats.org/drawingml/2006/main">
+            <a:off x="1524000" y="3476625"/>
             <a:ext cx="2381250" cy="247650"/>
           </a:xfrm>
           <a:prstGeom xmlns:a="http://schemas.openxmlformats.org/drawingml/2006/main" prst="rect">
@@ -9885,18 +9956,18 @@
           <p:cNvPr id="18" name="">
             <a:extLst xmlns:a="http://schemas.openxmlformats.org/drawingml/2006/main">
               <a:ext uri="{FF2B5EF4-FFF2-40B4-BE49-F238E27FC236}">
-                <a16:creationId xmlns:a16="http://schemas.microsoft.com/office/drawing/2014/main" id="{80C00ADA-AF03-4900-B4F7-AA0E333C2C3D}"/>
-              </a:ext>
-            </a:extLst>
-          </p:cNvPr>
-          <p:cNvSpPr>
-            <a:spLocks xmlns:a="http://schemas.openxmlformats.org/drawingml/2006/main" noGrp="1"/>
-          </p:cNvSpPr>
-          <p:nvPr/>
-        </p:nvSpPr>
-        <p:spPr>
-          <a:xfrm xmlns:a="http://schemas.openxmlformats.org/drawingml/2006/main">
-            <a:off x="4238625" y="3867150"/>
+                <a16:creationId xmlns:a16="http://schemas.microsoft.com/office/drawing/2014/main" id="{DAB7F0F4-D290-47F9-BA84-3D5EC6FC2314}"/>
+              </a:ext>
+            </a:extLst>
+          </p:cNvPr>
+          <p:cNvSpPr>
+            <a:spLocks xmlns:a="http://schemas.openxmlformats.org/drawingml/2006/main" noGrp="1"/>
+          </p:cNvSpPr>
+          <p:nvPr/>
+        </p:nvSpPr>
+        <p:spPr>
+          <a:xfrm xmlns:a="http://schemas.openxmlformats.org/drawingml/2006/main">
+            <a:off x="4238625" y="3486150"/>
             <a:ext cx="6477000" cy="247650"/>
           </a:xfrm>
           <a:prstGeom xmlns:a="http://schemas.openxmlformats.org/drawingml/2006/main" prst="rect">
@@ -9935,18 +10006,18 @@
           <p:cNvPr id="19" name="">
             <a:extLst xmlns:a="http://schemas.openxmlformats.org/drawingml/2006/main">
               <a:ext uri="{FF2B5EF4-FFF2-40B4-BE49-F238E27FC236}">
-                <a16:creationId xmlns:a16="http://schemas.microsoft.com/office/drawing/2014/main" id="{81F5DB66-6E68-412F-B481-D17DFB4E07B7}"/>
-              </a:ext>
-            </a:extLst>
-          </p:cNvPr>
-          <p:cNvSpPr>
-            <a:spLocks xmlns:a="http://schemas.openxmlformats.org/drawingml/2006/main" noGrp="1"/>
-          </p:cNvSpPr>
-          <p:nvPr/>
-        </p:nvSpPr>
-        <p:spPr>
-          <a:xfrm xmlns:a="http://schemas.openxmlformats.org/drawingml/2006/main">
-            <a:off x="781050" y="4476750"/>
+                <a16:creationId xmlns:a16="http://schemas.microsoft.com/office/drawing/2014/main" id="{F2F83855-66E5-46A6-9A55-5E035BED4A86}"/>
+              </a:ext>
+            </a:extLst>
+          </p:cNvPr>
+          <p:cNvSpPr>
+            <a:spLocks xmlns:a="http://schemas.openxmlformats.org/drawingml/2006/main" noGrp="1"/>
+          </p:cNvSpPr>
+          <p:nvPr/>
+        </p:nvSpPr>
+        <p:spPr>
+          <a:xfrm xmlns:a="http://schemas.openxmlformats.org/drawingml/2006/main">
+            <a:off x="781050" y="4000500"/>
             <a:ext cx="438150" cy="361950"/>
           </a:xfrm>
           <a:prstGeom xmlns:a="http://schemas.openxmlformats.org/drawingml/2006/main" prst="roundRect">
@@ -9968,18 +10039,18 @@
           <p:cNvPr id="20" name="">
             <a:extLst xmlns:a="http://schemas.openxmlformats.org/drawingml/2006/main">
               <a:ext uri="{FF2B5EF4-FFF2-40B4-BE49-F238E27FC236}">
-                <a16:creationId xmlns:a16="http://schemas.microsoft.com/office/drawing/2014/main" id="{DCF9EC88-7CCF-4FBE-8DEC-1CC5B48F9D1F}"/>
-              </a:ext>
-            </a:extLst>
-          </p:cNvPr>
-          <p:cNvSpPr>
-            <a:spLocks xmlns:a="http://schemas.openxmlformats.org/drawingml/2006/main" noGrp="1"/>
-          </p:cNvSpPr>
-          <p:nvPr/>
-        </p:nvSpPr>
-        <p:spPr>
-          <a:xfrm xmlns:a="http://schemas.openxmlformats.org/drawingml/2006/main">
-            <a:off x="923925" y="4543425"/>
+                <a16:creationId xmlns:a16="http://schemas.microsoft.com/office/drawing/2014/main" id="{4877B7C2-BBB8-40D0-9933-BF220FC5D8AC}"/>
+              </a:ext>
+            </a:extLst>
+          </p:cNvPr>
+          <p:cNvSpPr>
+            <a:spLocks xmlns:a="http://schemas.openxmlformats.org/drawingml/2006/main" noGrp="1"/>
+          </p:cNvSpPr>
+          <p:nvPr/>
+        </p:nvSpPr>
+        <p:spPr>
+          <a:xfrm xmlns:a="http://schemas.openxmlformats.org/drawingml/2006/main">
+            <a:off x="923925" y="4067175"/>
             <a:ext cx="190500" cy="190500"/>
           </a:xfrm>
           <a:prstGeom xmlns:a="http://schemas.openxmlformats.org/drawingml/2006/main" prst="rect">
@@ -10018,18 +10089,18 @@
           <p:cNvPr id="21" name="">
             <a:extLst xmlns:a="http://schemas.openxmlformats.org/drawingml/2006/main">
               <a:ext uri="{FF2B5EF4-FFF2-40B4-BE49-F238E27FC236}">
-                <a16:creationId xmlns:a16="http://schemas.microsoft.com/office/drawing/2014/main" id="{4CA705C6-74A0-43D5-B352-5C8A6992C0D1}"/>
-              </a:ext>
-            </a:extLst>
-          </p:cNvPr>
-          <p:cNvSpPr>
-            <a:spLocks xmlns:a="http://schemas.openxmlformats.org/drawingml/2006/main" noGrp="1"/>
-          </p:cNvSpPr>
-          <p:nvPr/>
-        </p:nvSpPr>
-        <p:spPr>
-          <a:xfrm xmlns:a="http://schemas.openxmlformats.org/drawingml/2006/main">
-            <a:off x="1524000" y="4524375"/>
+                <a16:creationId xmlns:a16="http://schemas.microsoft.com/office/drawing/2014/main" id="{13EE96E3-9AA4-4975-9025-0D666C3E7BE0}"/>
+              </a:ext>
+            </a:extLst>
+          </p:cNvPr>
+          <p:cNvSpPr>
+            <a:spLocks xmlns:a="http://schemas.openxmlformats.org/drawingml/2006/main" noGrp="1"/>
+          </p:cNvSpPr>
+          <p:nvPr/>
+        </p:nvSpPr>
+        <p:spPr>
+          <a:xfrm xmlns:a="http://schemas.openxmlformats.org/drawingml/2006/main">
+            <a:off x="1524000" y="4048125"/>
             <a:ext cx="2381250" cy="247650"/>
           </a:xfrm>
           <a:prstGeom xmlns:a="http://schemas.openxmlformats.org/drawingml/2006/main" prst="rect">
@@ -10068,18 +10139,18 @@
           <p:cNvPr id="22" name="">
             <a:extLst xmlns:a="http://schemas.openxmlformats.org/drawingml/2006/main">
               <a:ext uri="{FF2B5EF4-FFF2-40B4-BE49-F238E27FC236}">
-                <a16:creationId xmlns:a16="http://schemas.microsoft.com/office/drawing/2014/main" id="{DDB273FD-1CED-46C8-8443-CB71FE2C3850}"/>
-              </a:ext>
-            </a:extLst>
-          </p:cNvPr>
-          <p:cNvSpPr>
-            <a:spLocks xmlns:a="http://schemas.openxmlformats.org/drawingml/2006/main" noGrp="1"/>
-          </p:cNvSpPr>
-          <p:nvPr/>
-        </p:nvSpPr>
-        <p:spPr>
-          <a:xfrm xmlns:a="http://schemas.openxmlformats.org/drawingml/2006/main">
-            <a:off x="4238625" y="4533900"/>
+                <a16:creationId xmlns:a16="http://schemas.microsoft.com/office/drawing/2014/main" id="{E21364B6-867D-4303-BCE8-F715994EC5F7}"/>
+              </a:ext>
+            </a:extLst>
+          </p:cNvPr>
+          <p:cNvSpPr>
+            <a:spLocks xmlns:a="http://schemas.openxmlformats.org/drawingml/2006/main" noGrp="1"/>
+          </p:cNvSpPr>
+          <p:nvPr/>
+        </p:nvSpPr>
+        <p:spPr>
+          <a:xfrm xmlns:a="http://schemas.openxmlformats.org/drawingml/2006/main">
+            <a:off x="4238625" y="4057650"/>
             <a:ext cx="6477000" cy="247650"/>
           </a:xfrm>
           <a:prstGeom xmlns:a="http://schemas.openxmlformats.org/drawingml/2006/main" prst="rect">
@@ -10108,7 +10179,7 @@
                   <a:srgbClr val="64748B"/>
                 </a:solidFill>
               </a:rPr>
-              <a:t>MIT License · 模拟接口说明 · 生产路线</a:t>
+              <a:t>MIT License · GitHub · 模拟接口说明</a:t>
             </a:r>
           </a:p>
         </p:txBody>
@@ -10118,7 +10189,190 @@
           <p:cNvPr id="23" name="">
             <a:extLst xmlns:a="http://schemas.openxmlformats.org/drawingml/2006/main">
               <a:ext uri="{FF2B5EF4-FFF2-40B4-BE49-F238E27FC236}">
-                <a16:creationId xmlns:a16="http://schemas.microsoft.com/office/drawing/2014/main" id="{17AFC2CE-76EF-4060-BCF9-2DD41C681972}"/>
+                <a16:creationId xmlns:a16="http://schemas.microsoft.com/office/drawing/2014/main" id="{30025555-133F-488E-971B-83BA20AA870C}"/>
+              </a:ext>
+            </a:extLst>
+          </p:cNvPr>
+          <p:cNvSpPr>
+            <a:spLocks xmlns:a="http://schemas.openxmlformats.org/drawingml/2006/main" noGrp="1"/>
+          </p:cNvSpPr>
+          <p:nvPr/>
+        </p:nvSpPr>
+        <p:spPr>
+          <a:xfrm xmlns:a="http://schemas.openxmlformats.org/drawingml/2006/main">
+            <a:off x="781050" y="4572000"/>
+            <a:ext cx="438150" cy="361950"/>
+          </a:xfrm>
+          <a:prstGeom xmlns:a="http://schemas.openxmlformats.org/drawingml/2006/main" prst="roundRect">
+            <a:avLst>
+              <a:gd name="adj" fmla="val 21053"/>
+            </a:avLst>
+          </a:prstGeom>
+          <a:solidFill xmlns:a="http://schemas.openxmlformats.org/drawingml/2006/main">
+            <a:srgbClr val="3667F5"/>
+          </a:solidFill>
+          <a:ln xmlns:a="http://schemas.openxmlformats.org/drawingml/2006/main" w="0">
+            <a:noFill/>
+            <a:prstDash val="solid"/>
+          </a:ln>
+        </p:spPr>
+      </p:sp>
+      <p:sp>
+        <p:nvSpPr>
+          <p:cNvPr id="24" name="">
+            <a:extLst xmlns:a="http://schemas.openxmlformats.org/drawingml/2006/main">
+              <a:ext uri="{FF2B5EF4-FFF2-40B4-BE49-F238E27FC236}">
+                <a16:creationId xmlns:a16="http://schemas.microsoft.com/office/drawing/2014/main" id="{54DA4B6C-2C25-4EA1-B09F-CD0F697B1065}"/>
+              </a:ext>
+            </a:extLst>
+          </p:cNvPr>
+          <p:cNvSpPr>
+            <a:spLocks xmlns:a="http://schemas.openxmlformats.org/drawingml/2006/main" noGrp="1"/>
+          </p:cNvSpPr>
+          <p:nvPr/>
+        </p:nvSpPr>
+        <p:spPr>
+          <a:xfrm xmlns:a="http://schemas.openxmlformats.org/drawingml/2006/main">
+            <a:off x="923925" y="4638675"/>
+            <a:ext cx="190500" cy="190500"/>
+          </a:xfrm>
+          <a:prstGeom xmlns:a="http://schemas.openxmlformats.org/drawingml/2006/main" prst="rect">
+            <a:avLst/>
+          </a:prstGeom>
+          <a:noFill xmlns:a="http://schemas.openxmlformats.org/drawingml/2006/main"/>
+          <a:ln xmlns:a="http://schemas.openxmlformats.org/drawingml/2006/main" w="0">
+            <a:noFill/>
+            <a:prstDash val="solid"/>
+          </a:ln>
+        </p:spPr>
+        <p:txBody>
+          <a:bodyPr xmlns:a="http://schemas.openxmlformats.org/drawingml/2006/main"/>
+          <a:lstStyle xmlns:a="http://schemas.openxmlformats.org/drawingml/2006/main"/>
+          <a:p xmlns:a="http://schemas.openxmlformats.org/drawingml/2006/main">
+            <a:pPr>
+              <a:defRPr sz="1275" b="1">
+                <a:solidFill>
+                  <a:srgbClr val="FFFFFF"/>
+                </a:solidFill>
+              </a:defRPr>
+            </a:pPr>
+            <a:r>
+              <a:rPr sz="1275" b="1">
+                <a:solidFill>
+                  <a:srgbClr val="FFFFFF"/>
+                </a:solidFill>
+              </a:rPr>
+              <a:t>✓</a:t>
+            </a:r>
+          </a:p>
+        </p:txBody>
+      </p:sp>
+      <p:sp>
+        <p:nvSpPr>
+          <p:cNvPr id="25" name="">
+            <a:extLst xmlns:a="http://schemas.openxmlformats.org/drawingml/2006/main">
+              <a:ext uri="{FF2B5EF4-FFF2-40B4-BE49-F238E27FC236}">
+                <a16:creationId xmlns:a16="http://schemas.microsoft.com/office/drawing/2014/main" id="{FC32553E-6B1F-4CD7-80B3-BA51F252E528}"/>
+              </a:ext>
+            </a:extLst>
+          </p:cNvPr>
+          <p:cNvSpPr>
+            <a:spLocks xmlns:a="http://schemas.openxmlformats.org/drawingml/2006/main" noGrp="1"/>
+          </p:cNvSpPr>
+          <p:nvPr/>
+        </p:nvSpPr>
+        <p:spPr>
+          <a:xfrm xmlns:a="http://schemas.openxmlformats.org/drawingml/2006/main">
+            <a:off x="1524000" y="4619625"/>
+            <a:ext cx="2381250" cy="247650"/>
+          </a:xfrm>
+          <a:prstGeom xmlns:a="http://schemas.openxmlformats.org/drawingml/2006/main" prst="rect">
+            <a:avLst/>
+          </a:prstGeom>
+          <a:noFill xmlns:a="http://schemas.openxmlformats.org/drawingml/2006/main"/>
+          <a:ln xmlns:a="http://schemas.openxmlformats.org/drawingml/2006/main" w="0">
+            <a:noFill/>
+            <a:prstDash val="solid"/>
+          </a:ln>
+        </p:spPr>
+        <p:txBody>
+          <a:bodyPr xmlns:a="http://schemas.openxmlformats.org/drawingml/2006/main"/>
+          <a:lstStyle xmlns:a="http://schemas.openxmlformats.org/drawingml/2006/main"/>
+          <a:p xmlns:a="http://schemas.openxmlformats.org/drawingml/2006/main">
+            <a:pPr>
+              <a:defRPr sz="1500" b="1">
+                <a:solidFill>
+                  <a:srgbClr val="173052"/>
+                </a:solidFill>
+              </a:defRPr>
+            </a:pPr>
+            <a:r>
+              <a:rPr sz="1500" b="1">
+                <a:solidFill>
+                  <a:srgbClr val="173052"/>
+                </a:solidFill>
+              </a:rPr>
+              <a:t>代码仓库</a:t>
+            </a:r>
+          </a:p>
+        </p:txBody>
+      </p:sp>
+      <p:sp>
+        <p:nvSpPr>
+          <p:cNvPr id="26" name="">
+            <a:extLst xmlns:a="http://schemas.openxmlformats.org/drawingml/2006/main">
+              <a:ext uri="{FF2B5EF4-FFF2-40B4-BE49-F238E27FC236}">
+                <a16:creationId xmlns:a16="http://schemas.microsoft.com/office/drawing/2014/main" id="{D7F54F29-32ED-4577-920F-01199B509708}"/>
+              </a:ext>
+            </a:extLst>
+          </p:cNvPr>
+          <p:cNvSpPr>
+            <a:spLocks xmlns:a="http://schemas.openxmlformats.org/drawingml/2006/main" noGrp="1"/>
+          </p:cNvSpPr>
+          <p:nvPr/>
+        </p:nvSpPr>
+        <p:spPr>
+          <a:xfrm xmlns:a="http://schemas.openxmlformats.org/drawingml/2006/main">
+            <a:off x="4238625" y="4629150"/>
+            <a:ext cx="6477000" cy="247650"/>
+          </a:xfrm>
+          <a:prstGeom xmlns:a="http://schemas.openxmlformats.org/drawingml/2006/main" prst="rect">
+            <a:avLst/>
+          </a:prstGeom>
+          <a:noFill xmlns:a="http://schemas.openxmlformats.org/drawingml/2006/main"/>
+          <a:ln xmlns:a="http://schemas.openxmlformats.org/drawingml/2006/main" w="0">
+            <a:noFill/>
+            <a:prstDash val="solid"/>
+          </a:ln>
+        </p:spPr>
+        <p:txBody>
+          <a:bodyPr xmlns:a="http://schemas.openxmlformats.org/drawingml/2006/main"/>
+          <a:lstStyle xmlns:a="http://schemas.openxmlformats.org/drawingml/2006/main"/>
+          <a:p xmlns:a="http://schemas.openxmlformats.org/drawingml/2006/main">
+            <a:pPr>
+              <a:defRPr sz="1350" b="0">
+                <a:solidFill>
+                  <a:srgbClr val="64748B"/>
+                </a:solidFill>
+              </a:defRPr>
+            </a:pPr>
+            <a:r>
+              <a:rPr sz="1350" b="0">
+                <a:solidFill>
+                  <a:srgbClr val="64748B"/>
+                </a:solidFill>
+              </a:rPr>
+              <a:t>github.com/marcuslim318-cloud/project-test</a:t>
+            </a:r>
+          </a:p>
+        </p:txBody>
+      </p:sp>
+      <p:sp>
+        <p:nvSpPr>
+          <p:cNvPr id="27" name="">
+            <a:extLst xmlns:a="http://schemas.openxmlformats.org/drawingml/2006/main">
+              <a:ext uri="{FF2B5EF4-FFF2-40B4-BE49-F238E27FC236}">
+                <a16:creationId xmlns:a16="http://schemas.microsoft.com/office/drawing/2014/main" id="{C2B3B0C0-5506-414D-B911-F5145E218056}"/>
               </a:ext>
             </a:extLst>
           </p:cNvPr>
@@ -10158,17 +10412,17 @@
                   <a:srgbClr val="16805B"/>
                 </a:solidFill>
               </a:rPr>
-              <a:t>关键改进：后端 Token 鉴权、共享审核队列、审批状态与通知均由 API 持久化，而不是只在单一浏览器内存中运行。</a:t>
-            </a:r>
-          </a:p>
-        </p:txBody>
-      </p:sp>
-      <p:sp>
-        <p:nvSpPr>
-          <p:cNvPr id="24" name="">
-            <a:extLst xmlns:a="http://schemas.openxmlformats.org/drawingml/2006/main">
-              <a:ext uri="{FF2B5EF4-FFF2-40B4-BE49-F238E27FC236}">
-                <a16:creationId xmlns:a16="http://schemas.microsoft.com/office/drawing/2014/main" id="{9C2DC6C4-7C8E-42AD-A03C-853D57C66BF1}"/>
+              <a:t>关键改进：管理员工作台真实读取 /api/receipts 全部待审核单据；登录 API 不返回密码；后端规则引擎判定重复与高风险。</a:t>
+            </a:r>
+          </a:p>
+        </p:txBody>
+      </p:sp>
+      <p:sp>
+        <p:nvSpPr>
+          <p:cNvPr id="28" name="">
+            <a:extLst xmlns:a="http://schemas.openxmlformats.org/drawingml/2006/main">
+              <a:ext uri="{FF2B5EF4-FFF2-40B4-BE49-F238E27FC236}">
+                <a16:creationId xmlns:a16="http://schemas.microsoft.com/office/drawing/2014/main" id="{3B48426A-E920-4C9D-A83B-7F03B16789B5}"/>
               </a:ext>
             </a:extLst>
           </p:cNvPr>
@@ -10215,10 +10469,10 @@
       </p:sp>
       <p:sp>
         <p:nvSpPr>
-          <p:cNvPr id="25" name="">
-            <a:extLst xmlns:a="http://schemas.openxmlformats.org/drawingml/2006/main">
-              <a:ext uri="{FF2B5EF4-FFF2-40B4-BE49-F238E27FC236}">
-                <a16:creationId xmlns:a16="http://schemas.microsoft.com/office/drawing/2014/main" id="{A4FC712C-B9B7-4929-AE70-84D3BD808545}"/>
+          <p:cNvPr id="29" name="">
+            <a:extLst xmlns:a="http://schemas.openxmlformats.org/drawingml/2006/main">
+              <a:ext uri="{FF2B5EF4-FFF2-40B4-BE49-F238E27FC236}">
+                <a16:creationId xmlns:a16="http://schemas.microsoft.com/office/drawing/2014/main" id="{50606DFC-BB52-4C91-A062-1028E756140F}"/>
               </a:ext>
             </a:extLst>
           </p:cNvPr>
@@ -10266,7 +10520,818 @@
     </p:spTree>
     <p:extLst>
       <p:ext uri="{BB962C8B-B14F-4D97-AF65-F5344CB8AC3E}">
-        <p14:creationId xmlns:p14="http://schemas.microsoft.com/office/powerpoint/2010/main" val="579362479"/>
+        <p14:creationId xmlns:p14="http://schemas.microsoft.com/office/powerpoint/2010/main" val="890185939"/>
+      </p:ext>
+    </p:extLst>
+  </p:cSld>
+</p:sld>
+</file>
+
+<file path=ppt/slides/slide18.xml><?xml version="1.0" encoding="utf-8"?>
+<p:sld xmlns:p="http://schemas.openxmlformats.org/presentationml/2006/main">
+  <p:cSld>
+    <p:bg>
+      <p:bgPr>
+        <a:solidFill xmlns:a="http://schemas.openxmlformats.org/drawingml/2006/main">
+          <a:srgbClr val="F5F7FA"/>
+        </a:solidFill>
+      </p:bgPr>
+    </p:bg>
+    <p:spTree>
+      <p:nvGrpSpPr>
+        <p:cNvPr id="1" name=""/>
+        <p:cNvGrpSpPr/>
+        <p:nvPr/>
+      </p:nvGrpSpPr>
+      <p:grpSpPr>
+        <a:xfrm xmlns:a="http://schemas.openxmlformats.org/drawingml/2006/main"/>
+      </p:grpSpPr>
+      <p:sp>
+        <p:nvSpPr>
+          <p:cNvPr id="18" name="">
+            <a:extLst xmlns:a="http://schemas.openxmlformats.org/drawingml/2006/main">
+              <a:ext uri="{FF2B5EF4-FFF2-40B4-BE49-F238E27FC236}">
+                <a16:creationId xmlns:a16="http://schemas.microsoft.com/office/drawing/2014/main" id="{483CF364-ED10-48E8-8666-6B8321C71769}"/>
+              </a:ext>
+            </a:extLst>
+          </p:cNvPr>
+          <p:cNvSpPr>
+            <a:spLocks xmlns:a="http://schemas.openxmlformats.org/drawingml/2006/main" noGrp="1"/>
+          </p:cNvSpPr>
+          <p:nvPr/>
+        </p:nvSpPr>
+        <p:spPr>
+          <a:xfrm xmlns:a="http://schemas.openxmlformats.org/drawingml/2006/main">
+            <a:off x="685800" y="381000"/>
+            <a:ext cx="4762500" cy="209550"/>
+          </a:xfrm>
+          <a:prstGeom xmlns:a="http://schemas.openxmlformats.org/drawingml/2006/main" prst="rect">
+            <a:avLst/>
+          </a:prstGeom>
+          <a:noFill xmlns:a="http://schemas.openxmlformats.org/drawingml/2006/main"/>
+          <a:ln xmlns:a="http://schemas.openxmlformats.org/drawingml/2006/main" w="0">
+            <a:noFill/>
+            <a:prstDash val="solid"/>
+          </a:ln>
+        </p:spPr>
+        <p:txBody>
+          <a:bodyPr xmlns:a="http://schemas.openxmlformats.org/drawingml/2006/main"/>
+          <a:lstStyle xmlns:a="http://schemas.openxmlformats.org/drawingml/2006/main"/>
+          <a:p xmlns:a="http://schemas.openxmlformats.org/drawingml/2006/main">
+            <a:pPr>
+              <a:defRPr sz="975" b="1">
+                <a:solidFill>
+                  <a:srgbClr val="3667F5"/>
+                </a:solidFill>
+              </a:defRPr>
+            </a:pPr>
+            <a:r>
+              <a:rPr sz="975" b="1">
+                <a:solidFill>
+                  <a:srgbClr val="3667F5"/>
+                </a:solidFill>
+              </a:rPr>
+              <a:t>17 · 三种可复现测试</a:t>
+            </a:r>
+          </a:p>
+        </p:txBody>
+      </p:sp>
+      <p:sp>
+        <p:nvSpPr>
+          <p:cNvPr id="2" name="">
+            <a:extLst xmlns:a="http://schemas.openxmlformats.org/drawingml/2006/main">
+              <a:ext uri="{FF2B5EF4-FFF2-40B4-BE49-F238E27FC236}">
+                <a16:creationId xmlns:a16="http://schemas.microsoft.com/office/drawing/2014/main" id="{BC53975E-1A09-4CA8-AFEA-8C102DCE3C27}"/>
+              </a:ext>
+            </a:extLst>
+          </p:cNvPr>
+          <p:cNvSpPr>
+            <a:spLocks xmlns:a="http://schemas.openxmlformats.org/drawingml/2006/main" noGrp="1"/>
+          </p:cNvSpPr>
+          <p:nvPr/>
+        </p:nvSpPr>
+        <p:spPr>
+          <a:xfrm xmlns:a="http://schemas.openxmlformats.org/drawingml/2006/main">
+            <a:off x="685800" y="704850"/>
+            <a:ext cx="10668000" cy="571500"/>
+          </a:xfrm>
+          <a:prstGeom xmlns:a="http://schemas.openxmlformats.org/drawingml/2006/main" prst="rect">
+            <a:avLst/>
+          </a:prstGeom>
+          <a:noFill xmlns:a="http://schemas.openxmlformats.org/drawingml/2006/main"/>
+          <a:ln xmlns:a="http://schemas.openxmlformats.org/drawingml/2006/main" w="0">
+            <a:noFill/>
+            <a:prstDash val="solid"/>
+          </a:ln>
+        </p:spPr>
+        <p:txBody>
+          <a:bodyPr xmlns:a="http://schemas.openxmlformats.org/drawingml/2006/main"/>
+          <a:lstStyle xmlns:a="http://schemas.openxmlformats.org/drawingml/2006/main"/>
+          <a:p xmlns:a="http://schemas.openxmlformats.org/drawingml/2006/main">
+            <a:pPr>
+              <a:defRPr sz="2700" b="1">
+                <a:solidFill>
+                  <a:srgbClr val="173052"/>
+                </a:solidFill>
+              </a:defRPr>
+            </a:pPr>
+            <a:r>
+              <a:rPr sz="2700" b="1">
+                <a:solidFill>
+                  <a:srgbClr val="173052"/>
+                </a:solidFill>
+              </a:rPr>
+              <a:t>不依赖网络与外部密钥，npm test 即可复跑。</a:t>
+            </a:r>
+          </a:p>
+        </p:txBody>
+      </p:sp>
+      <p:sp>
+        <p:nvSpPr>
+          <p:cNvPr id="3" name="">
+            <a:extLst xmlns:a="http://schemas.openxmlformats.org/drawingml/2006/main">
+              <a:ext uri="{FF2B5EF4-FFF2-40B4-BE49-F238E27FC236}">
+                <a16:creationId xmlns:a16="http://schemas.microsoft.com/office/drawing/2014/main" id="{1071800C-344E-4CCE-8B04-9F318F7F34D7}"/>
+              </a:ext>
+            </a:extLst>
+          </p:cNvPr>
+          <p:cNvSpPr>
+            <a:spLocks xmlns:a="http://schemas.openxmlformats.org/drawingml/2006/main" noGrp="1"/>
+          </p:cNvSpPr>
+          <p:nvPr/>
+        </p:nvSpPr>
+        <p:spPr>
+          <a:xfrm xmlns:a="http://schemas.openxmlformats.org/drawingml/2006/main">
+            <a:off x="809625" y="1905000"/>
+            <a:ext cx="2190750" cy="533400"/>
+          </a:xfrm>
+          <a:prstGeom xmlns:a="http://schemas.openxmlformats.org/drawingml/2006/main" prst="roundRect">
+            <a:avLst>
+              <a:gd name="adj" fmla="val 14286"/>
+            </a:avLst>
+          </a:prstGeom>
+          <a:solidFill xmlns:a="http://schemas.openxmlformats.org/drawingml/2006/main">
+            <a:srgbClr val="3667F5"/>
+          </a:solidFill>
+          <a:ln xmlns:a="http://schemas.openxmlformats.org/drawingml/2006/main" w="0">
+            <a:noFill/>
+            <a:prstDash val="solid"/>
+          </a:ln>
+        </p:spPr>
+      </p:sp>
+      <p:sp>
+        <p:nvSpPr>
+          <p:cNvPr id="4" name="">
+            <a:extLst xmlns:a="http://schemas.openxmlformats.org/drawingml/2006/main">
+              <a:ext uri="{FF2B5EF4-FFF2-40B4-BE49-F238E27FC236}">
+                <a16:creationId xmlns:a16="http://schemas.microsoft.com/office/drawing/2014/main" id="{4142C748-F293-4208-BB7E-D15C5CC00770}"/>
+              </a:ext>
+            </a:extLst>
+          </p:cNvPr>
+          <p:cNvSpPr>
+            <a:spLocks xmlns:a="http://schemas.openxmlformats.org/drawingml/2006/main" noGrp="1"/>
+          </p:cNvSpPr>
+          <p:nvPr/>
+        </p:nvSpPr>
+        <p:spPr>
+          <a:xfrm xmlns:a="http://schemas.openxmlformats.org/drawingml/2006/main">
+            <a:off x="1028700" y="2057400"/>
+            <a:ext cx="1809750" cy="247650"/>
+          </a:xfrm>
+          <a:prstGeom xmlns:a="http://schemas.openxmlformats.org/drawingml/2006/main" prst="rect">
+            <a:avLst/>
+          </a:prstGeom>
+          <a:noFill xmlns:a="http://schemas.openxmlformats.org/drawingml/2006/main"/>
+          <a:ln xmlns:a="http://schemas.openxmlformats.org/drawingml/2006/main" w="0">
+            <a:noFill/>
+            <a:prstDash val="solid"/>
+          </a:ln>
+        </p:spPr>
+        <p:txBody>
+          <a:bodyPr xmlns:a="http://schemas.openxmlformats.org/drawingml/2006/main"/>
+          <a:lstStyle xmlns:a="http://schemas.openxmlformats.org/drawingml/2006/main"/>
+          <a:p xmlns:a="http://schemas.openxmlformats.org/drawingml/2006/main">
+            <a:pPr>
+              <a:defRPr sz="1425" b="1">
+                <a:solidFill>
+                  <a:srgbClr val="FFFFFF"/>
+                </a:solidFill>
+              </a:defRPr>
+            </a:pPr>
+            <a:r>
+              <a:rPr sz="1425" b="1">
+                <a:solidFill>
+                  <a:srgbClr val="FFFFFF"/>
+                </a:solidFill>
+              </a:rPr>
+              <a:t>登录安全</a:t>
+            </a:r>
+          </a:p>
+        </p:txBody>
+      </p:sp>
+      <p:sp>
+        <p:nvSpPr>
+          <p:cNvPr id="5" name="">
+            <a:extLst xmlns:a="http://schemas.openxmlformats.org/drawingml/2006/main">
+              <a:ext uri="{FF2B5EF4-FFF2-40B4-BE49-F238E27FC236}">
+                <a16:creationId xmlns:a16="http://schemas.microsoft.com/office/drawing/2014/main" id="{FAF1C580-2FF9-407F-86B7-BB63ADB80B45}"/>
+              </a:ext>
+            </a:extLst>
+          </p:cNvPr>
+          <p:cNvSpPr>
+            <a:spLocks xmlns:a="http://schemas.openxmlformats.org/drawingml/2006/main" noGrp="1"/>
+          </p:cNvSpPr>
+          <p:nvPr/>
+        </p:nvSpPr>
+        <p:spPr>
+          <a:xfrm xmlns:a="http://schemas.openxmlformats.org/drawingml/2006/main">
+            <a:off x="3286125" y="1962150"/>
+            <a:ext cx="7000875" cy="571500"/>
+          </a:xfrm>
+          <a:prstGeom xmlns:a="http://schemas.openxmlformats.org/drawingml/2006/main" prst="rect">
+            <a:avLst/>
+          </a:prstGeom>
+          <a:noFill xmlns:a="http://schemas.openxmlformats.org/drawingml/2006/main"/>
+          <a:ln xmlns:a="http://schemas.openxmlformats.org/drawingml/2006/main" w="0">
+            <a:noFill/>
+            <a:prstDash val="solid"/>
+          </a:ln>
+        </p:spPr>
+        <p:txBody>
+          <a:bodyPr xmlns:a="http://schemas.openxmlformats.org/drawingml/2006/main"/>
+          <a:lstStyle xmlns:a="http://schemas.openxmlformats.org/drawingml/2006/main"/>
+          <a:p xmlns:a="http://schemas.openxmlformats.org/drawingml/2006/main">
+            <a:pPr>
+              <a:defRPr sz="1350" b="0">
+                <a:solidFill>
+                  <a:srgbClr val="173052"/>
+                </a:solidFill>
+              </a:defRPr>
+            </a:pPr>
+            <a:r>
+              <a:rPr sz="1350" b="0">
+                <a:solidFill>
+                  <a:srgbClr val="173052"/>
+                </a:solidFill>
+              </a:rPr>
+              <a:t>四个账号登录响应均不含密码字段；错误密码 401</a:t>
+            </a:r>
+          </a:p>
+        </p:txBody>
+      </p:sp>
+      <p:sp>
+        <p:nvSpPr>
+          <p:cNvPr id="6" name="">
+            <a:extLst xmlns:a="http://schemas.openxmlformats.org/drawingml/2006/main">
+              <a:ext uri="{FF2B5EF4-FFF2-40B4-BE49-F238E27FC236}">
+                <a16:creationId xmlns:a16="http://schemas.microsoft.com/office/drawing/2014/main" id="{CC0CCE7C-0963-46C3-8ECB-D55649C31AD8}"/>
+              </a:ext>
+            </a:extLst>
+          </p:cNvPr>
+          <p:cNvSpPr>
+            <a:spLocks xmlns:a="http://schemas.openxmlformats.org/drawingml/2006/main" noGrp="1"/>
+          </p:cNvSpPr>
+          <p:nvPr/>
+        </p:nvSpPr>
+        <p:spPr>
+          <a:xfrm xmlns:a="http://schemas.openxmlformats.org/drawingml/2006/main">
+            <a:off x="809625" y="2743200"/>
+            <a:ext cx="2190750" cy="533400"/>
+          </a:xfrm>
+          <a:prstGeom xmlns:a="http://schemas.openxmlformats.org/drawingml/2006/main" prst="roundRect">
+            <a:avLst>
+              <a:gd name="adj" fmla="val 14286"/>
+            </a:avLst>
+          </a:prstGeom>
+          <a:solidFill xmlns:a="http://schemas.openxmlformats.org/drawingml/2006/main">
+            <a:srgbClr val="3667F5"/>
+          </a:solidFill>
+          <a:ln xmlns:a="http://schemas.openxmlformats.org/drawingml/2006/main" w="0">
+            <a:noFill/>
+            <a:prstDash val="solid"/>
+          </a:ln>
+        </p:spPr>
+      </p:sp>
+      <p:sp>
+        <p:nvSpPr>
+          <p:cNvPr id="7" name="">
+            <a:extLst xmlns:a="http://schemas.openxmlformats.org/drawingml/2006/main">
+              <a:ext uri="{FF2B5EF4-FFF2-40B4-BE49-F238E27FC236}">
+                <a16:creationId xmlns:a16="http://schemas.microsoft.com/office/drawing/2014/main" id="{C7A082D6-77F3-4693-AD12-4122520AD0F9}"/>
+              </a:ext>
+            </a:extLst>
+          </p:cNvPr>
+          <p:cNvSpPr>
+            <a:spLocks xmlns:a="http://schemas.openxmlformats.org/drawingml/2006/main" noGrp="1"/>
+          </p:cNvSpPr>
+          <p:nvPr/>
+        </p:nvSpPr>
+        <p:spPr>
+          <a:xfrm xmlns:a="http://schemas.openxmlformats.org/drawingml/2006/main">
+            <a:off x="1028700" y="2895600"/>
+            <a:ext cx="1809750" cy="247650"/>
+          </a:xfrm>
+          <a:prstGeom xmlns:a="http://schemas.openxmlformats.org/drawingml/2006/main" prst="rect">
+            <a:avLst/>
+          </a:prstGeom>
+          <a:noFill xmlns:a="http://schemas.openxmlformats.org/drawingml/2006/main"/>
+          <a:ln xmlns:a="http://schemas.openxmlformats.org/drawingml/2006/main" w="0">
+            <a:noFill/>
+            <a:prstDash val="solid"/>
+          </a:ln>
+        </p:spPr>
+        <p:txBody>
+          <a:bodyPr xmlns:a="http://schemas.openxmlformats.org/drawingml/2006/main"/>
+          <a:lstStyle xmlns:a="http://schemas.openxmlformats.org/drawingml/2006/main"/>
+          <a:p xmlns:a="http://schemas.openxmlformats.org/drawingml/2006/main">
+            <a:pPr>
+              <a:defRPr sz="1425" b="1">
+                <a:solidFill>
+                  <a:srgbClr val="FFFFFF"/>
+                </a:solidFill>
+              </a:defRPr>
+            </a:pPr>
+            <a:r>
+              <a:rPr sz="1425" b="1">
+                <a:solidFill>
+                  <a:srgbClr val="FFFFFF"/>
+                </a:solidFill>
+              </a:rPr>
+              <a:t>正常收据</a:t>
+            </a:r>
+          </a:p>
+        </p:txBody>
+      </p:sp>
+      <p:sp>
+        <p:nvSpPr>
+          <p:cNvPr id="8" name="">
+            <a:extLst xmlns:a="http://schemas.openxmlformats.org/drawingml/2006/main">
+              <a:ext uri="{FF2B5EF4-FFF2-40B4-BE49-F238E27FC236}">
+                <a16:creationId xmlns:a16="http://schemas.microsoft.com/office/drawing/2014/main" id="{79443B1F-BFC8-496D-90DE-4E3D38CD193B}"/>
+              </a:ext>
+            </a:extLst>
+          </p:cNvPr>
+          <p:cNvSpPr>
+            <a:spLocks xmlns:a="http://schemas.openxmlformats.org/drawingml/2006/main" noGrp="1"/>
+          </p:cNvSpPr>
+          <p:nvPr/>
+        </p:nvSpPr>
+        <p:spPr>
+          <a:xfrm xmlns:a="http://schemas.openxmlformats.org/drawingml/2006/main">
+            <a:off x="3286125" y="2800350"/>
+            <a:ext cx="7000875" cy="571500"/>
+          </a:xfrm>
+          <a:prstGeom xmlns:a="http://schemas.openxmlformats.org/drawingml/2006/main" prst="rect">
+            <a:avLst/>
+          </a:prstGeom>
+          <a:noFill xmlns:a="http://schemas.openxmlformats.org/drawingml/2006/main"/>
+          <a:ln xmlns:a="http://schemas.openxmlformats.org/drawingml/2006/main" w="0">
+            <a:noFill/>
+            <a:prstDash val="solid"/>
+          </a:ln>
+        </p:spPr>
+        <p:txBody>
+          <a:bodyPr xmlns:a="http://schemas.openxmlformats.org/drawingml/2006/main"/>
+          <a:lstStyle xmlns:a="http://schemas.openxmlformats.org/drawingml/2006/main"/>
+          <a:p xmlns:a="http://schemas.openxmlformats.org/drawingml/2006/main">
+            <a:pPr>
+              <a:defRPr sz="1350" b="0">
+                <a:solidFill>
+                  <a:srgbClr val="173052"/>
+                </a:solidFill>
+              </a:defRPr>
+            </a:pPr>
+            <a:r>
+              <a:rPr sz="1350" b="0">
+                <a:solidFill>
+                  <a:srgbClr val="173052"/>
+                </a:solidFill>
+              </a:rPr>
+              <a:t>员工提交 → 管理员读取 /api/receipts 队列 → 批准 → 员工通知</a:t>
+            </a:r>
+          </a:p>
+        </p:txBody>
+      </p:sp>
+      <p:sp>
+        <p:nvSpPr>
+          <p:cNvPr id="9" name="">
+            <a:extLst xmlns:a="http://schemas.openxmlformats.org/drawingml/2006/main">
+              <a:ext uri="{FF2B5EF4-FFF2-40B4-BE49-F238E27FC236}">
+                <a16:creationId xmlns:a16="http://schemas.microsoft.com/office/drawing/2014/main" id="{402FCE81-84CE-46C0-8352-9E787A75B3B2}"/>
+              </a:ext>
+            </a:extLst>
+          </p:cNvPr>
+          <p:cNvSpPr>
+            <a:spLocks xmlns:a="http://schemas.openxmlformats.org/drawingml/2006/main" noGrp="1"/>
+          </p:cNvSpPr>
+          <p:nvPr/>
+        </p:nvSpPr>
+        <p:spPr>
+          <a:xfrm xmlns:a="http://schemas.openxmlformats.org/drawingml/2006/main">
+            <a:off x="809625" y="3581400"/>
+            <a:ext cx="2190750" cy="533400"/>
+          </a:xfrm>
+          <a:prstGeom xmlns:a="http://schemas.openxmlformats.org/drawingml/2006/main" prst="roundRect">
+            <a:avLst>
+              <a:gd name="adj" fmla="val 14286"/>
+            </a:avLst>
+          </a:prstGeom>
+          <a:solidFill xmlns:a="http://schemas.openxmlformats.org/drawingml/2006/main">
+            <a:srgbClr val="3667F5"/>
+          </a:solidFill>
+          <a:ln xmlns:a="http://schemas.openxmlformats.org/drawingml/2006/main" w="0">
+            <a:noFill/>
+            <a:prstDash val="solid"/>
+          </a:ln>
+        </p:spPr>
+      </p:sp>
+      <p:sp>
+        <p:nvSpPr>
+          <p:cNvPr id="10" name="">
+            <a:extLst xmlns:a="http://schemas.openxmlformats.org/drawingml/2006/main">
+              <a:ext uri="{FF2B5EF4-FFF2-40B4-BE49-F238E27FC236}">
+                <a16:creationId xmlns:a16="http://schemas.microsoft.com/office/drawing/2014/main" id="{BF2C4533-8FD9-4B67-BDC8-C503EB35CC84}"/>
+              </a:ext>
+            </a:extLst>
+          </p:cNvPr>
+          <p:cNvSpPr>
+            <a:spLocks xmlns:a="http://schemas.openxmlformats.org/drawingml/2006/main" noGrp="1"/>
+          </p:cNvSpPr>
+          <p:nvPr/>
+        </p:nvSpPr>
+        <p:spPr>
+          <a:xfrm xmlns:a="http://schemas.openxmlformats.org/drawingml/2006/main">
+            <a:off x="1028700" y="3733800"/>
+            <a:ext cx="1809750" cy="247650"/>
+          </a:xfrm>
+          <a:prstGeom xmlns:a="http://schemas.openxmlformats.org/drawingml/2006/main" prst="rect">
+            <a:avLst/>
+          </a:prstGeom>
+          <a:noFill xmlns:a="http://schemas.openxmlformats.org/drawingml/2006/main"/>
+          <a:ln xmlns:a="http://schemas.openxmlformats.org/drawingml/2006/main" w="0">
+            <a:noFill/>
+            <a:prstDash val="solid"/>
+          </a:ln>
+        </p:spPr>
+        <p:txBody>
+          <a:bodyPr xmlns:a="http://schemas.openxmlformats.org/drawingml/2006/main"/>
+          <a:lstStyle xmlns:a="http://schemas.openxmlformats.org/drawingml/2006/main"/>
+          <a:p xmlns:a="http://schemas.openxmlformats.org/drawingml/2006/main">
+            <a:pPr>
+              <a:defRPr sz="1425" b="1">
+                <a:solidFill>
+                  <a:srgbClr val="FFFFFF"/>
+                </a:solidFill>
+              </a:defRPr>
+            </a:pPr>
+            <a:r>
+              <a:rPr sz="1425" b="1">
+                <a:solidFill>
+                  <a:srgbClr val="FFFFFF"/>
+                </a:solidFill>
+              </a:rPr>
+              <a:t>重复收据</a:t>
+            </a:r>
+          </a:p>
+        </p:txBody>
+      </p:sp>
+      <p:sp>
+        <p:nvSpPr>
+          <p:cNvPr id="11" name="">
+            <a:extLst xmlns:a="http://schemas.openxmlformats.org/drawingml/2006/main">
+              <a:ext uri="{FF2B5EF4-FFF2-40B4-BE49-F238E27FC236}">
+                <a16:creationId xmlns:a16="http://schemas.microsoft.com/office/drawing/2014/main" id="{27EEFC45-BB8A-4B88-B788-C550CBE7AD08}"/>
+              </a:ext>
+            </a:extLst>
+          </p:cNvPr>
+          <p:cNvSpPr>
+            <a:spLocks xmlns:a="http://schemas.openxmlformats.org/drawingml/2006/main" noGrp="1"/>
+          </p:cNvSpPr>
+          <p:nvPr/>
+        </p:nvSpPr>
+        <p:spPr>
+          <a:xfrm xmlns:a="http://schemas.openxmlformats.org/drawingml/2006/main">
+            <a:off x="3286125" y="3638550"/>
+            <a:ext cx="7000875" cy="571500"/>
+          </a:xfrm>
+          <a:prstGeom xmlns:a="http://schemas.openxmlformats.org/drawingml/2006/main" prst="rect">
+            <a:avLst/>
+          </a:prstGeom>
+          <a:noFill xmlns:a="http://schemas.openxmlformats.org/drawingml/2006/main"/>
+          <a:ln xmlns:a="http://schemas.openxmlformats.org/drawingml/2006/main" w="0">
+            <a:noFill/>
+            <a:prstDash val="solid"/>
+          </a:ln>
+        </p:spPr>
+        <p:txBody>
+          <a:bodyPr xmlns:a="http://schemas.openxmlformats.org/drawingml/2006/main"/>
+          <a:lstStyle xmlns:a="http://schemas.openxmlformats.org/drawingml/2006/main"/>
+          <a:p xmlns:a="http://schemas.openxmlformats.org/drawingml/2006/main">
+            <a:pPr>
+              <a:defRPr sz="1350" b="0">
+                <a:solidFill>
+                  <a:srgbClr val="173052"/>
+                </a:solidFill>
+              </a:defRPr>
+            </a:pPr>
+            <a:r>
+              <a:rPr sz="1350" b="0">
+                <a:solidFill>
+                  <a:srgbClr val="173052"/>
+                </a:solidFill>
+              </a:rPr>
+              <a:t>相同收据号再次提交 → 标记重复 + risk:review</a:t>
+            </a:r>
+          </a:p>
+        </p:txBody>
+      </p:sp>
+      <p:sp>
+        <p:nvSpPr>
+          <p:cNvPr id="12" name="">
+            <a:extLst xmlns:a="http://schemas.openxmlformats.org/drawingml/2006/main">
+              <a:ext uri="{FF2B5EF4-FFF2-40B4-BE49-F238E27FC236}">
+                <a16:creationId xmlns:a16="http://schemas.microsoft.com/office/drawing/2014/main" id="{310BBB4C-32A6-44D7-92CE-8BC7DBCA1407}"/>
+              </a:ext>
+            </a:extLst>
+          </p:cNvPr>
+          <p:cNvSpPr>
+            <a:spLocks xmlns:a="http://schemas.openxmlformats.org/drawingml/2006/main" noGrp="1"/>
+          </p:cNvSpPr>
+          <p:nvPr/>
+        </p:nvSpPr>
+        <p:spPr>
+          <a:xfrm xmlns:a="http://schemas.openxmlformats.org/drawingml/2006/main">
+            <a:off x="809625" y="4419600"/>
+            <a:ext cx="2190750" cy="533400"/>
+          </a:xfrm>
+          <a:prstGeom xmlns:a="http://schemas.openxmlformats.org/drawingml/2006/main" prst="roundRect">
+            <a:avLst>
+              <a:gd name="adj" fmla="val 14286"/>
+            </a:avLst>
+          </a:prstGeom>
+          <a:solidFill xmlns:a="http://schemas.openxmlformats.org/drawingml/2006/main">
+            <a:srgbClr val="3667F5"/>
+          </a:solidFill>
+          <a:ln xmlns:a="http://schemas.openxmlformats.org/drawingml/2006/main" w="0">
+            <a:noFill/>
+            <a:prstDash val="solid"/>
+          </a:ln>
+        </p:spPr>
+      </p:sp>
+      <p:sp>
+        <p:nvSpPr>
+          <p:cNvPr id="13" name="">
+            <a:extLst xmlns:a="http://schemas.openxmlformats.org/drawingml/2006/main">
+              <a:ext uri="{FF2B5EF4-FFF2-40B4-BE49-F238E27FC236}">
+                <a16:creationId xmlns:a16="http://schemas.microsoft.com/office/drawing/2014/main" id="{9FE6E30F-DA62-494E-B92B-456FE1407C60}"/>
+              </a:ext>
+            </a:extLst>
+          </p:cNvPr>
+          <p:cNvSpPr>
+            <a:spLocks xmlns:a="http://schemas.openxmlformats.org/drawingml/2006/main" noGrp="1"/>
+          </p:cNvSpPr>
+          <p:nvPr/>
+        </p:nvSpPr>
+        <p:spPr>
+          <a:xfrm xmlns:a="http://schemas.openxmlformats.org/drawingml/2006/main">
+            <a:off x="1028700" y="4572000"/>
+            <a:ext cx="1809750" cy="247650"/>
+          </a:xfrm>
+          <a:prstGeom xmlns:a="http://schemas.openxmlformats.org/drawingml/2006/main" prst="rect">
+            <a:avLst/>
+          </a:prstGeom>
+          <a:noFill xmlns:a="http://schemas.openxmlformats.org/drawingml/2006/main"/>
+          <a:ln xmlns:a="http://schemas.openxmlformats.org/drawingml/2006/main" w="0">
+            <a:noFill/>
+            <a:prstDash val="solid"/>
+          </a:ln>
+        </p:spPr>
+        <p:txBody>
+          <a:bodyPr xmlns:a="http://schemas.openxmlformats.org/drawingml/2006/main"/>
+          <a:lstStyle xmlns:a="http://schemas.openxmlformats.org/drawingml/2006/main"/>
+          <a:p xmlns:a="http://schemas.openxmlformats.org/drawingml/2006/main">
+            <a:pPr>
+              <a:defRPr sz="1425" b="1">
+                <a:solidFill>
+                  <a:srgbClr val="FFFFFF"/>
+                </a:solidFill>
+              </a:defRPr>
+            </a:pPr>
+            <a:r>
+              <a:rPr sz="1425" b="1">
+                <a:solidFill>
+                  <a:srgbClr val="FFFFFF"/>
+                </a:solidFill>
+              </a:rPr>
+              <a:t>模糊/缺失 MyInvois</a:t>
+            </a:r>
+          </a:p>
+        </p:txBody>
+      </p:sp>
+      <p:sp>
+        <p:nvSpPr>
+          <p:cNvPr id="14" name="">
+            <a:extLst xmlns:a="http://schemas.openxmlformats.org/drawingml/2006/main">
+              <a:ext uri="{FF2B5EF4-FFF2-40B4-BE49-F238E27FC236}">
+                <a16:creationId xmlns:a16="http://schemas.microsoft.com/office/drawing/2014/main" id="{A8EECC25-C554-4083-9AEA-2A7360655148}"/>
+              </a:ext>
+            </a:extLst>
+          </p:cNvPr>
+          <p:cNvSpPr>
+            <a:spLocks xmlns:a="http://schemas.openxmlformats.org/drawingml/2006/main" noGrp="1"/>
+          </p:cNvSpPr>
+          <p:nvPr/>
+        </p:nvSpPr>
+        <p:spPr>
+          <a:xfrm xmlns:a="http://schemas.openxmlformats.org/drawingml/2006/main">
+            <a:off x="3286125" y="4476750"/>
+            <a:ext cx="7000875" cy="571500"/>
+          </a:xfrm>
+          <a:prstGeom xmlns:a="http://schemas.openxmlformats.org/drawingml/2006/main" prst="rect">
+            <a:avLst/>
+          </a:prstGeom>
+          <a:noFill xmlns:a="http://schemas.openxmlformats.org/drawingml/2006/main"/>
+          <a:ln xmlns:a="http://schemas.openxmlformats.org/drawingml/2006/main" w="0">
+            <a:noFill/>
+            <a:prstDash val="solid"/>
+          </a:ln>
+        </p:spPr>
+        <p:txBody>
+          <a:bodyPr xmlns:a="http://schemas.openxmlformats.org/drawingml/2006/main"/>
+          <a:lstStyle xmlns:a="http://schemas.openxmlformats.org/drawingml/2006/main"/>
+          <a:p xmlns:a="http://schemas.openxmlformats.org/drawingml/2006/main">
+            <a:pPr>
+              <a:defRPr sz="1350" b="0">
+                <a:solidFill>
+                  <a:srgbClr val="173052"/>
+                </a:solidFill>
+              </a:defRPr>
+            </a:pPr>
+            <a:r>
+              <a:rPr sz="1350" b="0">
+                <a:solidFill>
+                  <a:srgbClr val="173052"/>
+                </a:solidFill>
+              </a:rPr>
+              <a:t>低置信度、缺收据号、MyInvois 状态为空 → risk:review</a:t>
+            </a:r>
+          </a:p>
+        </p:txBody>
+      </p:sp>
+      <p:sp>
+        <p:nvSpPr>
+          <p:cNvPr id="15" name="">
+            <a:extLst xmlns:a="http://schemas.openxmlformats.org/drawingml/2006/main">
+              <a:ext uri="{FF2B5EF4-FFF2-40B4-BE49-F238E27FC236}">
+                <a16:creationId xmlns:a16="http://schemas.microsoft.com/office/drawing/2014/main" id="{419A3D52-5A32-4E99-B9E5-B1855B7FE2EB}"/>
+              </a:ext>
+            </a:extLst>
+          </p:cNvPr>
+          <p:cNvSpPr>
+            <a:spLocks xmlns:a="http://schemas.openxmlformats.org/drawingml/2006/main" noGrp="1"/>
+          </p:cNvSpPr>
+          <p:nvPr/>
+        </p:nvSpPr>
+        <p:spPr>
+          <a:xfrm xmlns:a="http://schemas.openxmlformats.org/drawingml/2006/main">
+            <a:off x="781050" y="5381625"/>
+            <a:ext cx="7620000" cy="285750"/>
+          </a:xfrm>
+          <a:prstGeom xmlns:a="http://schemas.openxmlformats.org/drawingml/2006/main" prst="rect">
+            <a:avLst/>
+          </a:prstGeom>
+          <a:noFill xmlns:a="http://schemas.openxmlformats.org/drawingml/2006/main"/>
+          <a:ln xmlns:a="http://schemas.openxmlformats.org/drawingml/2006/main" w="0">
+            <a:noFill/>
+            <a:prstDash val="solid"/>
+          </a:ln>
+        </p:spPr>
+        <p:txBody>
+          <a:bodyPr xmlns:a="http://schemas.openxmlformats.org/drawingml/2006/main"/>
+          <a:lstStyle xmlns:a="http://schemas.openxmlformats.org/drawingml/2006/main"/>
+          <a:p xmlns:a="http://schemas.openxmlformats.org/drawingml/2006/main">
+            <a:pPr>
+              <a:defRPr sz="1350" b="0">
+                <a:solidFill>
+                  <a:srgbClr val="64748B"/>
+                </a:solidFill>
+              </a:defRPr>
+            </a:pPr>
+            <a:r>
+              <a:rPr sz="1350" b="0">
+                <a:solidFill>
+                  <a:srgbClr val="64748B"/>
+                </a:solidFill>
+              </a:rPr>
+              <a:t>运行：npm test　·　用例文件：tests/api.test.mjs</a:t>
+            </a:r>
+          </a:p>
+        </p:txBody>
+      </p:sp>
+      <p:sp>
+        <p:nvSpPr>
+          <p:cNvPr id="16" name="">
+            <a:extLst xmlns:a="http://schemas.openxmlformats.org/drawingml/2006/main">
+              <a:ext uri="{FF2B5EF4-FFF2-40B4-BE49-F238E27FC236}">
+                <a16:creationId xmlns:a16="http://schemas.microsoft.com/office/drawing/2014/main" id="{8D35039D-64D6-440B-994C-4B9D461685A3}"/>
+              </a:ext>
+            </a:extLst>
+          </p:cNvPr>
+          <p:cNvSpPr>
+            <a:spLocks xmlns:a="http://schemas.openxmlformats.org/drawingml/2006/main" noGrp="1"/>
+          </p:cNvSpPr>
+          <p:nvPr/>
+        </p:nvSpPr>
+        <p:spPr>
+          <a:xfrm xmlns:a="http://schemas.openxmlformats.org/drawingml/2006/main">
+            <a:off x="685800" y="6496050"/>
+            <a:ext cx="4762500" cy="152400"/>
+          </a:xfrm>
+          <a:prstGeom xmlns:a="http://schemas.openxmlformats.org/drawingml/2006/main" prst="rect">
+            <a:avLst/>
+          </a:prstGeom>
+          <a:noFill xmlns:a="http://schemas.openxmlformats.org/drawingml/2006/main"/>
+          <a:ln xmlns:a="http://schemas.openxmlformats.org/drawingml/2006/main" w="0">
+            <a:noFill/>
+            <a:prstDash val="solid"/>
+          </a:ln>
+        </p:spPr>
+        <p:txBody>
+          <a:bodyPr xmlns:a="http://schemas.openxmlformats.org/drawingml/2006/main"/>
+          <a:lstStyle xmlns:a="http://schemas.openxmlformats.org/drawingml/2006/main"/>
+          <a:p xmlns:a="http://schemas.openxmlformats.org/drawingml/2006/main">
+            <a:pPr>
+              <a:defRPr sz="825" b="1">
+                <a:solidFill>
+                  <a:srgbClr val="64748B"/>
+                </a:solidFill>
+              </a:defRPr>
+            </a:pPr>
+            <a:r>
+              <a:rPr sz="825" b="1">
+                <a:solidFill>
+                  <a:srgbClr val="64748B"/>
+                </a:solidFill>
+              </a:rPr>
+              <a:t>LEDGERLENS AI  ·  MALAYSIA SME FINANCE</a:t>
+            </a:r>
+          </a:p>
+        </p:txBody>
+      </p:sp>
+      <p:sp>
+        <p:nvSpPr>
+          <p:cNvPr id="17" name="">
+            <a:extLst xmlns:a="http://schemas.openxmlformats.org/drawingml/2006/main">
+              <a:ext uri="{FF2B5EF4-FFF2-40B4-BE49-F238E27FC236}">
+                <a16:creationId xmlns:a16="http://schemas.microsoft.com/office/drawing/2014/main" id="{012BBC15-311C-4128-A986-9C7291C8979D}"/>
+              </a:ext>
+            </a:extLst>
+          </p:cNvPr>
+          <p:cNvSpPr>
+            <a:spLocks xmlns:a="http://schemas.openxmlformats.org/drawingml/2006/main" noGrp="1"/>
+          </p:cNvSpPr>
+          <p:nvPr/>
+        </p:nvSpPr>
+        <p:spPr>
+          <a:xfrm xmlns:a="http://schemas.openxmlformats.org/drawingml/2006/main">
+            <a:off x="11239500" y="6496050"/>
+            <a:ext cx="266700" cy="152400"/>
+          </a:xfrm>
+          <a:prstGeom xmlns:a="http://schemas.openxmlformats.org/drawingml/2006/main" prst="rect">
+            <a:avLst/>
+          </a:prstGeom>
+          <a:noFill xmlns:a="http://schemas.openxmlformats.org/drawingml/2006/main"/>
+          <a:ln xmlns:a="http://schemas.openxmlformats.org/drawingml/2006/main" w="0">
+            <a:noFill/>
+            <a:prstDash val="solid"/>
+          </a:ln>
+        </p:spPr>
+        <p:txBody>
+          <a:bodyPr xmlns:a="http://schemas.openxmlformats.org/drawingml/2006/main"/>
+          <a:lstStyle xmlns:a="http://schemas.openxmlformats.org/drawingml/2006/main"/>
+          <a:p xmlns:a="http://schemas.openxmlformats.org/drawingml/2006/main">
+            <a:pPr>
+              <a:defRPr sz="825" b="1">
+                <a:solidFill>
+                  <a:srgbClr val="64748B"/>
+                </a:solidFill>
+              </a:defRPr>
+            </a:pPr>
+            <a:r>
+              <a:rPr sz="825" b="1">
+                <a:solidFill>
+                  <a:srgbClr val="64748B"/>
+                </a:solidFill>
+              </a:rPr>
+              <a:t>18</a:t>
+            </a:r>
+          </a:p>
+        </p:txBody>
+      </p:sp>
+    </p:spTree>
+    <p:extLst>
+      <p:ext uri="{BB962C8B-B14F-4D97-AF65-F5344CB8AC3E}">
+        <p14:creationId xmlns:p14="http://schemas.microsoft.com/office/powerpoint/2010/main" val="947783469"/>
       </p:ext>
     </p:extLst>
   </p:cSld>
@@ -10297,7 +11362,7 @@
           <p:cNvPr id="30" name="">
             <a:extLst xmlns:a="http://schemas.openxmlformats.org/drawingml/2006/main">
               <a:ext uri="{FF2B5EF4-FFF2-40B4-BE49-F238E27FC236}">
-                <a16:creationId xmlns:a16="http://schemas.microsoft.com/office/drawing/2014/main" id="{1A4DB3BB-F373-4929-BA0D-3D8449A6C693}"/>
+                <a16:creationId xmlns:a16="http://schemas.microsoft.com/office/drawing/2014/main" id="{82FDE172-2FAA-4E65-B932-EB6D8734F21D}"/>
               </a:ext>
             </a:extLst>
           </p:cNvPr>
@@ -10347,7 +11412,7 @@
           <p:cNvPr id="2" name="">
             <a:extLst xmlns:a="http://schemas.openxmlformats.org/drawingml/2006/main">
               <a:ext uri="{FF2B5EF4-FFF2-40B4-BE49-F238E27FC236}">
-                <a16:creationId xmlns:a16="http://schemas.microsoft.com/office/drawing/2014/main" id="{8F07D183-BBC4-4D98-97B6-7EA046DD6343}"/>
+                <a16:creationId xmlns:a16="http://schemas.microsoft.com/office/drawing/2014/main" id="{68EB4145-9B80-40FA-8765-1AE7CEE44A3B}"/>
               </a:ext>
             </a:extLst>
           </p:cNvPr>
@@ -10397,7 +11462,7 @@
           <p:cNvPr id="3" name="">
             <a:extLst xmlns:a="http://schemas.openxmlformats.org/drawingml/2006/main">
               <a:ext uri="{FF2B5EF4-FFF2-40B4-BE49-F238E27FC236}">
-                <a16:creationId xmlns:a16="http://schemas.microsoft.com/office/drawing/2014/main" id="{F0121286-BC38-4A83-A78B-07F11AF2E7A0}"/>
+                <a16:creationId xmlns:a16="http://schemas.microsoft.com/office/drawing/2014/main" id="{1DD2E7B8-0E47-4CB5-A56E-583F93099FB1}"/>
               </a:ext>
             </a:extLst>
           </p:cNvPr>
@@ -10447,7 +11512,7 @@
           <p:cNvPr id="4" name="">
             <a:extLst xmlns:a="http://schemas.openxmlformats.org/drawingml/2006/main">
               <a:ext uri="{FF2B5EF4-FFF2-40B4-BE49-F238E27FC236}">
-                <a16:creationId xmlns:a16="http://schemas.microsoft.com/office/drawing/2014/main" id="{99E086CA-672E-4954-A7A8-ABDEC428FCAF}"/>
+                <a16:creationId xmlns:a16="http://schemas.microsoft.com/office/drawing/2014/main" id="{7A7CF901-00E3-46FE-B79D-10464974283B}"/>
               </a:ext>
             </a:extLst>
           </p:cNvPr>
@@ -10497,7 +11562,7 @@
           <p:cNvPr id="5" name="">
             <a:extLst xmlns:a="http://schemas.openxmlformats.org/drawingml/2006/main">
               <a:ext uri="{FF2B5EF4-FFF2-40B4-BE49-F238E27FC236}">
-                <a16:creationId xmlns:a16="http://schemas.microsoft.com/office/drawing/2014/main" id="{3FA6B02E-36A0-469C-8BC3-54281C28DE8E}"/>
+                <a16:creationId xmlns:a16="http://schemas.microsoft.com/office/drawing/2014/main" id="{55AA4C79-2C7D-4197-8D13-583D4068B9BD}"/>
               </a:ext>
             </a:extLst>
           </p:cNvPr>
@@ -10547,7 +11612,7 @@
           <p:cNvPr id="6" name="">
             <a:extLst xmlns:a="http://schemas.openxmlformats.org/drawingml/2006/main">
               <a:ext uri="{FF2B5EF4-FFF2-40B4-BE49-F238E27FC236}">
-                <a16:creationId xmlns:a16="http://schemas.microsoft.com/office/drawing/2014/main" id="{EDD7D095-6C34-4ACD-A543-33695D6E3D13}"/>
+                <a16:creationId xmlns:a16="http://schemas.microsoft.com/office/drawing/2014/main" id="{CF42D74B-4802-4BBE-9B04-7D3AB5F96254}"/>
               </a:ext>
             </a:extLst>
           </p:cNvPr>
@@ -10597,7 +11662,7 @@
           <p:cNvPr id="7" name="">
             <a:extLst xmlns:a="http://schemas.openxmlformats.org/drawingml/2006/main">
               <a:ext uri="{FF2B5EF4-FFF2-40B4-BE49-F238E27FC236}">
-                <a16:creationId xmlns:a16="http://schemas.microsoft.com/office/drawing/2014/main" id="{90A7373B-E4AF-4A4B-B817-7F610972BBF5}"/>
+                <a16:creationId xmlns:a16="http://schemas.microsoft.com/office/drawing/2014/main" id="{A1985043-5446-459A-B27E-89CDDDDC0536}"/>
               </a:ext>
             </a:extLst>
           </p:cNvPr>
@@ -10628,7 +11693,7 @@
           <p:cNvPr id="8" name="">
             <a:extLst xmlns:a="http://schemas.openxmlformats.org/drawingml/2006/main">
               <a:ext uri="{FF2B5EF4-FFF2-40B4-BE49-F238E27FC236}">
-                <a16:creationId xmlns:a16="http://schemas.microsoft.com/office/drawing/2014/main" id="{3360E859-BBD2-42B2-BF5B-AD7C727983A2}"/>
+                <a16:creationId xmlns:a16="http://schemas.microsoft.com/office/drawing/2014/main" id="{72AAA9B7-1FA8-43E2-BF30-A5DC78C9D640}"/>
               </a:ext>
             </a:extLst>
           </p:cNvPr>
@@ -10678,7 +11743,7 @@
           <p:cNvPr id="9" name="">
             <a:extLst xmlns:a="http://schemas.openxmlformats.org/drawingml/2006/main">
               <a:ext uri="{FF2B5EF4-FFF2-40B4-BE49-F238E27FC236}">
-                <a16:creationId xmlns:a16="http://schemas.microsoft.com/office/drawing/2014/main" id="{FC535048-07E8-48EB-B1A8-000D1E0726A1}"/>
+                <a16:creationId xmlns:a16="http://schemas.microsoft.com/office/drawing/2014/main" id="{92C11303-3FF2-4204-BCC3-883C31F2B7BA}"/>
               </a:ext>
             </a:extLst>
           </p:cNvPr>
@@ -10728,7 +11793,7 @@
           <p:cNvPr id="10" name="">
             <a:extLst xmlns:a="http://schemas.openxmlformats.org/drawingml/2006/main">
               <a:ext uri="{FF2B5EF4-FFF2-40B4-BE49-F238E27FC236}">
-                <a16:creationId xmlns:a16="http://schemas.microsoft.com/office/drawing/2014/main" id="{B5605C9D-80FF-4319-9604-3312F1AFEED3}"/>
+                <a16:creationId xmlns:a16="http://schemas.microsoft.com/office/drawing/2014/main" id="{6065BDB5-8F20-4DD3-892F-ACE682D2D3BC}"/>
               </a:ext>
             </a:extLst>
           </p:cNvPr>
@@ -10778,7 +11843,7 @@
           <p:cNvPr id="11" name="">
             <a:extLst xmlns:a="http://schemas.openxmlformats.org/drawingml/2006/main">
               <a:ext uri="{FF2B5EF4-FFF2-40B4-BE49-F238E27FC236}">
-                <a16:creationId xmlns:a16="http://schemas.microsoft.com/office/drawing/2014/main" id="{86206CFA-BF4C-4C01-95FB-2CBCC0B86F45}"/>
+                <a16:creationId xmlns:a16="http://schemas.microsoft.com/office/drawing/2014/main" id="{188455C8-CB4E-48F6-80F3-D8CB37588444}"/>
               </a:ext>
             </a:extLst>
           </p:cNvPr>
@@ -10809,7 +11874,7 @@
           <p:cNvPr id="12" name="">
             <a:extLst xmlns:a="http://schemas.openxmlformats.org/drawingml/2006/main">
               <a:ext uri="{FF2B5EF4-FFF2-40B4-BE49-F238E27FC236}">
-                <a16:creationId xmlns:a16="http://schemas.microsoft.com/office/drawing/2014/main" id="{568C7BD4-48B0-466E-B489-ED975C35C315}"/>
+                <a16:creationId xmlns:a16="http://schemas.microsoft.com/office/drawing/2014/main" id="{563536B0-A462-426E-B3F5-F216FAD7C115}"/>
               </a:ext>
             </a:extLst>
           </p:cNvPr>
@@ -10859,7 +11924,7 @@
           <p:cNvPr id="13" name="">
             <a:extLst xmlns:a="http://schemas.openxmlformats.org/drawingml/2006/main">
               <a:ext uri="{FF2B5EF4-FFF2-40B4-BE49-F238E27FC236}">
-                <a16:creationId xmlns:a16="http://schemas.microsoft.com/office/drawing/2014/main" id="{630BD626-0F3B-4093-A279-61105323B541}"/>
+                <a16:creationId xmlns:a16="http://schemas.microsoft.com/office/drawing/2014/main" id="{D2038794-3922-473B-8783-58142FBEB630}"/>
               </a:ext>
             </a:extLst>
           </p:cNvPr>
@@ -10909,7 +11974,7 @@
           <p:cNvPr id="14" name="">
             <a:extLst xmlns:a="http://schemas.openxmlformats.org/drawingml/2006/main">
               <a:ext uri="{FF2B5EF4-FFF2-40B4-BE49-F238E27FC236}">
-                <a16:creationId xmlns:a16="http://schemas.microsoft.com/office/drawing/2014/main" id="{BEFB3462-F8C3-41D1-B143-8A00ACB974C0}"/>
+                <a16:creationId xmlns:a16="http://schemas.microsoft.com/office/drawing/2014/main" id="{94A35BAF-3B00-4061-8CC3-5C030758E5BC}"/>
               </a:ext>
             </a:extLst>
           </p:cNvPr>
@@ -10959,7 +12024,7 @@
           <p:cNvPr id="15" name="">
             <a:extLst xmlns:a="http://schemas.openxmlformats.org/drawingml/2006/main">
               <a:ext uri="{FF2B5EF4-FFF2-40B4-BE49-F238E27FC236}">
-                <a16:creationId xmlns:a16="http://schemas.microsoft.com/office/drawing/2014/main" id="{8CE09E28-D762-40D0-825A-7ED68AC3C66A}"/>
+                <a16:creationId xmlns:a16="http://schemas.microsoft.com/office/drawing/2014/main" id="{76DBAC41-4FBD-45D6-A3D8-2759E4F8AC74}"/>
               </a:ext>
             </a:extLst>
           </p:cNvPr>
@@ -10990,7 +12055,7 @@
           <p:cNvPr id="16" name="">
             <a:extLst xmlns:a="http://schemas.openxmlformats.org/drawingml/2006/main">
               <a:ext uri="{FF2B5EF4-FFF2-40B4-BE49-F238E27FC236}">
-                <a16:creationId xmlns:a16="http://schemas.microsoft.com/office/drawing/2014/main" id="{4703F5C2-40D4-463C-BC9D-CDC8E5CEBC45}"/>
+                <a16:creationId xmlns:a16="http://schemas.microsoft.com/office/drawing/2014/main" id="{341E2606-AB44-4857-AC99-2A285B84C9A8}"/>
               </a:ext>
             </a:extLst>
           </p:cNvPr>
@@ -11040,7 +12105,7 @@
           <p:cNvPr id="17" name="">
             <a:extLst xmlns:a="http://schemas.openxmlformats.org/drawingml/2006/main">
               <a:ext uri="{FF2B5EF4-FFF2-40B4-BE49-F238E27FC236}">
-                <a16:creationId xmlns:a16="http://schemas.microsoft.com/office/drawing/2014/main" id="{0D04C1C1-9E7D-48FD-9CBF-27D12D326CEC}"/>
+                <a16:creationId xmlns:a16="http://schemas.microsoft.com/office/drawing/2014/main" id="{6DB83F81-F0DD-4CA4-A5AC-E7906EAEA233}"/>
               </a:ext>
             </a:extLst>
           </p:cNvPr>
@@ -11090,7 +12155,7 @@
           <p:cNvPr id="18" name="">
             <a:extLst xmlns:a="http://schemas.openxmlformats.org/drawingml/2006/main">
               <a:ext uri="{FF2B5EF4-FFF2-40B4-BE49-F238E27FC236}">
-                <a16:creationId xmlns:a16="http://schemas.microsoft.com/office/drawing/2014/main" id="{4F3408C1-55D3-43A8-A331-BD384151D16A}"/>
+                <a16:creationId xmlns:a16="http://schemas.microsoft.com/office/drawing/2014/main" id="{AB2AA210-8576-4D6D-B7CF-B78EC168DCC7}"/>
               </a:ext>
             </a:extLst>
           </p:cNvPr>
@@ -11140,7 +12205,7 @@
           <p:cNvPr id="19" name="">
             <a:extLst xmlns:a="http://schemas.openxmlformats.org/drawingml/2006/main">
               <a:ext uri="{FF2B5EF4-FFF2-40B4-BE49-F238E27FC236}">
-                <a16:creationId xmlns:a16="http://schemas.microsoft.com/office/drawing/2014/main" id="{B0DB0621-5767-45FB-A88D-4853D250D977}"/>
+                <a16:creationId xmlns:a16="http://schemas.microsoft.com/office/drawing/2014/main" id="{CF58F1EF-19C1-4BCC-A896-0D898FA4D171}"/>
               </a:ext>
             </a:extLst>
           </p:cNvPr>
@@ -11171,7 +12236,7 @@
           <p:cNvPr id="20" name="">
             <a:extLst xmlns:a="http://schemas.openxmlformats.org/drawingml/2006/main">
               <a:ext uri="{FF2B5EF4-FFF2-40B4-BE49-F238E27FC236}">
-                <a16:creationId xmlns:a16="http://schemas.microsoft.com/office/drawing/2014/main" id="{7B751254-5334-4766-9E9F-18075D2E070E}"/>
+                <a16:creationId xmlns:a16="http://schemas.microsoft.com/office/drawing/2014/main" id="{8D1D5A86-1966-4172-8C6B-194EC088B672}"/>
               </a:ext>
             </a:extLst>
           </p:cNvPr>
@@ -11221,7 +12286,7 @@
           <p:cNvPr id="21" name="">
             <a:extLst xmlns:a="http://schemas.openxmlformats.org/drawingml/2006/main">
               <a:ext uri="{FF2B5EF4-FFF2-40B4-BE49-F238E27FC236}">
-                <a16:creationId xmlns:a16="http://schemas.microsoft.com/office/drawing/2014/main" id="{A7DC01C0-14E7-4F77-9666-CFC6A316D589}"/>
+                <a16:creationId xmlns:a16="http://schemas.microsoft.com/office/drawing/2014/main" id="{3D0483C6-8BA4-4DCF-9864-D8594BD20AD2}"/>
               </a:ext>
             </a:extLst>
           </p:cNvPr>
@@ -11271,7 +12336,7 @@
           <p:cNvPr id="22" name="">
             <a:extLst xmlns:a="http://schemas.openxmlformats.org/drawingml/2006/main">
               <a:ext uri="{FF2B5EF4-FFF2-40B4-BE49-F238E27FC236}">
-                <a16:creationId xmlns:a16="http://schemas.microsoft.com/office/drawing/2014/main" id="{0FA2D922-DAF8-4271-B753-5023CA44F2E5}"/>
+                <a16:creationId xmlns:a16="http://schemas.microsoft.com/office/drawing/2014/main" id="{1A635EE7-D8BB-40EC-A24A-AEFF6F173921}"/>
               </a:ext>
             </a:extLst>
           </p:cNvPr>
@@ -11321,7 +12386,7 @@
           <p:cNvPr id="23" name="">
             <a:extLst xmlns:a="http://schemas.openxmlformats.org/drawingml/2006/main">
               <a:ext uri="{FF2B5EF4-FFF2-40B4-BE49-F238E27FC236}">
-                <a16:creationId xmlns:a16="http://schemas.microsoft.com/office/drawing/2014/main" id="{7465995B-1ED6-4335-9749-E2A2070B0E71}"/>
+                <a16:creationId xmlns:a16="http://schemas.microsoft.com/office/drawing/2014/main" id="{41DF60D7-A9AF-4D56-9E60-884DF0AC2E78}"/>
               </a:ext>
             </a:extLst>
           </p:cNvPr>
@@ -11352,7 +12417,7 @@
           <p:cNvPr id="24" name="">
             <a:extLst xmlns:a="http://schemas.openxmlformats.org/drawingml/2006/main">
               <a:ext uri="{FF2B5EF4-FFF2-40B4-BE49-F238E27FC236}">
-                <a16:creationId xmlns:a16="http://schemas.microsoft.com/office/drawing/2014/main" id="{2D2F123F-3928-4FD2-9318-082E192B2C24}"/>
+                <a16:creationId xmlns:a16="http://schemas.microsoft.com/office/drawing/2014/main" id="{A8846C43-A465-4606-B465-946472BD6ACC}"/>
               </a:ext>
             </a:extLst>
           </p:cNvPr>
@@ -11402,7 +12467,7 @@
           <p:cNvPr id="25" name="">
             <a:extLst xmlns:a="http://schemas.openxmlformats.org/drawingml/2006/main">
               <a:ext uri="{FF2B5EF4-FFF2-40B4-BE49-F238E27FC236}">
-                <a16:creationId xmlns:a16="http://schemas.microsoft.com/office/drawing/2014/main" id="{7E454442-D19D-4F7D-AD05-A1B78C0DC90E}"/>
+                <a16:creationId xmlns:a16="http://schemas.microsoft.com/office/drawing/2014/main" id="{D6AFD7F3-0AF4-418C-8F98-F3389D0E8C41}"/>
               </a:ext>
             </a:extLst>
           </p:cNvPr>
@@ -11452,7 +12517,7 @@
           <p:cNvPr id="26" name="">
             <a:extLst xmlns:a="http://schemas.openxmlformats.org/drawingml/2006/main">
               <a:ext uri="{FF2B5EF4-FFF2-40B4-BE49-F238E27FC236}">
-                <a16:creationId xmlns:a16="http://schemas.microsoft.com/office/drawing/2014/main" id="{62A95F16-A612-419B-8AC8-1B1B25145872}"/>
+                <a16:creationId xmlns:a16="http://schemas.microsoft.com/office/drawing/2014/main" id="{7B903C65-4018-4479-A6A4-91E1B4E55780}"/>
               </a:ext>
             </a:extLst>
           </p:cNvPr>
@@ -11502,7 +12567,7 @@
           <p:cNvPr id="27" name="">
             <a:extLst xmlns:a="http://schemas.openxmlformats.org/drawingml/2006/main">
               <a:ext uri="{FF2B5EF4-FFF2-40B4-BE49-F238E27FC236}">
-                <a16:creationId xmlns:a16="http://schemas.microsoft.com/office/drawing/2014/main" id="{1A4A99B3-A093-4ABC-B58B-F23F2A1B4AEC}"/>
+                <a16:creationId xmlns:a16="http://schemas.microsoft.com/office/drawing/2014/main" id="{DFE5DC1A-9FF7-4B71-A5EB-016DFFE11AE1}"/>
               </a:ext>
             </a:extLst>
           </p:cNvPr>
@@ -11533,7 +12598,7 @@
           <p:cNvPr id="28" name="">
             <a:extLst xmlns:a="http://schemas.openxmlformats.org/drawingml/2006/main">
               <a:ext uri="{FF2B5EF4-FFF2-40B4-BE49-F238E27FC236}">
-                <a16:creationId xmlns:a16="http://schemas.microsoft.com/office/drawing/2014/main" id="{98308C9F-1D9E-4FBD-8507-FD1B69EF5533}"/>
+                <a16:creationId xmlns:a16="http://schemas.microsoft.com/office/drawing/2014/main" id="{7ECE834D-4065-4248-B806-282E831DBF98}"/>
               </a:ext>
             </a:extLst>
           </p:cNvPr>
@@ -11583,7 +12648,7 @@
           <p:cNvPr id="29" name="">
             <a:extLst xmlns:a="http://schemas.openxmlformats.org/drawingml/2006/main">
               <a:ext uri="{FF2B5EF4-FFF2-40B4-BE49-F238E27FC236}">
-                <a16:creationId xmlns:a16="http://schemas.microsoft.com/office/drawing/2014/main" id="{AF9953C3-B399-43C4-B04F-89D51655D54C}"/>
+                <a16:creationId xmlns:a16="http://schemas.microsoft.com/office/drawing/2014/main" id="{0A31FA8E-CC7F-4957-85CA-663F2B51D0FA}"/>
               </a:ext>
             </a:extLst>
           </p:cNvPr>
@@ -11631,7 +12696,7 @@
     </p:spTree>
     <p:extLst>
       <p:ext uri="{BB962C8B-B14F-4D97-AF65-F5344CB8AC3E}">
-        <p14:creationId xmlns:p14="http://schemas.microsoft.com/office/powerpoint/2010/main" val="807984699"/>
+        <p14:creationId xmlns:p14="http://schemas.microsoft.com/office/powerpoint/2010/main" val="1455041985"/>
       </p:ext>
     </p:extLst>
   </p:cSld>
@@ -11662,7 +12727,7 @@
           <p:cNvPr id="22" name="">
             <a:extLst xmlns:a="http://schemas.openxmlformats.org/drawingml/2006/main">
               <a:ext uri="{FF2B5EF4-FFF2-40B4-BE49-F238E27FC236}">
-                <a16:creationId xmlns:a16="http://schemas.microsoft.com/office/drawing/2014/main" id="{C7B8A0AC-DF34-42A5-8B38-A7B36CE1C9E1}"/>
+                <a16:creationId xmlns:a16="http://schemas.microsoft.com/office/drawing/2014/main" id="{E394AF10-B862-4330-81AD-8F039245C845}"/>
               </a:ext>
             </a:extLst>
           </p:cNvPr>
@@ -11712,7 +12777,7 @@
           <p:cNvPr id="2" name="">
             <a:extLst xmlns:a="http://schemas.openxmlformats.org/drawingml/2006/main">
               <a:ext uri="{FF2B5EF4-FFF2-40B4-BE49-F238E27FC236}">
-                <a16:creationId xmlns:a16="http://schemas.microsoft.com/office/drawing/2014/main" id="{C8AA6F85-9C26-4628-84BA-F9AF7B8E5A84}"/>
+                <a16:creationId xmlns:a16="http://schemas.microsoft.com/office/drawing/2014/main" id="{775FD813-1241-4E8D-B0EA-4DA5B4A9BE91}"/>
               </a:ext>
             </a:extLst>
           </p:cNvPr>
@@ -11762,7 +12827,7 @@
           <p:cNvPr id="3" name="">
             <a:extLst xmlns:a="http://schemas.openxmlformats.org/drawingml/2006/main">
               <a:ext uri="{FF2B5EF4-FFF2-40B4-BE49-F238E27FC236}">
-                <a16:creationId xmlns:a16="http://schemas.microsoft.com/office/drawing/2014/main" id="{5BE7C60E-906B-4389-A2A9-91E5C3094AF7}"/>
+                <a16:creationId xmlns:a16="http://schemas.microsoft.com/office/drawing/2014/main" id="{C56B588B-3A29-4997-ACD6-484F2A84155E}"/>
               </a:ext>
             </a:extLst>
           </p:cNvPr>
@@ -11797,7 +12862,7 @@
           <p:cNvPr id="4" name="">
             <a:extLst xmlns:a="http://schemas.openxmlformats.org/drawingml/2006/main">
               <a:ext uri="{FF2B5EF4-FFF2-40B4-BE49-F238E27FC236}">
-                <a16:creationId xmlns:a16="http://schemas.microsoft.com/office/drawing/2014/main" id="{9798F660-F33B-4EE5-9E8C-076059B613C4}"/>
+                <a16:creationId xmlns:a16="http://schemas.microsoft.com/office/drawing/2014/main" id="{54065668-FF36-4D8D-A579-265A576928D4}"/>
               </a:ext>
             </a:extLst>
           </p:cNvPr>
@@ -11847,7 +12912,7 @@
           <p:cNvPr id="5" name="">
             <a:extLst xmlns:a="http://schemas.openxmlformats.org/drawingml/2006/main">
               <a:ext uri="{FF2B5EF4-FFF2-40B4-BE49-F238E27FC236}">
-                <a16:creationId xmlns:a16="http://schemas.microsoft.com/office/drawing/2014/main" id="{337B72CF-BBA5-4097-B45F-5F369183392C}"/>
+                <a16:creationId xmlns:a16="http://schemas.microsoft.com/office/drawing/2014/main" id="{D2551B40-A604-4863-A501-B8F2DA2A4691}"/>
               </a:ext>
             </a:extLst>
           </p:cNvPr>
@@ -11897,7 +12962,7 @@
           <p:cNvPr id="6" name="">
             <a:extLst xmlns:a="http://schemas.openxmlformats.org/drawingml/2006/main">
               <a:ext uri="{FF2B5EF4-FFF2-40B4-BE49-F238E27FC236}">
-                <a16:creationId xmlns:a16="http://schemas.microsoft.com/office/drawing/2014/main" id="{B833D496-202F-4074-B1C5-E540BBBCFA32}"/>
+                <a16:creationId xmlns:a16="http://schemas.microsoft.com/office/drawing/2014/main" id="{787862ED-66A2-4E45-8635-0DAE2EA24AA3}"/>
               </a:ext>
             </a:extLst>
           </p:cNvPr>
@@ -11947,7 +13012,7 @@
           <p:cNvPr id="7" name="">
             <a:extLst xmlns:a="http://schemas.openxmlformats.org/drawingml/2006/main">
               <a:ext uri="{FF2B5EF4-FFF2-40B4-BE49-F238E27FC236}">
-                <a16:creationId xmlns:a16="http://schemas.microsoft.com/office/drawing/2014/main" id="{6CFF1FE5-E8DD-4D83-8740-B2D3F272125C}"/>
+                <a16:creationId xmlns:a16="http://schemas.microsoft.com/office/drawing/2014/main" id="{0B120AC1-9CB3-45DE-9E1E-248B7F543BAB}"/>
               </a:ext>
             </a:extLst>
           </p:cNvPr>
@@ -11982,7 +13047,7 @@
           <p:cNvPr id="8" name="">
             <a:extLst xmlns:a="http://schemas.openxmlformats.org/drawingml/2006/main">
               <a:ext uri="{FF2B5EF4-FFF2-40B4-BE49-F238E27FC236}">
-                <a16:creationId xmlns:a16="http://schemas.microsoft.com/office/drawing/2014/main" id="{5AB01DCE-5231-42D4-BEE1-6F1A61C08541}"/>
+                <a16:creationId xmlns:a16="http://schemas.microsoft.com/office/drawing/2014/main" id="{4DD6EF0F-F925-42C6-8123-17173B93B457}"/>
               </a:ext>
             </a:extLst>
           </p:cNvPr>
@@ -12032,7 +13097,7 @@
           <p:cNvPr id="9" name="">
             <a:extLst xmlns:a="http://schemas.openxmlformats.org/drawingml/2006/main">
               <a:ext uri="{FF2B5EF4-FFF2-40B4-BE49-F238E27FC236}">
-                <a16:creationId xmlns:a16="http://schemas.microsoft.com/office/drawing/2014/main" id="{AA1BDE06-2585-41E2-899F-E8A639AB2C89}"/>
+                <a16:creationId xmlns:a16="http://schemas.microsoft.com/office/drawing/2014/main" id="{A2464C43-A2F3-4C6F-B60C-F0B823D52C13}"/>
               </a:ext>
             </a:extLst>
           </p:cNvPr>
@@ -12082,7 +13147,7 @@
           <p:cNvPr id="10" name="">
             <a:extLst xmlns:a="http://schemas.openxmlformats.org/drawingml/2006/main">
               <a:ext uri="{FF2B5EF4-FFF2-40B4-BE49-F238E27FC236}">
-                <a16:creationId xmlns:a16="http://schemas.microsoft.com/office/drawing/2014/main" id="{270B8835-5C42-489E-82C9-36D481D414F6}"/>
+                <a16:creationId xmlns:a16="http://schemas.microsoft.com/office/drawing/2014/main" id="{1BFD989F-6FA6-40CB-80CC-0946D8412762}"/>
               </a:ext>
             </a:extLst>
           </p:cNvPr>
@@ -12132,7 +13197,7 @@
           <p:cNvPr id="11" name="">
             <a:extLst xmlns:a="http://schemas.openxmlformats.org/drawingml/2006/main">
               <a:ext uri="{FF2B5EF4-FFF2-40B4-BE49-F238E27FC236}">
-                <a16:creationId xmlns:a16="http://schemas.microsoft.com/office/drawing/2014/main" id="{4FDCE689-4CFA-4170-8B31-99F1DA2DF19F}"/>
+                <a16:creationId xmlns:a16="http://schemas.microsoft.com/office/drawing/2014/main" id="{6A028467-998C-454E-8312-036C2B236755}"/>
               </a:ext>
             </a:extLst>
           </p:cNvPr>
@@ -12167,7 +13232,7 @@
           <p:cNvPr id="12" name="">
             <a:extLst xmlns:a="http://schemas.openxmlformats.org/drawingml/2006/main">
               <a:ext uri="{FF2B5EF4-FFF2-40B4-BE49-F238E27FC236}">
-                <a16:creationId xmlns:a16="http://schemas.microsoft.com/office/drawing/2014/main" id="{8DCB834D-2866-49E0-8D1B-46CBF00E1050}"/>
+                <a16:creationId xmlns:a16="http://schemas.microsoft.com/office/drawing/2014/main" id="{A0113E13-05D8-48F7-8CFA-FDA3654EAC1A}"/>
               </a:ext>
             </a:extLst>
           </p:cNvPr>
@@ -12217,7 +13282,7 @@
           <p:cNvPr id="13" name="">
             <a:extLst xmlns:a="http://schemas.openxmlformats.org/drawingml/2006/main">
               <a:ext uri="{FF2B5EF4-FFF2-40B4-BE49-F238E27FC236}">
-                <a16:creationId xmlns:a16="http://schemas.microsoft.com/office/drawing/2014/main" id="{C40E2E73-C675-4D51-ABF9-11774C2A9B03}"/>
+                <a16:creationId xmlns:a16="http://schemas.microsoft.com/office/drawing/2014/main" id="{910E6514-23EC-4269-B209-9795BF381772}"/>
               </a:ext>
             </a:extLst>
           </p:cNvPr>
@@ -12267,7 +13332,7 @@
           <p:cNvPr id="14" name="">
             <a:extLst xmlns:a="http://schemas.openxmlformats.org/drawingml/2006/main">
               <a:ext uri="{FF2B5EF4-FFF2-40B4-BE49-F238E27FC236}">
-                <a16:creationId xmlns:a16="http://schemas.microsoft.com/office/drawing/2014/main" id="{C0A35010-B2B5-4337-AA09-F7F82AC981F2}"/>
+                <a16:creationId xmlns:a16="http://schemas.microsoft.com/office/drawing/2014/main" id="{BB428FEF-0842-46DC-973D-B81F00039B54}"/>
               </a:ext>
             </a:extLst>
           </p:cNvPr>
@@ -12317,7 +13382,7 @@
           <p:cNvPr id="15" name="">
             <a:extLst xmlns:a="http://schemas.openxmlformats.org/drawingml/2006/main">
               <a:ext uri="{FF2B5EF4-FFF2-40B4-BE49-F238E27FC236}">
-                <a16:creationId xmlns:a16="http://schemas.microsoft.com/office/drawing/2014/main" id="{5C793B7C-958F-407E-9661-622F822CA9AB}"/>
+                <a16:creationId xmlns:a16="http://schemas.microsoft.com/office/drawing/2014/main" id="{B9C72D17-F4E8-43BC-A00E-6AF49B1AE365}"/>
               </a:ext>
             </a:extLst>
           </p:cNvPr>
@@ -12352,7 +13417,7 @@
           <p:cNvPr id="16" name="">
             <a:extLst xmlns:a="http://schemas.openxmlformats.org/drawingml/2006/main">
               <a:ext uri="{FF2B5EF4-FFF2-40B4-BE49-F238E27FC236}">
-                <a16:creationId xmlns:a16="http://schemas.microsoft.com/office/drawing/2014/main" id="{B671F34F-4A5C-42B5-A939-BB61C1B001A2}"/>
+                <a16:creationId xmlns:a16="http://schemas.microsoft.com/office/drawing/2014/main" id="{E6435A87-71E7-498A-A1C1-67C6B279ADF4}"/>
               </a:ext>
             </a:extLst>
           </p:cNvPr>
@@ -12402,7 +13467,7 @@
           <p:cNvPr id="17" name="">
             <a:extLst xmlns:a="http://schemas.openxmlformats.org/drawingml/2006/main">
               <a:ext uri="{FF2B5EF4-FFF2-40B4-BE49-F238E27FC236}">
-                <a16:creationId xmlns:a16="http://schemas.microsoft.com/office/drawing/2014/main" id="{49DDD4A4-516E-456A-B720-40EC837D2566}"/>
+                <a16:creationId xmlns:a16="http://schemas.microsoft.com/office/drawing/2014/main" id="{14183159-75A8-4C13-9274-77C670EF4F91}"/>
               </a:ext>
             </a:extLst>
           </p:cNvPr>
@@ -12452,7 +13517,7 @@
           <p:cNvPr id="18" name="">
             <a:extLst xmlns:a="http://schemas.openxmlformats.org/drawingml/2006/main">
               <a:ext uri="{FF2B5EF4-FFF2-40B4-BE49-F238E27FC236}">
-                <a16:creationId xmlns:a16="http://schemas.microsoft.com/office/drawing/2014/main" id="{562C9C20-4653-4EFB-897B-F58BC33BA31A}"/>
+                <a16:creationId xmlns:a16="http://schemas.microsoft.com/office/drawing/2014/main" id="{C9E56922-2381-4BE8-9929-E8CB952AD4D0}"/>
               </a:ext>
             </a:extLst>
           </p:cNvPr>
@@ -12502,7 +13567,7 @@
           <p:cNvPr id="19" name="">
             <a:extLst xmlns:a="http://schemas.openxmlformats.org/drawingml/2006/main">
               <a:ext uri="{FF2B5EF4-FFF2-40B4-BE49-F238E27FC236}">
-                <a16:creationId xmlns:a16="http://schemas.microsoft.com/office/drawing/2014/main" id="{5D32C1BE-44F7-4140-9F78-6B09007DADEB}"/>
+                <a16:creationId xmlns:a16="http://schemas.microsoft.com/office/drawing/2014/main" id="{C5999236-9E6B-467D-858A-6BBB5248F437}"/>
               </a:ext>
             </a:extLst>
           </p:cNvPr>
@@ -12552,7 +13617,7 @@
           <p:cNvPr id="20" name="">
             <a:extLst xmlns:a="http://schemas.openxmlformats.org/drawingml/2006/main">
               <a:ext uri="{FF2B5EF4-FFF2-40B4-BE49-F238E27FC236}">
-                <a16:creationId xmlns:a16="http://schemas.microsoft.com/office/drawing/2014/main" id="{A142B97F-C155-4038-9040-D1B4BEB9D471}"/>
+                <a16:creationId xmlns:a16="http://schemas.microsoft.com/office/drawing/2014/main" id="{30446C63-9228-4753-BA40-B06A1DB944C4}"/>
               </a:ext>
             </a:extLst>
           </p:cNvPr>
@@ -12602,7 +13667,7 @@
           <p:cNvPr id="21" name="">
             <a:extLst xmlns:a="http://schemas.openxmlformats.org/drawingml/2006/main">
               <a:ext uri="{FF2B5EF4-FFF2-40B4-BE49-F238E27FC236}">
-                <a16:creationId xmlns:a16="http://schemas.microsoft.com/office/drawing/2014/main" id="{97F5BFE3-9239-4B20-AD88-5AE1DB263E85}"/>
+                <a16:creationId xmlns:a16="http://schemas.microsoft.com/office/drawing/2014/main" id="{DF0A4A06-176F-4F0D-9B7E-0043AF70703E}"/>
               </a:ext>
             </a:extLst>
           </p:cNvPr>
@@ -12650,7 +13715,7 @@
     </p:spTree>
     <p:extLst>
       <p:ext uri="{BB962C8B-B14F-4D97-AF65-F5344CB8AC3E}">
-        <p14:creationId xmlns:p14="http://schemas.microsoft.com/office/powerpoint/2010/main" val="1609837136"/>
+        <p14:creationId xmlns:p14="http://schemas.microsoft.com/office/powerpoint/2010/main" val="1843701208"/>
       </p:ext>
     </p:extLst>
   </p:cSld>
@@ -12681,7 +13746,7 @@
           <p:cNvPr id="29" name="">
             <a:extLst xmlns:a="http://schemas.openxmlformats.org/drawingml/2006/main">
               <a:ext uri="{FF2B5EF4-FFF2-40B4-BE49-F238E27FC236}">
-                <a16:creationId xmlns:a16="http://schemas.microsoft.com/office/drawing/2014/main" id="{7FB1E712-5856-421C-91FA-2E279B9FA29E}"/>
+                <a16:creationId xmlns:a16="http://schemas.microsoft.com/office/drawing/2014/main" id="{10D9D419-85A1-44A6-A37E-69DBD5FBEE84}"/>
               </a:ext>
             </a:extLst>
           </p:cNvPr>
@@ -12731,7 +13796,7 @@
           <p:cNvPr id="2" name="">
             <a:extLst xmlns:a="http://schemas.openxmlformats.org/drawingml/2006/main">
               <a:ext uri="{FF2B5EF4-FFF2-40B4-BE49-F238E27FC236}">
-                <a16:creationId xmlns:a16="http://schemas.microsoft.com/office/drawing/2014/main" id="{9D9600EA-0C09-45C4-AF5F-19E7E5016148}"/>
+                <a16:creationId xmlns:a16="http://schemas.microsoft.com/office/drawing/2014/main" id="{F5A44A9B-6CF1-433C-A662-C0B138C93B0C}"/>
               </a:ext>
             </a:extLst>
           </p:cNvPr>
@@ -12781,7 +13846,7 @@
           <p:cNvPr id="3" name="">
             <a:extLst xmlns:a="http://schemas.openxmlformats.org/drawingml/2006/main">
               <a:ext uri="{FF2B5EF4-FFF2-40B4-BE49-F238E27FC236}">
-                <a16:creationId xmlns:a16="http://schemas.microsoft.com/office/drawing/2014/main" id="{D2467682-7B9E-47D6-978D-8F7A45C61EFB}"/>
+                <a16:creationId xmlns:a16="http://schemas.microsoft.com/office/drawing/2014/main" id="{C7D28A98-555B-4AA7-84EA-B3DF84472102}"/>
               </a:ext>
             </a:extLst>
           </p:cNvPr>
@@ -12814,7 +13879,7 @@
           <p:cNvPr id="4" name="">
             <a:extLst xmlns:a="http://schemas.openxmlformats.org/drawingml/2006/main">
               <a:ext uri="{FF2B5EF4-FFF2-40B4-BE49-F238E27FC236}">
-                <a16:creationId xmlns:a16="http://schemas.microsoft.com/office/drawing/2014/main" id="{541DF6B1-D8A2-4BF4-B18B-653C1358E40C}"/>
+                <a16:creationId xmlns:a16="http://schemas.microsoft.com/office/drawing/2014/main" id="{802AD7AA-F3DE-4F13-9AF9-D67EA060F15C}"/>
               </a:ext>
             </a:extLst>
           </p:cNvPr>
@@ -12864,7 +13929,7 @@
           <p:cNvPr id="5" name="">
             <a:extLst xmlns:a="http://schemas.openxmlformats.org/drawingml/2006/main">
               <a:ext uri="{FF2B5EF4-FFF2-40B4-BE49-F238E27FC236}">
-                <a16:creationId xmlns:a16="http://schemas.microsoft.com/office/drawing/2014/main" id="{CF4BD5C1-4095-40CB-A19B-3C7A5C73E3B7}"/>
+                <a16:creationId xmlns:a16="http://schemas.microsoft.com/office/drawing/2014/main" id="{0A5814BB-860B-49E4-BD3D-8B7C667B4F35}"/>
               </a:ext>
             </a:extLst>
           </p:cNvPr>
@@ -12914,7 +13979,7 @@
           <p:cNvPr id="6" name="">
             <a:extLst xmlns:a="http://schemas.openxmlformats.org/drawingml/2006/main">
               <a:ext uri="{FF2B5EF4-FFF2-40B4-BE49-F238E27FC236}">
-                <a16:creationId xmlns:a16="http://schemas.microsoft.com/office/drawing/2014/main" id="{38FFC878-D15B-418E-AE9F-19E86FF23CDB}"/>
+                <a16:creationId xmlns:a16="http://schemas.microsoft.com/office/drawing/2014/main" id="{7F9CBFF5-AA85-4700-92F3-7091B8B28F06}"/>
               </a:ext>
             </a:extLst>
           </p:cNvPr>
@@ -12964,7 +14029,7 @@
           <p:cNvPr id="7" name="">
             <a:extLst xmlns:a="http://schemas.openxmlformats.org/drawingml/2006/main">
               <a:ext uri="{FF2B5EF4-FFF2-40B4-BE49-F238E27FC236}">
-                <a16:creationId xmlns:a16="http://schemas.microsoft.com/office/drawing/2014/main" id="{CDCEF09A-CBA0-4B1E-A5EF-3123DB9ADFD4}"/>
+                <a16:creationId xmlns:a16="http://schemas.microsoft.com/office/drawing/2014/main" id="{0F0BE873-D7CB-46BC-8D64-455E7BAFDE0F}"/>
               </a:ext>
             </a:extLst>
           </p:cNvPr>
@@ -12995,7 +14060,7 @@
           <p:cNvPr id="8" name="">
             <a:extLst xmlns:a="http://schemas.openxmlformats.org/drawingml/2006/main">
               <a:ext uri="{FF2B5EF4-FFF2-40B4-BE49-F238E27FC236}">
-                <a16:creationId xmlns:a16="http://schemas.microsoft.com/office/drawing/2014/main" id="{50E233C0-E414-4426-8102-4BD7ACEE4597}"/>
+                <a16:creationId xmlns:a16="http://schemas.microsoft.com/office/drawing/2014/main" id="{44EA58D6-35EC-42ED-8164-7247719EE309}"/>
               </a:ext>
             </a:extLst>
           </p:cNvPr>
@@ -13028,7 +14093,7 @@
           <p:cNvPr id="9" name="">
             <a:extLst xmlns:a="http://schemas.openxmlformats.org/drawingml/2006/main">
               <a:ext uri="{FF2B5EF4-FFF2-40B4-BE49-F238E27FC236}">
-                <a16:creationId xmlns:a16="http://schemas.microsoft.com/office/drawing/2014/main" id="{F2522E5C-CDBD-4A8D-8D69-B491F31934E9}"/>
+                <a16:creationId xmlns:a16="http://schemas.microsoft.com/office/drawing/2014/main" id="{FAB1ABEF-6B4D-41B0-A1A1-7FEBEDA4866C}"/>
               </a:ext>
             </a:extLst>
           </p:cNvPr>
@@ -13078,7 +14143,7 @@
           <p:cNvPr id="10" name="">
             <a:extLst xmlns:a="http://schemas.openxmlformats.org/drawingml/2006/main">
               <a:ext uri="{FF2B5EF4-FFF2-40B4-BE49-F238E27FC236}">
-                <a16:creationId xmlns:a16="http://schemas.microsoft.com/office/drawing/2014/main" id="{CA14652A-77BE-47BA-B14C-1C1D13D4964E}"/>
+                <a16:creationId xmlns:a16="http://schemas.microsoft.com/office/drawing/2014/main" id="{CF7A5DAD-0133-4F32-8C7C-F5AB7382EAE1}"/>
               </a:ext>
             </a:extLst>
           </p:cNvPr>
@@ -13128,7 +14193,7 @@
           <p:cNvPr id="11" name="">
             <a:extLst xmlns:a="http://schemas.openxmlformats.org/drawingml/2006/main">
               <a:ext uri="{FF2B5EF4-FFF2-40B4-BE49-F238E27FC236}">
-                <a16:creationId xmlns:a16="http://schemas.microsoft.com/office/drawing/2014/main" id="{F85A18C3-6CE6-4486-AD75-6E8CA17E4F7B}"/>
+                <a16:creationId xmlns:a16="http://schemas.microsoft.com/office/drawing/2014/main" id="{FFAC463E-7ABF-44AA-A2E1-A0F3E8EAE465}"/>
               </a:ext>
             </a:extLst>
           </p:cNvPr>
@@ -13178,7 +14243,7 @@
           <p:cNvPr id="12" name="">
             <a:extLst xmlns:a="http://schemas.openxmlformats.org/drawingml/2006/main">
               <a:ext uri="{FF2B5EF4-FFF2-40B4-BE49-F238E27FC236}">
-                <a16:creationId xmlns:a16="http://schemas.microsoft.com/office/drawing/2014/main" id="{445AC638-DEC3-438B-BB88-672EBEDBDBD0}"/>
+                <a16:creationId xmlns:a16="http://schemas.microsoft.com/office/drawing/2014/main" id="{B92CF15B-CD4F-44B6-AA6C-AA4DE4EC7EF5}"/>
               </a:ext>
             </a:extLst>
           </p:cNvPr>
@@ -13209,7 +14274,7 @@
           <p:cNvPr id="13" name="">
             <a:extLst xmlns:a="http://schemas.openxmlformats.org/drawingml/2006/main">
               <a:ext uri="{FF2B5EF4-FFF2-40B4-BE49-F238E27FC236}">
-                <a16:creationId xmlns:a16="http://schemas.microsoft.com/office/drawing/2014/main" id="{D9A1BC89-8DB4-46AF-BC41-B4E8B575F127}"/>
+                <a16:creationId xmlns:a16="http://schemas.microsoft.com/office/drawing/2014/main" id="{D6694350-02FB-4C37-887B-EC5E8512857E}"/>
               </a:ext>
             </a:extLst>
           </p:cNvPr>
@@ -13242,7 +14307,7 @@
           <p:cNvPr id="14" name="">
             <a:extLst xmlns:a="http://schemas.openxmlformats.org/drawingml/2006/main">
               <a:ext uri="{FF2B5EF4-FFF2-40B4-BE49-F238E27FC236}">
-                <a16:creationId xmlns:a16="http://schemas.microsoft.com/office/drawing/2014/main" id="{BE8F63AB-6152-4885-809C-26B62D592170}"/>
+                <a16:creationId xmlns:a16="http://schemas.microsoft.com/office/drawing/2014/main" id="{5AFE4450-FDE9-4917-82FE-564F9BADA958}"/>
               </a:ext>
             </a:extLst>
           </p:cNvPr>
@@ -13292,7 +14357,7 @@
           <p:cNvPr id="15" name="">
             <a:extLst xmlns:a="http://schemas.openxmlformats.org/drawingml/2006/main">
               <a:ext uri="{FF2B5EF4-FFF2-40B4-BE49-F238E27FC236}">
-                <a16:creationId xmlns:a16="http://schemas.microsoft.com/office/drawing/2014/main" id="{FF3A828B-5767-4E4E-BA75-3BD396551B4C}"/>
+                <a16:creationId xmlns:a16="http://schemas.microsoft.com/office/drawing/2014/main" id="{D8E143C0-D9D8-413C-B75E-0D2F7E730B7C}"/>
               </a:ext>
             </a:extLst>
           </p:cNvPr>
@@ -13342,7 +14407,7 @@
           <p:cNvPr id="16" name="">
             <a:extLst xmlns:a="http://schemas.openxmlformats.org/drawingml/2006/main">
               <a:ext uri="{FF2B5EF4-FFF2-40B4-BE49-F238E27FC236}">
-                <a16:creationId xmlns:a16="http://schemas.microsoft.com/office/drawing/2014/main" id="{CAEF1570-F33F-4BC9-8A54-45BEB7F5191B}"/>
+                <a16:creationId xmlns:a16="http://schemas.microsoft.com/office/drawing/2014/main" id="{E99D324E-1D4E-4136-92DD-73010710E0F6}"/>
               </a:ext>
             </a:extLst>
           </p:cNvPr>
@@ -13392,7 +14457,7 @@
           <p:cNvPr id="17" name="">
             <a:extLst xmlns:a="http://schemas.openxmlformats.org/drawingml/2006/main">
               <a:ext uri="{FF2B5EF4-FFF2-40B4-BE49-F238E27FC236}">
-                <a16:creationId xmlns:a16="http://schemas.microsoft.com/office/drawing/2014/main" id="{BBC3A596-F787-4550-BD9A-60ED03516295}"/>
+                <a16:creationId xmlns:a16="http://schemas.microsoft.com/office/drawing/2014/main" id="{C5EA0A9C-AFFB-4366-B4A6-6D5E167935C0}"/>
               </a:ext>
             </a:extLst>
           </p:cNvPr>
@@ -13423,7 +14488,7 @@
           <p:cNvPr id="18" name="">
             <a:extLst xmlns:a="http://schemas.openxmlformats.org/drawingml/2006/main">
               <a:ext uri="{FF2B5EF4-FFF2-40B4-BE49-F238E27FC236}">
-                <a16:creationId xmlns:a16="http://schemas.microsoft.com/office/drawing/2014/main" id="{855C7415-14A7-42A4-A947-065CAB8FB07E}"/>
+                <a16:creationId xmlns:a16="http://schemas.microsoft.com/office/drawing/2014/main" id="{8EFFC9E7-018A-496F-A219-1A672C2653A1}"/>
               </a:ext>
             </a:extLst>
           </p:cNvPr>
@@ -13456,7 +14521,7 @@
           <p:cNvPr id="19" name="">
             <a:extLst xmlns:a="http://schemas.openxmlformats.org/drawingml/2006/main">
               <a:ext uri="{FF2B5EF4-FFF2-40B4-BE49-F238E27FC236}">
-                <a16:creationId xmlns:a16="http://schemas.microsoft.com/office/drawing/2014/main" id="{ED1AC5E3-FA65-4591-82A9-0E0958FAE944}"/>
+                <a16:creationId xmlns:a16="http://schemas.microsoft.com/office/drawing/2014/main" id="{ECC6F5AB-3534-4E58-A4C8-E0CF751FB5D9}"/>
               </a:ext>
             </a:extLst>
           </p:cNvPr>
@@ -13506,7 +14571,7 @@
           <p:cNvPr id="20" name="">
             <a:extLst xmlns:a="http://schemas.openxmlformats.org/drawingml/2006/main">
               <a:ext uri="{FF2B5EF4-FFF2-40B4-BE49-F238E27FC236}">
-                <a16:creationId xmlns:a16="http://schemas.microsoft.com/office/drawing/2014/main" id="{F4F5D66C-F9DA-4BB3-84E7-518EC3D1C04C}"/>
+                <a16:creationId xmlns:a16="http://schemas.microsoft.com/office/drawing/2014/main" id="{8947F3BF-9890-4E7F-BF31-0188565681EC}"/>
               </a:ext>
             </a:extLst>
           </p:cNvPr>
@@ -13556,7 +14621,7 @@
           <p:cNvPr id="21" name="">
             <a:extLst xmlns:a="http://schemas.openxmlformats.org/drawingml/2006/main">
               <a:ext uri="{FF2B5EF4-FFF2-40B4-BE49-F238E27FC236}">
-                <a16:creationId xmlns:a16="http://schemas.microsoft.com/office/drawing/2014/main" id="{9872F043-88F0-41BF-BE82-DBA6EA8BD857}"/>
+                <a16:creationId xmlns:a16="http://schemas.microsoft.com/office/drawing/2014/main" id="{8298317F-A53D-4AFA-80C0-0289EFF5FCE8}"/>
               </a:ext>
             </a:extLst>
           </p:cNvPr>
@@ -13606,7 +14671,7 @@
           <p:cNvPr id="22" name="">
             <a:extLst xmlns:a="http://schemas.openxmlformats.org/drawingml/2006/main">
               <a:ext uri="{FF2B5EF4-FFF2-40B4-BE49-F238E27FC236}">
-                <a16:creationId xmlns:a16="http://schemas.microsoft.com/office/drawing/2014/main" id="{97D075C8-699F-499E-B395-2B72EE5FBB65}"/>
+                <a16:creationId xmlns:a16="http://schemas.microsoft.com/office/drawing/2014/main" id="{CA24C181-B466-4BF4-A0E0-A3DA70A50346}"/>
               </a:ext>
             </a:extLst>
           </p:cNvPr>
@@ -13637,7 +14702,7 @@
           <p:cNvPr id="23" name="">
             <a:extLst xmlns:a="http://schemas.openxmlformats.org/drawingml/2006/main">
               <a:ext uri="{FF2B5EF4-FFF2-40B4-BE49-F238E27FC236}">
-                <a16:creationId xmlns:a16="http://schemas.microsoft.com/office/drawing/2014/main" id="{62C78FE1-4056-4FE6-A547-E1FECF5F5FA6}"/>
+                <a16:creationId xmlns:a16="http://schemas.microsoft.com/office/drawing/2014/main" id="{BF713B35-B4BA-41E8-9F1B-9311BD4C0425}"/>
               </a:ext>
             </a:extLst>
           </p:cNvPr>
@@ -13670,7 +14735,7 @@
           <p:cNvPr id="24" name="">
             <a:extLst xmlns:a="http://schemas.openxmlformats.org/drawingml/2006/main">
               <a:ext uri="{FF2B5EF4-FFF2-40B4-BE49-F238E27FC236}">
-                <a16:creationId xmlns:a16="http://schemas.microsoft.com/office/drawing/2014/main" id="{F4270265-FF12-4285-8793-9418057F21A8}"/>
+                <a16:creationId xmlns:a16="http://schemas.microsoft.com/office/drawing/2014/main" id="{668A3C69-7F9B-4427-A6A4-E7CEEFA36F70}"/>
               </a:ext>
             </a:extLst>
           </p:cNvPr>
@@ -13720,7 +14785,7 @@
           <p:cNvPr id="25" name="">
             <a:extLst xmlns:a="http://schemas.openxmlformats.org/drawingml/2006/main">
               <a:ext uri="{FF2B5EF4-FFF2-40B4-BE49-F238E27FC236}">
-                <a16:creationId xmlns:a16="http://schemas.microsoft.com/office/drawing/2014/main" id="{ADA86F90-5E00-44EC-AB64-E0AB8D68B345}"/>
+                <a16:creationId xmlns:a16="http://schemas.microsoft.com/office/drawing/2014/main" id="{5B96FACB-7B3B-4920-B9A0-8F1B33828F86}"/>
               </a:ext>
             </a:extLst>
           </p:cNvPr>
@@ -13770,7 +14835,7 @@
           <p:cNvPr id="26" name="">
             <a:extLst xmlns:a="http://schemas.openxmlformats.org/drawingml/2006/main">
               <a:ext uri="{FF2B5EF4-FFF2-40B4-BE49-F238E27FC236}">
-                <a16:creationId xmlns:a16="http://schemas.microsoft.com/office/drawing/2014/main" id="{A64B09DC-1311-4972-BF62-FDA3808CB4FC}"/>
+                <a16:creationId xmlns:a16="http://schemas.microsoft.com/office/drawing/2014/main" id="{E81546B9-78D5-4ACE-8598-8DC1BF174B92}"/>
               </a:ext>
             </a:extLst>
           </p:cNvPr>
@@ -13820,7 +14885,7 @@
           <p:cNvPr id="27" name="">
             <a:extLst xmlns:a="http://schemas.openxmlformats.org/drawingml/2006/main">
               <a:ext uri="{FF2B5EF4-FFF2-40B4-BE49-F238E27FC236}">
-                <a16:creationId xmlns:a16="http://schemas.microsoft.com/office/drawing/2014/main" id="{3EB69BF0-8CB1-4756-85D6-A55F60FDAA4F}"/>
+                <a16:creationId xmlns:a16="http://schemas.microsoft.com/office/drawing/2014/main" id="{C0F51181-8E02-47CC-852D-D562B1BFD180}"/>
               </a:ext>
             </a:extLst>
           </p:cNvPr>
@@ -13870,7 +14935,7 @@
           <p:cNvPr id="28" name="">
             <a:extLst xmlns:a="http://schemas.openxmlformats.org/drawingml/2006/main">
               <a:ext uri="{FF2B5EF4-FFF2-40B4-BE49-F238E27FC236}">
-                <a16:creationId xmlns:a16="http://schemas.microsoft.com/office/drawing/2014/main" id="{8F72DEFE-4DC1-4DB3-8D44-FFAD3F889ACE}"/>
+                <a16:creationId xmlns:a16="http://schemas.microsoft.com/office/drawing/2014/main" id="{BAC53443-D843-4834-9063-AA10B47861E2}"/>
               </a:ext>
             </a:extLst>
           </p:cNvPr>
@@ -13918,7 +14983,7 @@
     </p:spTree>
     <p:extLst>
       <p:ext uri="{BB962C8B-B14F-4D97-AF65-F5344CB8AC3E}">
-        <p14:creationId xmlns:p14="http://schemas.microsoft.com/office/powerpoint/2010/main" val="620423318"/>
+        <p14:creationId xmlns:p14="http://schemas.microsoft.com/office/powerpoint/2010/main" val="460517184"/>
       </p:ext>
     </p:extLst>
   </p:cSld>
@@ -13949,7 +15014,7 @@
           <p:cNvPr id="20" name="">
             <a:extLst xmlns:a="http://schemas.openxmlformats.org/drawingml/2006/main">
               <a:ext uri="{FF2B5EF4-FFF2-40B4-BE49-F238E27FC236}">
-                <a16:creationId xmlns:a16="http://schemas.microsoft.com/office/drawing/2014/main" id="{E6BD328F-AF8D-4D0E-9AAB-D5B01335265C}"/>
+                <a16:creationId xmlns:a16="http://schemas.microsoft.com/office/drawing/2014/main" id="{CAD3EFEE-0A2C-485D-B312-29C41AF18428}"/>
               </a:ext>
             </a:extLst>
           </p:cNvPr>
@@ -13999,7 +15064,7 @@
           <p:cNvPr id="2" name="">
             <a:extLst xmlns:a="http://schemas.openxmlformats.org/drawingml/2006/main">
               <a:ext uri="{FF2B5EF4-FFF2-40B4-BE49-F238E27FC236}">
-                <a16:creationId xmlns:a16="http://schemas.microsoft.com/office/drawing/2014/main" id="{3A137026-84CB-49D2-9591-91EF73DE1CB3}"/>
+                <a16:creationId xmlns:a16="http://schemas.microsoft.com/office/drawing/2014/main" id="{47FC0B95-6F1E-4A2F-A9B0-3EBC509643B7}"/>
               </a:ext>
             </a:extLst>
           </p:cNvPr>
@@ -14049,7 +15114,7 @@
           <p:cNvPr id="3" name="">
             <a:extLst xmlns:a="http://schemas.openxmlformats.org/drawingml/2006/main">
               <a:ext uri="{FF2B5EF4-FFF2-40B4-BE49-F238E27FC236}">
-                <a16:creationId xmlns:a16="http://schemas.microsoft.com/office/drawing/2014/main" id="{F1D3AAF8-D56C-4085-97CF-A9BDCCB1AB87}"/>
+                <a16:creationId xmlns:a16="http://schemas.microsoft.com/office/drawing/2014/main" id="{3066A1BD-CEA4-4012-A814-85953C00D842}"/>
               </a:ext>
             </a:extLst>
           </p:cNvPr>
@@ -14084,7 +15149,7 @@
           <p:cNvPr id="4" name="">
             <a:extLst xmlns:a="http://schemas.openxmlformats.org/drawingml/2006/main">
               <a:ext uri="{FF2B5EF4-FFF2-40B4-BE49-F238E27FC236}">
-                <a16:creationId xmlns:a16="http://schemas.microsoft.com/office/drawing/2014/main" id="{A96D706D-4674-46E6-B141-B1007509C9E0}"/>
+                <a16:creationId xmlns:a16="http://schemas.microsoft.com/office/drawing/2014/main" id="{B651546D-2751-432A-9DFC-9C0D2BA60340}"/>
               </a:ext>
             </a:extLst>
           </p:cNvPr>
@@ -14134,7 +15199,7 @@
           <p:cNvPr id="5" name="">
             <a:extLst xmlns:a="http://schemas.openxmlformats.org/drawingml/2006/main">
               <a:ext uri="{FF2B5EF4-FFF2-40B4-BE49-F238E27FC236}">
-                <a16:creationId xmlns:a16="http://schemas.microsoft.com/office/drawing/2014/main" id="{7AD812DC-1585-4AAC-B443-BAF127A5F752}"/>
+                <a16:creationId xmlns:a16="http://schemas.microsoft.com/office/drawing/2014/main" id="{C461A87F-4878-4F1D-8BEA-3D9386D51EB3}"/>
               </a:ext>
             </a:extLst>
           </p:cNvPr>
@@ -14218,7 +15283,7 @@
           <p:cNvPr id="6" name="">
             <a:extLst xmlns:a="http://schemas.openxmlformats.org/drawingml/2006/main">
               <a:ext uri="{FF2B5EF4-FFF2-40B4-BE49-F238E27FC236}">
-                <a16:creationId xmlns:a16="http://schemas.microsoft.com/office/drawing/2014/main" id="{5F66BA55-DE70-42CA-A41E-3453A643F29D}"/>
+                <a16:creationId xmlns:a16="http://schemas.microsoft.com/office/drawing/2014/main" id="{8E944F51-5BEE-4ED3-96E5-D91BEA084FF4}"/>
               </a:ext>
             </a:extLst>
           </p:cNvPr>
@@ -14268,7 +15333,7 @@
           <p:cNvPr id="7" name="">
             <a:extLst xmlns:a="http://schemas.openxmlformats.org/drawingml/2006/main">
               <a:ext uri="{FF2B5EF4-FFF2-40B4-BE49-F238E27FC236}">
-                <a16:creationId xmlns:a16="http://schemas.microsoft.com/office/drawing/2014/main" id="{FD1F1884-F761-4FBB-9626-855209A61122}"/>
+                <a16:creationId xmlns:a16="http://schemas.microsoft.com/office/drawing/2014/main" id="{89A371A3-AEF1-4B24-881F-95CB7652F299}"/>
               </a:ext>
             </a:extLst>
           </p:cNvPr>
@@ -14303,7 +15368,7 @@
           <p:cNvPr id="8" name="">
             <a:extLst xmlns:a="http://schemas.openxmlformats.org/drawingml/2006/main">
               <a:ext uri="{FF2B5EF4-FFF2-40B4-BE49-F238E27FC236}">
-                <a16:creationId xmlns:a16="http://schemas.microsoft.com/office/drawing/2014/main" id="{E55F4DC0-D151-4E8B-81E8-05032692CAA0}"/>
+                <a16:creationId xmlns:a16="http://schemas.microsoft.com/office/drawing/2014/main" id="{8ECA7DEA-65D3-4D5F-9979-5A874B18978C}"/>
               </a:ext>
             </a:extLst>
           </p:cNvPr>
@@ -14353,7 +15418,7 @@
           <p:cNvPr id="9" name="">
             <a:extLst xmlns:a="http://schemas.openxmlformats.org/drawingml/2006/main">
               <a:ext uri="{FF2B5EF4-FFF2-40B4-BE49-F238E27FC236}">
-                <a16:creationId xmlns:a16="http://schemas.microsoft.com/office/drawing/2014/main" id="{2D3F7E1C-0887-41B1-97BD-3902775FABCA}"/>
+                <a16:creationId xmlns:a16="http://schemas.microsoft.com/office/drawing/2014/main" id="{D7F885A7-8D65-417B-9A27-2EF251238455}"/>
               </a:ext>
             </a:extLst>
           </p:cNvPr>
@@ -14437,7 +15502,7 @@
           <p:cNvPr id="10" name="">
             <a:extLst xmlns:a="http://schemas.openxmlformats.org/drawingml/2006/main">
               <a:ext uri="{FF2B5EF4-FFF2-40B4-BE49-F238E27FC236}">
-                <a16:creationId xmlns:a16="http://schemas.microsoft.com/office/drawing/2014/main" id="{3F72DB9B-5BD1-47A9-B58C-F93FB61F4D2C}"/>
+                <a16:creationId xmlns:a16="http://schemas.microsoft.com/office/drawing/2014/main" id="{48FCFADE-5AC7-4DE9-9A33-5B41FCAEDC8E}"/>
               </a:ext>
             </a:extLst>
           </p:cNvPr>
@@ -14487,7 +15552,7 @@
           <p:cNvPr id="11" name="">
             <a:extLst xmlns:a="http://schemas.openxmlformats.org/drawingml/2006/main">
               <a:ext uri="{FF2B5EF4-FFF2-40B4-BE49-F238E27FC236}">
-                <a16:creationId xmlns:a16="http://schemas.microsoft.com/office/drawing/2014/main" id="{E5CDE0CE-70BC-4A99-91AF-A52D5B9C6DED}"/>
+                <a16:creationId xmlns:a16="http://schemas.microsoft.com/office/drawing/2014/main" id="{7E53DABB-ED05-4645-AFE0-71642C04EE3A}"/>
               </a:ext>
             </a:extLst>
           </p:cNvPr>
@@ -14522,7 +15587,7 @@
           <p:cNvPr id="12" name="">
             <a:extLst xmlns:a="http://schemas.openxmlformats.org/drawingml/2006/main">
               <a:ext uri="{FF2B5EF4-FFF2-40B4-BE49-F238E27FC236}">
-                <a16:creationId xmlns:a16="http://schemas.microsoft.com/office/drawing/2014/main" id="{3D1042EA-0FA2-4595-B64D-606F9F7A5957}"/>
+                <a16:creationId xmlns:a16="http://schemas.microsoft.com/office/drawing/2014/main" id="{ADCD2671-4E47-4FAA-835C-5EC415C64ABE}"/>
               </a:ext>
             </a:extLst>
           </p:cNvPr>
@@ -14572,7 +15637,7 @@
           <p:cNvPr id="13" name="">
             <a:extLst xmlns:a="http://schemas.openxmlformats.org/drawingml/2006/main">
               <a:ext uri="{FF2B5EF4-FFF2-40B4-BE49-F238E27FC236}">
-                <a16:creationId xmlns:a16="http://schemas.microsoft.com/office/drawing/2014/main" id="{D3B0BBF7-F0DE-4FD2-9FDF-6098DD16FD1A}"/>
+                <a16:creationId xmlns:a16="http://schemas.microsoft.com/office/drawing/2014/main" id="{550DF499-CDDC-4AC3-814A-6663123D363E}"/>
               </a:ext>
             </a:extLst>
           </p:cNvPr>
@@ -14656,7 +15721,7 @@
           <p:cNvPr id="14" name="">
             <a:extLst xmlns:a="http://schemas.openxmlformats.org/drawingml/2006/main">
               <a:ext uri="{FF2B5EF4-FFF2-40B4-BE49-F238E27FC236}">
-                <a16:creationId xmlns:a16="http://schemas.microsoft.com/office/drawing/2014/main" id="{25C17E8C-4B07-4539-A2F2-725FA41C0C13}"/>
+                <a16:creationId xmlns:a16="http://schemas.microsoft.com/office/drawing/2014/main" id="{22C4C3F5-C7FA-4ADA-B2A9-6691C24207F2}"/>
               </a:ext>
             </a:extLst>
           </p:cNvPr>
@@ -14706,7 +15771,7 @@
           <p:cNvPr id="15" name="">
             <a:extLst xmlns:a="http://schemas.openxmlformats.org/drawingml/2006/main">
               <a:ext uri="{FF2B5EF4-FFF2-40B4-BE49-F238E27FC236}">
-                <a16:creationId xmlns:a16="http://schemas.microsoft.com/office/drawing/2014/main" id="{60B22A05-4C4E-41C6-BA62-2E0100DA5E66}"/>
+                <a16:creationId xmlns:a16="http://schemas.microsoft.com/office/drawing/2014/main" id="{C0E71120-0198-485E-BED4-DDAB0F36854C}"/>
               </a:ext>
             </a:extLst>
           </p:cNvPr>
@@ -14741,7 +15806,7 @@
           <p:cNvPr id="16" name="">
             <a:extLst xmlns:a="http://schemas.openxmlformats.org/drawingml/2006/main">
               <a:ext uri="{FF2B5EF4-FFF2-40B4-BE49-F238E27FC236}">
-                <a16:creationId xmlns:a16="http://schemas.microsoft.com/office/drawing/2014/main" id="{105D8DDF-E44E-4EBE-8629-F16409B4A9C6}"/>
+                <a16:creationId xmlns:a16="http://schemas.microsoft.com/office/drawing/2014/main" id="{A3421039-34AE-45C9-BBB1-6411224EF004}"/>
               </a:ext>
             </a:extLst>
           </p:cNvPr>
@@ -14791,7 +15856,7 @@
           <p:cNvPr id="17" name="">
             <a:extLst xmlns:a="http://schemas.openxmlformats.org/drawingml/2006/main">
               <a:ext uri="{FF2B5EF4-FFF2-40B4-BE49-F238E27FC236}">
-                <a16:creationId xmlns:a16="http://schemas.microsoft.com/office/drawing/2014/main" id="{A9A32DC5-E671-4182-B604-3C53A6C6343B}"/>
+                <a16:creationId xmlns:a16="http://schemas.microsoft.com/office/drawing/2014/main" id="{DB820A59-F8D3-42F0-8C6E-0F3E99E27CA1}"/>
               </a:ext>
             </a:extLst>
           </p:cNvPr>
@@ -14875,7 +15940,7 @@
           <p:cNvPr id="18" name="">
             <a:extLst xmlns:a="http://schemas.openxmlformats.org/drawingml/2006/main">
               <a:ext uri="{FF2B5EF4-FFF2-40B4-BE49-F238E27FC236}">
-                <a16:creationId xmlns:a16="http://schemas.microsoft.com/office/drawing/2014/main" id="{F398AFB8-C2DF-45DC-95E3-81DBD8A5947A}"/>
+                <a16:creationId xmlns:a16="http://schemas.microsoft.com/office/drawing/2014/main" id="{2EB640A3-8536-4E7B-9A5C-22D3AE48EA79}"/>
               </a:ext>
             </a:extLst>
           </p:cNvPr>
@@ -14925,7 +15990,7 @@
           <p:cNvPr id="19" name="">
             <a:extLst xmlns:a="http://schemas.openxmlformats.org/drawingml/2006/main">
               <a:ext uri="{FF2B5EF4-FFF2-40B4-BE49-F238E27FC236}">
-                <a16:creationId xmlns:a16="http://schemas.microsoft.com/office/drawing/2014/main" id="{3775678A-4E90-40BB-9940-18ECC07476B3}"/>
+                <a16:creationId xmlns:a16="http://schemas.microsoft.com/office/drawing/2014/main" id="{2DD2A649-8723-4C8A-99BE-2C426C8B3885}"/>
               </a:ext>
             </a:extLst>
           </p:cNvPr>
@@ -14973,7 +16038,7 @@
     </p:spTree>
     <p:extLst>
       <p:ext uri="{BB962C8B-B14F-4D97-AF65-F5344CB8AC3E}">
-        <p14:creationId xmlns:p14="http://schemas.microsoft.com/office/powerpoint/2010/main" val="206097134"/>
+        <p14:creationId xmlns:p14="http://schemas.microsoft.com/office/powerpoint/2010/main" val="2105838613"/>
       </p:ext>
     </p:extLst>
   </p:cSld>
@@ -15004,7 +16069,7 @@
           <p:cNvPr id="15" name="">
             <a:extLst xmlns:a="http://schemas.openxmlformats.org/drawingml/2006/main">
               <a:ext uri="{FF2B5EF4-FFF2-40B4-BE49-F238E27FC236}">
-                <a16:creationId xmlns:a16="http://schemas.microsoft.com/office/drawing/2014/main" id="{109DF7FD-E10B-4135-B0E6-F9A71C10601F}"/>
+                <a16:creationId xmlns:a16="http://schemas.microsoft.com/office/drawing/2014/main" id="{318086DD-A115-4511-A882-84B59F894A87}"/>
               </a:ext>
             </a:extLst>
           </p:cNvPr>
@@ -15054,7 +16119,7 @@
           <p:cNvPr id="2" name="">
             <a:extLst xmlns:a="http://schemas.openxmlformats.org/drawingml/2006/main">
               <a:ext uri="{FF2B5EF4-FFF2-40B4-BE49-F238E27FC236}">
-                <a16:creationId xmlns:a16="http://schemas.microsoft.com/office/drawing/2014/main" id="{ED151AF9-A628-4F6D-ACE8-1569E4D3518A}"/>
+                <a16:creationId xmlns:a16="http://schemas.microsoft.com/office/drawing/2014/main" id="{822FA93E-4133-4BD8-A914-78E97D609AFD}"/>
               </a:ext>
             </a:extLst>
           </p:cNvPr>
@@ -15104,7 +16169,7 @@
           <p:cNvPr id="3" name="">
             <a:extLst xmlns:a="http://schemas.openxmlformats.org/drawingml/2006/main">
               <a:ext uri="{FF2B5EF4-FFF2-40B4-BE49-F238E27FC236}">
-                <a16:creationId xmlns:a16="http://schemas.microsoft.com/office/drawing/2014/main" id="{EA97479D-DDA0-4801-AB97-4CD9C9865F33}"/>
+                <a16:creationId xmlns:a16="http://schemas.microsoft.com/office/drawing/2014/main" id="{6D176A5E-47B9-4B74-AD89-3D05DA0A8A6E}"/>
               </a:ext>
             </a:extLst>
           </p:cNvPr>
@@ -15139,7 +16204,7 @@
           <p:cNvPr id="4" name="">
             <a:extLst xmlns:a="http://schemas.openxmlformats.org/drawingml/2006/main">
               <a:ext uri="{FF2B5EF4-FFF2-40B4-BE49-F238E27FC236}">
-                <a16:creationId xmlns:a16="http://schemas.microsoft.com/office/drawing/2014/main" id="{B1F5B49A-797F-41AC-A0E3-55611DE44C31}"/>
+                <a16:creationId xmlns:a16="http://schemas.microsoft.com/office/drawing/2014/main" id="{23CAB120-987E-40B7-B6D9-835EBC3C1A72}"/>
               </a:ext>
             </a:extLst>
           </p:cNvPr>
@@ -15189,7 +16254,7 @@
           <p:cNvPr id="5" name="">
             <a:extLst xmlns:a="http://schemas.openxmlformats.org/drawingml/2006/main">
               <a:ext uri="{FF2B5EF4-FFF2-40B4-BE49-F238E27FC236}">
-                <a16:creationId xmlns:a16="http://schemas.microsoft.com/office/drawing/2014/main" id="{BA1255E7-4717-4875-95B2-8CC3B7140259}"/>
+                <a16:creationId xmlns:a16="http://schemas.microsoft.com/office/drawing/2014/main" id="{ED36CF76-801E-4593-850D-E97B1488528E}"/>
               </a:ext>
             </a:extLst>
           </p:cNvPr>
@@ -15239,7 +16304,7 @@
           <p:cNvPr id="6" name="">
             <a:extLst xmlns:a="http://schemas.openxmlformats.org/drawingml/2006/main">
               <a:ext uri="{FF2B5EF4-FFF2-40B4-BE49-F238E27FC236}">
-                <a16:creationId xmlns:a16="http://schemas.microsoft.com/office/drawing/2014/main" id="{8DC4A58F-0551-4037-9B72-D088E47B62F7}"/>
+                <a16:creationId xmlns:a16="http://schemas.microsoft.com/office/drawing/2014/main" id="{5DA0AAAF-4EE1-4686-BB8B-B0F541D3F21F}"/>
               </a:ext>
             </a:extLst>
           </p:cNvPr>
@@ -15289,7 +16354,7 @@
           <p:cNvPr id="7" name="">
             <a:extLst xmlns:a="http://schemas.openxmlformats.org/drawingml/2006/main">
               <a:ext uri="{FF2B5EF4-FFF2-40B4-BE49-F238E27FC236}">
-                <a16:creationId xmlns:a16="http://schemas.microsoft.com/office/drawing/2014/main" id="{4BC32D89-F98C-4698-B8D4-5175525024AE}"/>
+                <a16:creationId xmlns:a16="http://schemas.microsoft.com/office/drawing/2014/main" id="{AD620DFF-48A6-46BF-9136-C70FAF96A8C2}"/>
               </a:ext>
             </a:extLst>
           </p:cNvPr>
@@ -15339,7 +16404,7 @@
           <p:cNvPr id="8" name="">
             <a:extLst xmlns:a="http://schemas.openxmlformats.org/drawingml/2006/main">
               <a:ext uri="{FF2B5EF4-FFF2-40B4-BE49-F238E27FC236}">
-                <a16:creationId xmlns:a16="http://schemas.microsoft.com/office/drawing/2014/main" id="{D5013B3E-F5F2-49B9-8B75-1040984C7796}"/>
+                <a16:creationId xmlns:a16="http://schemas.microsoft.com/office/drawing/2014/main" id="{257466D7-77C9-4378-9DD4-22172BBA65AF}"/>
               </a:ext>
             </a:extLst>
           </p:cNvPr>
@@ -15389,7 +16454,7 @@
           <p:cNvPr id="9" name="">
             <a:extLst xmlns:a="http://schemas.openxmlformats.org/drawingml/2006/main">
               <a:ext uri="{FF2B5EF4-FFF2-40B4-BE49-F238E27FC236}">
-                <a16:creationId xmlns:a16="http://schemas.microsoft.com/office/drawing/2014/main" id="{ED60C24A-BC8E-46F7-A02F-408280F90FCF}"/>
+                <a16:creationId xmlns:a16="http://schemas.microsoft.com/office/drawing/2014/main" id="{05875B05-AE5E-4A3F-85DA-64D7BD3E67F8}"/>
               </a:ext>
             </a:extLst>
           </p:cNvPr>
@@ -15422,7 +16487,7 @@
           <p:cNvPr id="10" name="">
             <a:extLst xmlns:a="http://schemas.openxmlformats.org/drawingml/2006/main">
               <a:ext uri="{FF2B5EF4-FFF2-40B4-BE49-F238E27FC236}">
-                <a16:creationId xmlns:a16="http://schemas.microsoft.com/office/drawing/2014/main" id="{5429D86E-420E-4C59-928C-B287250A1063}"/>
+                <a16:creationId xmlns:a16="http://schemas.microsoft.com/office/drawing/2014/main" id="{49EBAEE4-167F-42A1-8CA4-0C8BEE8982F0}"/>
               </a:ext>
             </a:extLst>
           </p:cNvPr>
@@ -15472,7 +16537,7 @@
           <p:cNvPr id="11" name="">
             <a:extLst xmlns:a="http://schemas.openxmlformats.org/drawingml/2006/main">
               <a:ext uri="{FF2B5EF4-FFF2-40B4-BE49-F238E27FC236}">
-                <a16:creationId xmlns:a16="http://schemas.microsoft.com/office/drawing/2014/main" id="{9C3AD3D0-679D-4E9C-BAA4-48D2ADD838F4}"/>
+                <a16:creationId xmlns:a16="http://schemas.microsoft.com/office/drawing/2014/main" id="{E5651DEC-E43F-479D-8C30-B6AA510E8B6A}"/>
               </a:ext>
             </a:extLst>
           </p:cNvPr>
@@ -15539,7 +16604,7 @@
           <p:cNvPr id="12" name="">
             <a:extLst xmlns:a="http://schemas.openxmlformats.org/drawingml/2006/main">
               <a:ext uri="{FF2B5EF4-FFF2-40B4-BE49-F238E27FC236}">
-                <a16:creationId xmlns:a16="http://schemas.microsoft.com/office/drawing/2014/main" id="{B7595D45-3CF6-4155-BDDB-83F5C0FD93FF}"/>
+                <a16:creationId xmlns:a16="http://schemas.microsoft.com/office/drawing/2014/main" id="{88AFF1F9-6069-4B65-ACA2-31B7859BEFCF}"/>
               </a:ext>
             </a:extLst>
           </p:cNvPr>
@@ -15589,7 +16654,7 @@
           <p:cNvPr id="13" name="">
             <a:extLst xmlns:a="http://schemas.openxmlformats.org/drawingml/2006/main">
               <a:ext uri="{FF2B5EF4-FFF2-40B4-BE49-F238E27FC236}">
-                <a16:creationId xmlns:a16="http://schemas.microsoft.com/office/drawing/2014/main" id="{5FF3419B-7968-4379-9722-ED49657C8759}"/>
+                <a16:creationId xmlns:a16="http://schemas.microsoft.com/office/drawing/2014/main" id="{B964A6AA-50A1-453D-BE0B-87CE4676B58E}"/>
               </a:ext>
             </a:extLst>
           </p:cNvPr>
@@ -15639,7 +16704,7 @@
           <p:cNvPr id="14" name="">
             <a:extLst xmlns:a="http://schemas.openxmlformats.org/drawingml/2006/main">
               <a:ext uri="{FF2B5EF4-FFF2-40B4-BE49-F238E27FC236}">
-                <a16:creationId xmlns:a16="http://schemas.microsoft.com/office/drawing/2014/main" id="{91695FE5-62B9-4B49-A1E4-F599595807A9}"/>
+                <a16:creationId xmlns:a16="http://schemas.microsoft.com/office/drawing/2014/main" id="{80562902-0A94-47E7-ACF6-8E211F13DB64}"/>
               </a:ext>
             </a:extLst>
           </p:cNvPr>
@@ -15687,7 +16752,7 @@
     </p:spTree>
     <p:extLst>
       <p:ext uri="{BB962C8B-B14F-4D97-AF65-F5344CB8AC3E}">
-        <p14:creationId xmlns:p14="http://schemas.microsoft.com/office/powerpoint/2010/main" val="481892711"/>
+        <p14:creationId xmlns:p14="http://schemas.microsoft.com/office/powerpoint/2010/main" val="1861290511"/>
       </p:ext>
     </p:extLst>
   </p:cSld>
@@ -15718,7 +16783,7 @@
           <p:cNvPr id="17" name="">
             <a:extLst xmlns:a="http://schemas.openxmlformats.org/drawingml/2006/main">
               <a:ext uri="{FF2B5EF4-FFF2-40B4-BE49-F238E27FC236}">
-                <a16:creationId xmlns:a16="http://schemas.microsoft.com/office/drawing/2014/main" id="{630E0C30-41E7-42DD-95F6-576AF158D40B}"/>
+                <a16:creationId xmlns:a16="http://schemas.microsoft.com/office/drawing/2014/main" id="{F08E643E-EFE9-4056-A70B-089B5AE8062B}"/>
               </a:ext>
             </a:extLst>
           </p:cNvPr>
@@ -15768,7 +16833,7 @@
           <p:cNvPr id="2" name="">
             <a:extLst xmlns:a="http://schemas.openxmlformats.org/drawingml/2006/main">
               <a:ext uri="{FF2B5EF4-FFF2-40B4-BE49-F238E27FC236}">
-                <a16:creationId xmlns:a16="http://schemas.microsoft.com/office/drawing/2014/main" id="{6FBEA264-AC83-4393-A442-02AF4A8E973A}"/>
+                <a16:creationId xmlns:a16="http://schemas.microsoft.com/office/drawing/2014/main" id="{D99958F6-667D-45C1-9F56-D1E55C195F9D}"/>
               </a:ext>
             </a:extLst>
           </p:cNvPr>
@@ -15818,7 +16883,7 @@
           <p:cNvPr id="3" name="">
             <a:extLst xmlns:a="http://schemas.openxmlformats.org/drawingml/2006/main">
               <a:ext uri="{FF2B5EF4-FFF2-40B4-BE49-F238E27FC236}">
-                <a16:creationId xmlns:a16="http://schemas.microsoft.com/office/drawing/2014/main" id="{27D8E671-AD41-4A25-975D-42216037CC6C}"/>
+                <a16:creationId xmlns:a16="http://schemas.microsoft.com/office/drawing/2014/main" id="{DA5A0766-E3E8-4678-82D8-15A5A7951088}"/>
               </a:ext>
             </a:extLst>
           </p:cNvPr>
@@ -15868,7 +16933,7 @@
           <p:cNvPr id="4" name="">
             <a:extLst xmlns:a="http://schemas.openxmlformats.org/drawingml/2006/main">
               <a:ext uri="{FF2B5EF4-FFF2-40B4-BE49-F238E27FC236}">
-                <a16:creationId xmlns:a16="http://schemas.microsoft.com/office/drawing/2014/main" id="{5EE49715-3BC4-457C-864D-602B095F127D}"/>
+                <a16:creationId xmlns:a16="http://schemas.microsoft.com/office/drawing/2014/main" id="{203527C1-756A-4EB0-BF7F-91042AD021BA}"/>
               </a:ext>
             </a:extLst>
           </p:cNvPr>
@@ -15918,7 +16983,7 @@
           <p:cNvPr id="5" name="">
             <a:extLst xmlns:a="http://schemas.openxmlformats.org/drawingml/2006/main">
               <a:ext uri="{FF2B5EF4-FFF2-40B4-BE49-F238E27FC236}">
-                <a16:creationId xmlns:a16="http://schemas.microsoft.com/office/drawing/2014/main" id="{52CCC89B-6693-4644-A391-76B31D83F4A8}"/>
+                <a16:creationId xmlns:a16="http://schemas.microsoft.com/office/drawing/2014/main" id="{AAF6D635-D131-49AB-ADA5-BAE59D7A207A}"/>
               </a:ext>
             </a:extLst>
           </p:cNvPr>
@@ -15949,7 +17014,7 @@
           <p:cNvPr id="6" name="">
             <a:extLst xmlns:a="http://schemas.openxmlformats.org/drawingml/2006/main">
               <a:ext uri="{FF2B5EF4-FFF2-40B4-BE49-F238E27FC236}">
-                <a16:creationId xmlns:a16="http://schemas.microsoft.com/office/drawing/2014/main" id="{E63D8AB9-634C-4B92-A42E-23BBAC7C25B2}"/>
+                <a16:creationId xmlns:a16="http://schemas.microsoft.com/office/drawing/2014/main" id="{168D71ED-F6DB-4C1E-B5CF-FD61A7CA28CA}"/>
               </a:ext>
             </a:extLst>
           </p:cNvPr>
@@ -15999,7 +17064,7 @@
           <p:cNvPr id="7" name="">
             <a:extLst xmlns:a="http://schemas.openxmlformats.org/drawingml/2006/main">
               <a:ext uri="{FF2B5EF4-FFF2-40B4-BE49-F238E27FC236}">
-                <a16:creationId xmlns:a16="http://schemas.microsoft.com/office/drawing/2014/main" id="{38D58693-5B72-481E-9E2D-9E7FB5974320}"/>
+                <a16:creationId xmlns:a16="http://schemas.microsoft.com/office/drawing/2014/main" id="{0432CD25-64F2-4DC8-B2AE-E8CECCF1D29C}"/>
               </a:ext>
             </a:extLst>
           </p:cNvPr>
@@ -16049,7 +17114,7 @@
           <p:cNvPr id="8" name="">
             <a:extLst xmlns:a="http://schemas.openxmlformats.org/drawingml/2006/main">
               <a:ext uri="{FF2B5EF4-FFF2-40B4-BE49-F238E27FC236}">
-                <a16:creationId xmlns:a16="http://schemas.microsoft.com/office/drawing/2014/main" id="{B19A6377-7BA1-4E83-875E-43BBCA9C5690}"/>
+                <a16:creationId xmlns:a16="http://schemas.microsoft.com/office/drawing/2014/main" id="{E6CCD900-2446-4BDD-BD00-D4C433063A82}"/>
               </a:ext>
             </a:extLst>
           </p:cNvPr>
@@ -16080,7 +17145,7 @@
           <p:cNvPr id="9" name="">
             <a:extLst xmlns:a="http://schemas.openxmlformats.org/drawingml/2006/main">
               <a:ext uri="{FF2B5EF4-FFF2-40B4-BE49-F238E27FC236}">
-                <a16:creationId xmlns:a16="http://schemas.microsoft.com/office/drawing/2014/main" id="{2A259773-8953-43F0-9EBD-358DA1D92274}"/>
+                <a16:creationId xmlns:a16="http://schemas.microsoft.com/office/drawing/2014/main" id="{6697700A-B6BD-4D28-8556-C78C72F098BC}"/>
               </a:ext>
             </a:extLst>
           </p:cNvPr>
@@ -16130,7 +17195,7 @@
           <p:cNvPr id="10" name="">
             <a:extLst xmlns:a="http://schemas.openxmlformats.org/drawingml/2006/main">
               <a:ext uri="{FF2B5EF4-FFF2-40B4-BE49-F238E27FC236}">
-                <a16:creationId xmlns:a16="http://schemas.microsoft.com/office/drawing/2014/main" id="{6EB75D9D-B03A-4C3A-850E-7D470293DCC0}"/>
+                <a16:creationId xmlns:a16="http://schemas.microsoft.com/office/drawing/2014/main" id="{98F05B2C-428D-4786-B217-D113334F43DC}"/>
               </a:ext>
             </a:extLst>
           </p:cNvPr>
@@ -16180,7 +17245,7 @@
           <p:cNvPr id="11" name="">
             <a:extLst xmlns:a="http://schemas.openxmlformats.org/drawingml/2006/main">
               <a:ext uri="{FF2B5EF4-FFF2-40B4-BE49-F238E27FC236}">
-                <a16:creationId xmlns:a16="http://schemas.microsoft.com/office/drawing/2014/main" id="{35C436F0-59BC-4B85-A42A-1A5D3C7A4945}"/>
+                <a16:creationId xmlns:a16="http://schemas.microsoft.com/office/drawing/2014/main" id="{2954BC69-AF14-4B54-B9B5-9339B842A998}"/>
               </a:ext>
             </a:extLst>
           </p:cNvPr>
@@ -16211,7 +17276,7 @@
           <p:cNvPr id="12" name="">
             <a:extLst xmlns:a="http://schemas.openxmlformats.org/drawingml/2006/main">
               <a:ext uri="{FF2B5EF4-FFF2-40B4-BE49-F238E27FC236}">
-                <a16:creationId xmlns:a16="http://schemas.microsoft.com/office/drawing/2014/main" id="{499E7D28-714B-44E9-92D9-F594AD1C9504}"/>
+                <a16:creationId xmlns:a16="http://schemas.microsoft.com/office/drawing/2014/main" id="{A3AB4A68-B3D9-489E-811B-CA2AB54C568E}"/>
               </a:ext>
             </a:extLst>
           </p:cNvPr>
@@ -16261,7 +17326,7 @@
           <p:cNvPr id="13" name="">
             <a:extLst xmlns:a="http://schemas.openxmlformats.org/drawingml/2006/main">
               <a:ext uri="{FF2B5EF4-FFF2-40B4-BE49-F238E27FC236}">
-                <a16:creationId xmlns:a16="http://schemas.microsoft.com/office/drawing/2014/main" id="{A544C75D-BEB8-49EB-A0F0-57BE6A4F7EA7}"/>
+                <a16:creationId xmlns:a16="http://schemas.microsoft.com/office/drawing/2014/main" id="{F077B93F-BBEC-46E7-8679-B0347ABF4E96}"/>
               </a:ext>
             </a:extLst>
           </p:cNvPr>
@@ -16311,7 +17376,7 @@
           <p:cNvPr id="14" name="">
             <a:extLst xmlns:a="http://schemas.openxmlformats.org/drawingml/2006/main">
               <a:ext uri="{FF2B5EF4-FFF2-40B4-BE49-F238E27FC236}">
-                <a16:creationId xmlns:a16="http://schemas.microsoft.com/office/drawing/2014/main" id="{6A71EC0A-0E3E-45A3-9E4A-596F92FB1E5E}"/>
+                <a16:creationId xmlns:a16="http://schemas.microsoft.com/office/drawing/2014/main" id="{673EFAD8-E934-4B61-9BF4-76B927739EF7}"/>
               </a:ext>
             </a:extLst>
           </p:cNvPr>
@@ -16342,7 +17407,7 @@
           <p:cNvPr id="15" name="">
             <a:extLst xmlns:a="http://schemas.openxmlformats.org/drawingml/2006/main">
               <a:ext uri="{FF2B5EF4-FFF2-40B4-BE49-F238E27FC236}">
-                <a16:creationId xmlns:a16="http://schemas.microsoft.com/office/drawing/2014/main" id="{8025C48E-4E07-415D-B6B2-EEF7B750626A}"/>
+                <a16:creationId xmlns:a16="http://schemas.microsoft.com/office/drawing/2014/main" id="{FBE82E70-F5F0-4571-84A2-9B9345170126}"/>
               </a:ext>
             </a:extLst>
           </p:cNvPr>
@@ -16392,7 +17457,7 @@
           <p:cNvPr id="16" name="">
             <a:extLst xmlns:a="http://schemas.openxmlformats.org/drawingml/2006/main">
               <a:ext uri="{FF2B5EF4-FFF2-40B4-BE49-F238E27FC236}">
-                <a16:creationId xmlns:a16="http://schemas.microsoft.com/office/drawing/2014/main" id="{F1CC90EF-B6FE-4BC6-8779-B23DD2620AA0}"/>
+                <a16:creationId xmlns:a16="http://schemas.microsoft.com/office/drawing/2014/main" id="{C3179DF1-96AD-4384-80A0-17AE90335F14}"/>
               </a:ext>
             </a:extLst>
           </p:cNvPr>
@@ -16440,7 +17505,7 @@
     </p:spTree>
     <p:extLst>
       <p:ext uri="{BB962C8B-B14F-4D97-AF65-F5344CB8AC3E}">
-        <p14:creationId xmlns:p14="http://schemas.microsoft.com/office/powerpoint/2010/main" val="661953646"/>
+        <p14:creationId xmlns:p14="http://schemas.microsoft.com/office/powerpoint/2010/main" val="2077171920"/>
       </p:ext>
     </p:extLst>
   </p:cSld>
@@ -16471,7 +17536,7 @@
           <p:cNvPr id="14" name="">
             <a:extLst xmlns:a="http://schemas.openxmlformats.org/drawingml/2006/main">
               <a:ext uri="{FF2B5EF4-FFF2-40B4-BE49-F238E27FC236}">
-                <a16:creationId xmlns:a16="http://schemas.microsoft.com/office/drawing/2014/main" id="{57F2C938-9D9F-48ED-AF72-0290D34CDBFD}"/>
+                <a16:creationId xmlns:a16="http://schemas.microsoft.com/office/drawing/2014/main" id="{81EE67F0-C3A2-413B-BAB7-1E4A14FB1846}"/>
               </a:ext>
             </a:extLst>
           </p:cNvPr>
@@ -16521,7 +17586,7 @@
           <p:cNvPr id="2" name="">
             <a:extLst xmlns:a="http://schemas.openxmlformats.org/drawingml/2006/main">
               <a:ext uri="{FF2B5EF4-FFF2-40B4-BE49-F238E27FC236}">
-                <a16:creationId xmlns:a16="http://schemas.microsoft.com/office/drawing/2014/main" id="{5CAD6B19-E1BC-4C0C-BE6B-3BF83B43C13B}"/>
+                <a16:creationId xmlns:a16="http://schemas.microsoft.com/office/drawing/2014/main" id="{C4BA04CD-65F3-4C85-9756-82692A4F254C}"/>
               </a:ext>
             </a:extLst>
           </p:cNvPr>
@@ -16571,7 +17636,7 @@
           <p:cNvPr id="3" name="">
             <a:extLst xmlns:a="http://schemas.openxmlformats.org/drawingml/2006/main">
               <a:ext uri="{FF2B5EF4-FFF2-40B4-BE49-F238E27FC236}">
-                <a16:creationId xmlns:a16="http://schemas.microsoft.com/office/drawing/2014/main" id="{DE71EB6E-DC0D-4F13-A00C-138DB38F2CC6}"/>
+                <a16:creationId xmlns:a16="http://schemas.microsoft.com/office/drawing/2014/main" id="{671BA6C0-E6CA-4AFF-9A44-AC0114018AA2}"/>
               </a:ext>
             </a:extLst>
           </p:cNvPr>
@@ -16621,7 +17686,7 @@
           <p:cNvPr id="4" name="">
             <a:extLst xmlns:a="http://schemas.openxmlformats.org/drawingml/2006/main">
               <a:ext uri="{FF2B5EF4-FFF2-40B4-BE49-F238E27FC236}">
-                <a16:creationId xmlns:a16="http://schemas.microsoft.com/office/drawing/2014/main" id="{18B718BE-6772-4BBF-A930-1E091D7CF294}"/>
+                <a16:creationId xmlns:a16="http://schemas.microsoft.com/office/drawing/2014/main" id="{6245E308-CE99-4A6E-B95C-469B4832C0EB}"/>
               </a:ext>
             </a:extLst>
           </p:cNvPr>
@@ -16671,7 +17736,7 @@
           <p:cNvPr id="5" name="">
             <a:extLst xmlns:a="http://schemas.openxmlformats.org/drawingml/2006/main">
               <a:ext uri="{FF2B5EF4-FFF2-40B4-BE49-F238E27FC236}">
-                <a16:creationId xmlns:a16="http://schemas.microsoft.com/office/drawing/2014/main" id="{B36B08B0-3103-47B4-BEB6-B7219304689F}"/>
+                <a16:creationId xmlns:a16="http://schemas.microsoft.com/office/drawing/2014/main" id="{32AEB507-4C23-4A28-95D1-DFF7F8D9D32F}"/>
               </a:ext>
             </a:extLst>
           </p:cNvPr>
@@ -16721,7 +17786,7 @@
           <p:cNvPr id="6" name="">
             <a:extLst xmlns:a="http://schemas.openxmlformats.org/drawingml/2006/main">
               <a:ext uri="{FF2B5EF4-FFF2-40B4-BE49-F238E27FC236}">
-                <a16:creationId xmlns:a16="http://schemas.microsoft.com/office/drawing/2014/main" id="{CCEACED8-A018-4BA3-8E1F-23B2584FBCE5}"/>
+                <a16:creationId xmlns:a16="http://schemas.microsoft.com/office/drawing/2014/main" id="{7BF33BDA-4DE2-4542-8C4B-29A98FDC20CF}"/>
               </a:ext>
             </a:extLst>
           </p:cNvPr>
@@ -16771,7 +17836,7 @@
           <p:cNvPr id="7" name="">
             <a:extLst xmlns:a="http://schemas.openxmlformats.org/drawingml/2006/main">
               <a:ext uri="{FF2B5EF4-FFF2-40B4-BE49-F238E27FC236}">
-                <a16:creationId xmlns:a16="http://schemas.microsoft.com/office/drawing/2014/main" id="{4068C16B-104C-4F3D-A2D0-3AB001BF5888}"/>
+                <a16:creationId xmlns:a16="http://schemas.microsoft.com/office/drawing/2014/main" id="{FE5CC460-97F5-4B91-8F97-F4AEEF1BF9AB}"/>
               </a:ext>
             </a:extLst>
           </p:cNvPr>
@@ -16821,7 +17886,7 @@
           <p:cNvPr id="8" name="">
             <a:extLst xmlns:a="http://schemas.openxmlformats.org/drawingml/2006/main">
               <a:ext uri="{FF2B5EF4-FFF2-40B4-BE49-F238E27FC236}">
-                <a16:creationId xmlns:a16="http://schemas.microsoft.com/office/drawing/2014/main" id="{0CFA80F5-52F3-482B-9D8A-53186D707F46}"/>
+                <a16:creationId xmlns:a16="http://schemas.microsoft.com/office/drawing/2014/main" id="{6B413D79-6ACF-4559-BD9A-7DEABA08EDFE}"/>
               </a:ext>
             </a:extLst>
           </p:cNvPr>
@@ -16871,7 +17936,7 @@
           <p:cNvPr id="9" name="">
             <a:extLst xmlns:a="http://schemas.openxmlformats.org/drawingml/2006/main">
               <a:ext uri="{FF2B5EF4-FFF2-40B4-BE49-F238E27FC236}">
-                <a16:creationId xmlns:a16="http://schemas.microsoft.com/office/drawing/2014/main" id="{7913F4C8-6B17-4C51-A865-034EAA9B733D}"/>
+                <a16:creationId xmlns:a16="http://schemas.microsoft.com/office/drawing/2014/main" id="{CDC57E7E-62AE-4A69-9B10-5BA1C01F6F9D}"/>
               </a:ext>
             </a:extLst>
           </p:cNvPr>
@@ -16921,7 +17986,7 @@
           <p:cNvPr id="10" name="">
             <a:extLst xmlns:a="http://schemas.openxmlformats.org/drawingml/2006/main">
               <a:ext uri="{FF2B5EF4-FFF2-40B4-BE49-F238E27FC236}">
-                <a16:creationId xmlns:a16="http://schemas.microsoft.com/office/drawing/2014/main" id="{5B411C49-36AB-4141-8E5F-CEE582611599}"/>
+                <a16:creationId xmlns:a16="http://schemas.microsoft.com/office/drawing/2014/main" id="{8F165B05-203F-48E7-967D-B69D91C0DE3B}"/>
               </a:ext>
             </a:extLst>
           </p:cNvPr>
@@ -16971,7 +18036,7 @@
           <p:cNvPr id="11" name="">
             <a:extLst xmlns:a="http://schemas.openxmlformats.org/drawingml/2006/main">
               <a:ext uri="{FF2B5EF4-FFF2-40B4-BE49-F238E27FC236}">
-                <a16:creationId xmlns:a16="http://schemas.microsoft.com/office/drawing/2014/main" id="{E03624E7-E6F4-49AB-9BE4-7BB77B67112F}"/>
+                <a16:creationId xmlns:a16="http://schemas.microsoft.com/office/drawing/2014/main" id="{46837C66-76A9-4FC8-A342-95C0B4FF20A2}"/>
               </a:ext>
             </a:extLst>
           </p:cNvPr>
@@ -17021,7 +18086,7 @@
           <p:cNvPr id="12" name="">
             <a:extLst xmlns:a="http://schemas.openxmlformats.org/drawingml/2006/main">
               <a:ext uri="{FF2B5EF4-FFF2-40B4-BE49-F238E27FC236}">
-                <a16:creationId xmlns:a16="http://schemas.microsoft.com/office/drawing/2014/main" id="{2158BBD2-B2E3-4136-ADEF-367D62D213F6}"/>
+                <a16:creationId xmlns:a16="http://schemas.microsoft.com/office/drawing/2014/main" id="{4BA715FE-4A1D-458E-93FB-B89FF19180CB}"/>
               </a:ext>
             </a:extLst>
           </p:cNvPr>
@@ -17071,7 +18136,7 @@
           <p:cNvPr id="13" name="">
             <a:extLst xmlns:a="http://schemas.openxmlformats.org/drawingml/2006/main">
               <a:ext uri="{FF2B5EF4-FFF2-40B4-BE49-F238E27FC236}">
-                <a16:creationId xmlns:a16="http://schemas.microsoft.com/office/drawing/2014/main" id="{13A8240C-B5D9-403F-8ADE-0EC08F07E481}"/>
+                <a16:creationId xmlns:a16="http://schemas.microsoft.com/office/drawing/2014/main" id="{8A7C5875-D1DA-46E2-BCA0-013A78E9D493}"/>
               </a:ext>
             </a:extLst>
           </p:cNvPr>
@@ -17119,7 +18184,7 @@
     </p:spTree>
     <p:extLst>
       <p:ext uri="{BB962C8B-B14F-4D97-AF65-F5344CB8AC3E}">
-        <p14:creationId xmlns:p14="http://schemas.microsoft.com/office/powerpoint/2010/main" val="1724750265"/>
+        <p14:creationId xmlns:p14="http://schemas.microsoft.com/office/powerpoint/2010/main" val="23765288"/>
       </p:ext>
     </p:extLst>
   </p:cSld>
@@ -17150,7 +18215,7 @@
           <p:cNvPr id="21" name="">
             <a:extLst xmlns:a="http://schemas.openxmlformats.org/drawingml/2006/main">
               <a:ext uri="{FF2B5EF4-FFF2-40B4-BE49-F238E27FC236}">
-                <a16:creationId xmlns:a16="http://schemas.microsoft.com/office/drawing/2014/main" id="{31EF0C23-84EF-4690-87C1-79CF6E28555D}"/>
+                <a16:creationId xmlns:a16="http://schemas.microsoft.com/office/drawing/2014/main" id="{F6FE3393-D65F-47F6-9E53-8D27A19304D1}"/>
               </a:ext>
             </a:extLst>
           </p:cNvPr>
@@ -17200,7 +18265,7 @@
           <p:cNvPr id="2" name="">
             <a:extLst xmlns:a="http://schemas.openxmlformats.org/drawingml/2006/main">
               <a:ext uri="{FF2B5EF4-FFF2-40B4-BE49-F238E27FC236}">
-                <a16:creationId xmlns:a16="http://schemas.microsoft.com/office/drawing/2014/main" id="{AEEA466F-5846-434F-BB36-20AF2E5F6B78}"/>
+                <a16:creationId xmlns:a16="http://schemas.microsoft.com/office/drawing/2014/main" id="{6C1EDCAC-90DC-4524-88B4-5B3CB56AD494}"/>
               </a:ext>
             </a:extLst>
           </p:cNvPr>
@@ -17250,7 +18315,7 @@
           <p:cNvPr id="3" name="">
             <a:extLst xmlns:a="http://schemas.openxmlformats.org/drawingml/2006/main">
               <a:ext uri="{FF2B5EF4-FFF2-40B4-BE49-F238E27FC236}">
-                <a16:creationId xmlns:a16="http://schemas.microsoft.com/office/drawing/2014/main" id="{3C37BA62-8242-4400-B986-3917C1833F9A}"/>
+                <a16:creationId xmlns:a16="http://schemas.microsoft.com/office/drawing/2014/main" id="{05018C1D-31CA-45C8-88D5-86C0B0E78A36}"/>
               </a:ext>
             </a:extLst>
           </p:cNvPr>
@@ -17283,7 +18348,7 @@
           <p:cNvPr id="4" name="">
             <a:extLst xmlns:a="http://schemas.openxmlformats.org/drawingml/2006/main">
               <a:ext uri="{FF2B5EF4-FFF2-40B4-BE49-F238E27FC236}">
-                <a16:creationId xmlns:a16="http://schemas.microsoft.com/office/drawing/2014/main" id="{0BE61892-5175-44A0-8EAA-BA73D05ABBD5}"/>
+                <a16:creationId xmlns:a16="http://schemas.microsoft.com/office/drawing/2014/main" id="{8F892D5C-8B9C-4BB4-9679-C2BB9EF7E7CA}"/>
               </a:ext>
             </a:extLst>
           </p:cNvPr>
@@ -17333,7 +18398,7 @@
           <p:cNvPr id="5" name="">
             <a:extLst xmlns:a="http://schemas.openxmlformats.org/drawingml/2006/main">
               <a:ext uri="{FF2B5EF4-FFF2-40B4-BE49-F238E27FC236}">
-                <a16:creationId xmlns:a16="http://schemas.microsoft.com/office/drawing/2014/main" id="{49C6C71D-4471-4A56-BFFA-B47C396A28FC}"/>
+                <a16:creationId xmlns:a16="http://schemas.microsoft.com/office/drawing/2014/main" id="{81041BC4-0B39-49C7-A1FB-56546A027BCB}"/>
               </a:ext>
             </a:extLst>
           </p:cNvPr>
@@ -17383,7 +18448,7 @@
           <p:cNvPr id="6" name="">
             <a:extLst xmlns:a="http://schemas.openxmlformats.org/drawingml/2006/main">
               <a:ext uri="{FF2B5EF4-FFF2-40B4-BE49-F238E27FC236}">
-                <a16:creationId xmlns:a16="http://schemas.microsoft.com/office/drawing/2014/main" id="{30D4D0A7-5D73-49B1-A397-5BE1FB0C80F2}"/>
+                <a16:creationId xmlns:a16="http://schemas.microsoft.com/office/drawing/2014/main" id="{63C4ED88-71A3-4600-BC28-4C4CCB43F919}"/>
               </a:ext>
             </a:extLst>
           </p:cNvPr>
@@ -17416,7 +18481,7 @@
           <p:cNvPr id="7" name="">
             <a:extLst xmlns:a="http://schemas.openxmlformats.org/drawingml/2006/main">
               <a:ext uri="{FF2B5EF4-FFF2-40B4-BE49-F238E27FC236}">
-                <a16:creationId xmlns:a16="http://schemas.microsoft.com/office/drawing/2014/main" id="{98758C63-31C1-4485-8A3B-013C928B0060}"/>
+                <a16:creationId xmlns:a16="http://schemas.microsoft.com/office/drawing/2014/main" id="{96B2CF3F-8EB1-4A68-9810-0016BF644010}"/>
               </a:ext>
             </a:extLst>
           </p:cNvPr>
@@ -17466,7 +18531,7 @@
           <p:cNvPr id="8" name="">
             <a:extLst xmlns:a="http://schemas.openxmlformats.org/drawingml/2006/main">
               <a:ext uri="{FF2B5EF4-FFF2-40B4-BE49-F238E27FC236}">
-                <a16:creationId xmlns:a16="http://schemas.microsoft.com/office/drawing/2014/main" id="{4175E79B-6CA6-434A-89F3-0627275DFBE6}"/>
+                <a16:creationId xmlns:a16="http://schemas.microsoft.com/office/drawing/2014/main" id="{B57AB3B6-1852-490E-AFBA-514A6E944E6F}"/>
               </a:ext>
             </a:extLst>
           </p:cNvPr>
@@ -17516,7 +18581,7 @@
           <p:cNvPr id="9" name="">
             <a:extLst xmlns:a="http://schemas.openxmlformats.org/drawingml/2006/main">
               <a:ext uri="{FF2B5EF4-FFF2-40B4-BE49-F238E27FC236}">
-                <a16:creationId xmlns:a16="http://schemas.microsoft.com/office/drawing/2014/main" id="{4592CB1A-C054-4B4F-BEFC-41A4743473B7}"/>
+                <a16:creationId xmlns:a16="http://schemas.microsoft.com/office/drawing/2014/main" id="{D9F92480-008C-4A26-ACB9-189207F46A96}"/>
               </a:ext>
             </a:extLst>
           </p:cNvPr>
@@ -17549,7 +18614,7 @@
           <p:cNvPr id="10" name="">
             <a:extLst xmlns:a="http://schemas.openxmlformats.org/drawingml/2006/main">
               <a:ext uri="{FF2B5EF4-FFF2-40B4-BE49-F238E27FC236}">
-                <a16:creationId xmlns:a16="http://schemas.microsoft.com/office/drawing/2014/main" id="{DFD28BFF-8155-472A-9CE1-BFA8D47C3520}"/>
+                <a16:creationId xmlns:a16="http://schemas.microsoft.com/office/drawing/2014/main" id="{34E8DDE8-4604-4548-926B-690491E3F9BE}"/>
               </a:ext>
             </a:extLst>
           </p:cNvPr>
@@ -17599,7 +18664,7 @@
           <p:cNvPr id="11" name="">
             <a:extLst xmlns:a="http://schemas.openxmlformats.org/drawingml/2006/main">
               <a:ext uri="{FF2B5EF4-FFF2-40B4-BE49-F238E27FC236}">
-                <a16:creationId xmlns:a16="http://schemas.microsoft.com/office/drawing/2014/main" id="{FF15442B-E3A4-42CD-9BF5-30A6213FE691}"/>
+                <a16:creationId xmlns:a16="http://schemas.microsoft.com/office/drawing/2014/main" id="{D36B953B-4BED-4FAB-B7B9-764DD573D3B4}"/>
               </a:ext>
             </a:extLst>
           </p:cNvPr>
@@ -17649,7 +18714,7 @@
           <p:cNvPr id="12" name="">
             <a:extLst xmlns:a="http://schemas.openxmlformats.org/drawingml/2006/main">
               <a:ext uri="{FF2B5EF4-FFF2-40B4-BE49-F238E27FC236}">
-                <a16:creationId xmlns:a16="http://schemas.microsoft.com/office/drawing/2014/main" id="{FEE0DFB7-DE26-4D10-8C5E-4EBC5DE61EFA}"/>
+                <a16:creationId xmlns:a16="http://schemas.microsoft.com/office/drawing/2014/main" id="{4C7D604F-BAB5-4C87-ABC5-A429C3F8093F}"/>
               </a:ext>
             </a:extLst>
           </p:cNvPr>
@@ -17682,7 +18747,7 @@
           <p:cNvPr id="13" name="">
             <a:extLst xmlns:a="http://schemas.openxmlformats.org/drawingml/2006/main">
               <a:ext uri="{FF2B5EF4-FFF2-40B4-BE49-F238E27FC236}">
-                <a16:creationId xmlns:a16="http://schemas.microsoft.com/office/drawing/2014/main" id="{1264AD8D-449E-4584-B17B-630D068242EF}"/>
+                <a16:creationId xmlns:a16="http://schemas.microsoft.com/office/drawing/2014/main" id="{E59FFAF9-8384-460E-9AF5-A11E358325E7}"/>
               </a:ext>
             </a:extLst>
           </p:cNvPr>
@@ -17732,7 +18797,7 @@
           <p:cNvPr id="14" name="">
             <a:extLst xmlns:a="http://schemas.openxmlformats.org/drawingml/2006/main">
               <a:ext uri="{FF2B5EF4-FFF2-40B4-BE49-F238E27FC236}">
-                <a16:creationId xmlns:a16="http://schemas.microsoft.com/office/drawing/2014/main" id="{BB453BF5-F259-44FB-BE1F-5E16CA4616FE}"/>
+                <a16:creationId xmlns:a16="http://schemas.microsoft.com/office/drawing/2014/main" id="{97652872-D347-42C4-B83B-3078C776EDAE}"/>
               </a:ext>
             </a:extLst>
           </p:cNvPr>
@@ -17782,7 +18847,7 @@
           <p:cNvPr id="15" name="">
             <a:extLst xmlns:a="http://schemas.openxmlformats.org/drawingml/2006/main">
               <a:ext uri="{FF2B5EF4-FFF2-40B4-BE49-F238E27FC236}">
-                <a16:creationId xmlns:a16="http://schemas.microsoft.com/office/drawing/2014/main" id="{3DDD2974-8E2C-47D3-87CE-00DEC22CCB04}"/>
+                <a16:creationId xmlns:a16="http://schemas.microsoft.com/office/drawing/2014/main" id="{19393B23-7499-4FD1-A9D4-1EBD2ADA262B}"/>
               </a:ext>
             </a:extLst>
           </p:cNvPr>
@@ -17815,7 +18880,7 @@
           <p:cNvPr id="16" name="">
             <a:extLst xmlns:a="http://schemas.openxmlformats.org/drawingml/2006/main">
               <a:ext uri="{FF2B5EF4-FFF2-40B4-BE49-F238E27FC236}">
-                <a16:creationId xmlns:a16="http://schemas.microsoft.com/office/drawing/2014/main" id="{089E41B6-B78F-49B1-B677-E958BE725EE8}"/>
+                <a16:creationId xmlns:a16="http://schemas.microsoft.com/office/drawing/2014/main" id="{2800F652-1648-4FE4-93A3-0AD25F682458}"/>
               </a:ext>
             </a:extLst>
           </p:cNvPr>
@@ -17865,7 +18930,7 @@
           <p:cNvPr id="17" name="">
             <a:extLst xmlns:a="http://schemas.openxmlformats.org/drawingml/2006/main">
               <a:ext uri="{FF2B5EF4-FFF2-40B4-BE49-F238E27FC236}">
-                <a16:creationId xmlns:a16="http://schemas.microsoft.com/office/drawing/2014/main" id="{2E8BBBE6-C523-42F2-8F99-875C029ECBDF}"/>
+                <a16:creationId xmlns:a16="http://schemas.microsoft.com/office/drawing/2014/main" id="{595725EA-F23A-45C8-BE48-50E5136EFB14}"/>
               </a:ext>
             </a:extLst>
           </p:cNvPr>
@@ -17915,7 +18980,7 @@
           <p:cNvPr id="18" name="">
             <a:extLst xmlns:a="http://schemas.openxmlformats.org/drawingml/2006/main">
               <a:ext uri="{FF2B5EF4-FFF2-40B4-BE49-F238E27FC236}">
-                <a16:creationId xmlns:a16="http://schemas.microsoft.com/office/drawing/2014/main" id="{D0020D21-D199-4775-BBB1-6B68E7EC744F}"/>
+                <a16:creationId xmlns:a16="http://schemas.microsoft.com/office/drawing/2014/main" id="{245DB373-6347-4E5A-AFAA-F6B4030941D5}"/>
               </a:ext>
             </a:extLst>
           </p:cNvPr>
@@ -17965,7 +19030,7 @@
           <p:cNvPr id="19" name="">
             <a:extLst xmlns:a="http://schemas.openxmlformats.org/drawingml/2006/main">
               <a:ext uri="{FF2B5EF4-FFF2-40B4-BE49-F238E27FC236}">
-                <a16:creationId xmlns:a16="http://schemas.microsoft.com/office/drawing/2014/main" id="{0AF3930A-034D-4A67-9407-0F053CFD6194}"/>
+                <a16:creationId xmlns:a16="http://schemas.microsoft.com/office/drawing/2014/main" id="{35F246F9-8C94-423F-A6E2-2B1DBF22D552}"/>
               </a:ext>
             </a:extLst>
           </p:cNvPr>
@@ -18015,7 +19080,7 @@
           <p:cNvPr id="20" name="">
             <a:extLst xmlns:a="http://schemas.openxmlformats.org/drawingml/2006/main">
               <a:ext uri="{FF2B5EF4-FFF2-40B4-BE49-F238E27FC236}">
-                <a16:creationId xmlns:a16="http://schemas.microsoft.com/office/drawing/2014/main" id="{D46DD2D2-D988-4743-B6DF-D0DABC799B4C}"/>
+                <a16:creationId xmlns:a16="http://schemas.microsoft.com/office/drawing/2014/main" id="{65C42736-BC35-4139-9653-D33E1D9D4926}"/>
               </a:ext>
             </a:extLst>
           </p:cNvPr>
@@ -18063,7 +19128,7 @@
     </p:spTree>
     <p:extLst>
       <p:ext uri="{BB962C8B-B14F-4D97-AF65-F5344CB8AC3E}">
-        <p14:creationId xmlns:p14="http://schemas.microsoft.com/office/powerpoint/2010/main" val="894416105"/>
+        <p14:creationId xmlns:p14="http://schemas.microsoft.com/office/powerpoint/2010/main" val="1503464517"/>
       </p:ext>
     </p:extLst>
   </p:cSld>

</xml_diff>